<commit_message>
deck corso: piu' aria ai titoli Playfair per Canva
Co-Authored-By: Claude Fable 5.1 <noreply@anthropic.com>

Antigravity-Session-ID: 0987b7a5-5ad3-4a1c-a0b9-eafe66b303f5
Antigravity-Session-Path: C:\Users\marco\.gemini\antigravity\brain\0987b7a5-5ad3-4a1c-a0b9-eafe66b303f5
</commit_message>
<xml_diff>
--- a/grav-site/root/kit-corso/corso-base-hd.pptx
+++ b/grav-site/root/kit-corso/corso-base-hd.pptx
@@ -3221,7 +3221,7 @@
         <p:spPr>
           <a:xfrm>
             <a:off x="596899" y="2045290"/>
-            <a:ext cx="6381591" cy="2463397"/>
+            <a:ext cx="6942305" cy="2463397"/>
           </a:xfrm>
           <a:prstGeom prst="rect">
             <a:avLst/>
@@ -3530,7 +3530,7 @@
         <p:spPr>
           <a:xfrm>
             <a:off x="596899" y="647698"/>
-            <a:ext cx="6512274" cy="577849"/>
+            <a:ext cx="7084655" cy="577849"/>
           </a:xfrm>
           <a:prstGeom prst="rect">
             <a:avLst/>
@@ -3901,7 +3901,7 @@
         <p:spPr>
           <a:xfrm>
             <a:off x="596899" y="647698"/>
-            <a:ext cx="3770271" cy="577849"/>
+            <a:ext cx="4097831" cy="577849"/>
           </a:xfrm>
           <a:prstGeom prst="rect">
             <a:avLst/>
@@ -3979,7 +3979,7 @@
         <p:spPr>
           <a:xfrm>
             <a:off x="596899" y="4228296"/>
-            <a:ext cx="5440143" cy="748008"/>
+            <a:ext cx="5916798" cy="748008"/>
           </a:xfrm>
           <a:prstGeom prst="rect">
             <a:avLst/>
@@ -4577,7 +4577,7 @@
         <p:spPr>
           <a:xfrm>
             <a:off x="596899" y="647698"/>
-            <a:ext cx="5607385" cy="577849"/>
+            <a:ext cx="6098973" cy="577849"/>
           </a:xfrm>
           <a:prstGeom prst="rect">
             <a:avLst/>
@@ -5227,7 +5227,7 @@
         <p:spPr>
           <a:xfrm>
             <a:off x="596899" y="647698"/>
-            <a:ext cx="3083409" cy="577849"/>
+            <a:ext cx="3349642" cy="577849"/>
           </a:xfrm>
           <a:prstGeom prst="rect">
             <a:avLst/>
@@ -5304,8 +5304,8 @@
         </p:nvSpPr>
         <p:spPr>
           <a:xfrm>
-            <a:off x="4749010" y="1855584"/>
-            <a:ext cx="369077" cy="615948"/>
+            <a:off x="4725128" y="1855584"/>
+            <a:ext cx="392959" cy="615948"/>
           </a:xfrm>
           <a:prstGeom prst="rect">
             <a:avLst/>
@@ -5398,8 +5398,8 @@
         </p:nvSpPr>
         <p:spPr>
           <a:xfrm>
-            <a:off x="4761123" y="2632763"/>
-            <a:ext cx="356964" cy="615948"/>
+            <a:off x="4738322" y="2632763"/>
+            <a:ext cx="379765" cy="615948"/>
           </a:xfrm>
           <a:prstGeom prst="rect">
             <a:avLst/>
@@ -5492,8 +5492,8 @@
         </p:nvSpPr>
         <p:spPr>
           <a:xfrm>
-            <a:off x="4509092" y="3409941"/>
-            <a:ext cx="608995" cy="615948"/>
+            <a:off x="4463789" y="3409941"/>
+            <a:ext cx="654298" cy="615948"/>
           </a:xfrm>
           <a:prstGeom prst="rect">
             <a:avLst/>
@@ -5586,8 +5586,8 @@
         </p:nvSpPr>
         <p:spPr>
           <a:xfrm>
-            <a:off x="4489756" y="4187120"/>
-            <a:ext cx="628331" cy="615948"/>
+            <a:off x="4442727" y="4187120"/>
+            <a:ext cx="675360" cy="615948"/>
           </a:xfrm>
           <a:prstGeom prst="rect">
             <a:avLst/>
@@ -5680,8 +5680,8 @@
         </p:nvSpPr>
         <p:spPr>
           <a:xfrm>
-            <a:off x="4253727" y="4964299"/>
-            <a:ext cx="864360" cy="615948"/>
+            <a:off x="4185624" y="4964299"/>
+            <a:ext cx="932463" cy="615948"/>
           </a:xfrm>
           <a:prstGeom prst="rect">
             <a:avLst/>
@@ -6353,7 +6353,7 @@
         <p:spPr>
           <a:xfrm>
             <a:off x="596899" y="647698"/>
-            <a:ext cx="7581405" cy="577849"/>
+            <a:ext cx="8249245" cy="577849"/>
           </a:xfrm>
           <a:prstGeom prst="rect">
             <a:avLst/>
@@ -6997,7 +6997,7 @@
         <p:spPr>
           <a:xfrm>
             <a:off x="596899" y="647698"/>
-            <a:ext cx="6701519" cy="577849"/>
+            <a:ext cx="7290798" cy="577849"/>
           </a:xfrm>
           <a:prstGeom prst="rect">
             <a:avLst/>
@@ -7560,7 +7560,7 @@
         <p:spPr>
           <a:xfrm>
             <a:off x="596899" y="647698"/>
-            <a:ext cx="6791197" cy="577849"/>
+            <a:ext cx="7388482" cy="577849"/>
           </a:xfrm>
           <a:prstGeom prst="rect">
             <a:avLst/>
@@ -7637,8 +7637,8 @@
         </p:nvSpPr>
         <p:spPr>
           <a:xfrm>
-            <a:off x="3979841" y="3512732"/>
-            <a:ext cx="362965" cy="577849"/>
+            <a:off x="3968173" y="3512732"/>
+            <a:ext cx="386301" cy="577849"/>
           </a:xfrm>
           <a:prstGeom prst="rect">
             <a:avLst/>
@@ -7715,8 +7715,8 @@
         </p:nvSpPr>
         <p:spPr>
           <a:xfrm>
-            <a:off x="7835180" y="3512732"/>
-            <a:ext cx="390635" cy="577849"/>
+            <a:off x="7822277" y="3512732"/>
+            <a:ext cx="416442" cy="577849"/>
           </a:xfrm>
           <a:prstGeom prst="rect">
             <a:avLst/>
@@ -8009,7 +8009,7 @@
         <p:spPr>
           <a:xfrm>
             <a:off x="596899" y="647698"/>
-            <a:ext cx="4072975" cy="577849"/>
+            <a:ext cx="4427562" cy="577849"/>
           </a:xfrm>
           <a:prstGeom prst="rect">
             <a:avLst/>
@@ -8458,7 +8458,7 @@
         <p:spPr>
           <a:xfrm>
             <a:off x="596899" y="647698"/>
-            <a:ext cx="3672482" cy="577849"/>
+            <a:ext cx="3991310" cy="577849"/>
           </a:xfrm>
           <a:prstGeom prst="rect">
             <a:avLst/>
@@ -9315,7 +9315,7 @@
         <p:spPr>
           <a:xfrm>
             <a:off x="596899" y="647698"/>
-            <a:ext cx="6447599" cy="577849"/>
+            <a:ext cx="7014206" cy="577849"/>
           </a:xfrm>
           <a:prstGeom prst="rect">
             <a:avLst/>
@@ -10105,7 +10105,7 @@
         <p:spPr>
           <a:xfrm>
             <a:off x="596899" y="647698"/>
-            <a:ext cx="2975174" cy="577849"/>
+            <a:ext cx="3231743" cy="577849"/>
           </a:xfrm>
           <a:prstGeom prst="rect">
             <a:avLst/>
@@ -10562,7 +10562,7 @@
         <p:spPr>
           <a:xfrm>
             <a:off x="596899" y="647698"/>
-            <a:ext cx="5539933" cy="577849"/>
+            <a:ext cx="6025498" cy="577849"/>
           </a:xfrm>
           <a:prstGeom prst="rect">
             <a:avLst/>
@@ -10933,7 +10933,7 @@
         <p:spPr>
           <a:xfrm>
             <a:off x="596899" y="647698"/>
-            <a:ext cx="3555467" cy="577849"/>
+            <a:ext cx="3863848" cy="577849"/>
           </a:xfrm>
           <a:prstGeom prst="rect">
             <a:avLst/>
@@ -11665,7 +11665,7 @@
         <p:spPr>
           <a:xfrm>
             <a:off x="596899" y="622298"/>
-            <a:ext cx="1977830" cy="577849"/>
+            <a:ext cx="2145350" cy="577849"/>
           </a:xfrm>
           <a:prstGeom prst="rect">
             <a:avLst/>
@@ -11704,7 +11704,7 @@
         <p:spPr>
           <a:xfrm>
             <a:off x="2437203" y="622298"/>
-            <a:ext cx="275954" cy="577849"/>
+            <a:ext cx="291522" cy="577849"/>
           </a:xfrm>
           <a:prstGeom prst="rect">
             <a:avLst/>
@@ -12432,7 +12432,7 @@
         <p:spPr>
           <a:xfrm>
             <a:off x="596899" y="622298"/>
-            <a:ext cx="1977830" cy="577849"/>
+            <a:ext cx="2145350" cy="577849"/>
           </a:xfrm>
           <a:prstGeom prst="rect">
             <a:avLst/>
@@ -12471,7 +12471,7 @@
         <p:spPr>
           <a:xfrm>
             <a:off x="2437203" y="622298"/>
-            <a:ext cx="339740" cy="577849"/>
+            <a:ext cx="361003" cy="577849"/>
           </a:xfrm>
           <a:prstGeom prst="rect">
             <a:avLst/>
@@ -12847,7 +12847,7 @@
         <p:spPr>
           <a:xfrm>
             <a:off x="596899" y="4528630"/>
-            <a:ext cx="5024981" cy="748008"/>
+            <a:ext cx="5464568" cy="748008"/>
           </a:xfrm>
           <a:prstGeom prst="rect">
             <a:avLst/>
@@ -13164,7 +13164,7 @@
         <p:spPr>
           <a:xfrm>
             <a:off x="596899" y="622298"/>
-            <a:ext cx="1977830" cy="577849"/>
+            <a:ext cx="2145350" cy="577849"/>
           </a:xfrm>
           <a:prstGeom prst="rect">
             <a:avLst/>
@@ -13203,7 +13203,7 @@
         <p:spPr>
           <a:xfrm>
             <a:off x="2437203" y="622298"/>
-            <a:ext cx="323738" cy="577849"/>
+            <a:ext cx="343572" cy="577849"/>
           </a:xfrm>
           <a:prstGeom prst="rect">
             <a:avLst/>
@@ -13579,7 +13579,7 @@
         <p:spPr>
           <a:xfrm>
             <a:off x="596899" y="4528630"/>
-            <a:ext cx="5766294" cy="748008"/>
+            <a:ext cx="6272070" cy="748008"/>
           </a:xfrm>
           <a:prstGeom prst="rect">
             <a:avLst/>
@@ -13896,7 +13896,7 @@
         <p:spPr>
           <a:xfrm>
             <a:off x="596899" y="622298"/>
-            <a:ext cx="1977830" cy="577849"/>
+            <a:ext cx="2145350" cy="577849"/>
           </a:xfrm>
           <a:prstGeom prst="rect">
             <a:avLst/>
@@ -13935,7 +13935,7 @@
         <p:spPr>
           <a:xfrm>
             <a:off x="2437203" y="622298"/>
-            <a:ext cx="341963" cy="577849"/>
+            <a:ext cx="363423" cy="577849"/>
           </a:xfrm>
           <a:prstGeom prst="rect">
             <a:avLst/>
@@ -14311,7 +14311,7 @@
         <p:spPr>
           <a:xfrm>
             <a:off x="596899" y="4528630"/>
-            <a:ext cx="5901088" cy="748008"/>
+            <a:ext cx="6418899" cy="748008"/>
           </a:xfrm>
           <a:prstGeom prst="rect">
             <a:avLst/>
@@ -14623,7 +14623,7 @@
         <p:spPr>
           <a:xfrm>
             <a:off x="596899" y="2344732"/>
-            <a:ext cx="7315594" cy="1497009"/>
+            <a:ext cx="7959701" cy="1497009"/>
           </a:xfrm>
           <a:prstGeom prst="rect">
             <a:avLst/>
@@ -15080,7 +15080,7 @@
         <p:spPr>
           <a:xfrm>
             <a:off x="596899" y="647698"/>
-            <a:ext cx="5137661" cy="577849"/>
+            <a:ext cx="5587309" cy="577849"/>
           </a:xfrm>
           <a:prstGeom prst="rect">
             <a:avLst/>
@@ -15158,7 +15158,7 @@
         <p:spPr>
           <a:xfrm>
             <a:off x="596899" y="1640776"/>
-            <a:ext cx="955038" cy="393699"/>
+            <a:ext cx="1031237" cy="393699"/>
           </a:xfrm>
           <a:prstGeom prst="rect">
             <a:avLst/>
@@ -15232,7 +15232,7 @@
         <p:spPr>
           <a:xfrm>
             <a:off x="3403591" y="1640776"/>
-            <a:ext cx="955038" cy="393699"/>
+            <a:ext cx="1031237" cy="393699"/>
           </a:xfrm>
           <a:prstGeom prst="rect">
             <a:avLst/>
@@ -15306,7 +15306,7 @@
         <p:spPr>
           <a:xfrm>
             <a:off x="6210284" y="1640776"/>
-            <a:ext cx="955038" cy="393699"/>
+            <a:ext cx="1031237" cy="393699"/>
           </a:xfrm>
           <a:prstGeom prst="rect">
             <a:avLst/>
@@ -15380,7 +15380,7 @@
         <p:spPr>
           <a:xfrm>
             <a:off x="9016977" y="1640776"/>
-            <a:ext cx="955038" cy="393699"/>
+            <a:ext cx="1031237" cy="393699"/>
           </a:xfrm>
           <a:prstGeom prst="rect">
             <a:avLst/>
@@ -15454,7 +15454,7 @@
         <p:spPr>
           <a:xfrm>
             <a:off x="596899" y="5542346"/>
-            <a:ext cx="1218403" cy="546099"/>
+            <a:ext cx="1318118" cy="546099"/>
           </a:xfrm>
           <a:prstGeom prst="rect">
             <a:avLst/>
@@ -15532,7 +15532,7 @@
         <p:spPr>
           <a:xfrm>
             <a:off x="2599029" y="5542346"/>
-            <a:ext cx="1525996" cy="546099"/>
+            <a:ext cx="1653175" cy="546099"/>
           </a:xfrm>
           <a:prstGeom prst="rect">
             <a:avLst/>
@@ -15849,7 +15849,7 @@
         <p:spPr>
           <a:xfrm>
             <a:off x="596899" y="647698"/>
-            <a:ext cx="6340142" cy="577849"/>
+            <a:ext cx="6897154" cy="577849"/>
           </a:xfrm>
           <a:prstGeom prst="rect">
             <a:avLst/>
@@ -16195,8 +16195,8 @@
         </p:nvSpPr>
         <p:spPr>
           <a:xfrm>
-            <a:off x="2207610" y="2997193"/>
-            <a:ext cx="7776651" cy="1054097"/>
+            <a:off x="1864973" y="2997193"/>
+            <a:ext cx="8461923" cy="1054097"/>
           </a:xfrm>
           <a:prstGeom prst="rect">
             <a:avLst/>
@@ -16450,7 +16450,7 @@
         <p:spPr>
           <a:xfrm>
             <a:off x="596899" y="1474089"/>
-            <a:ext cx="4397570" cy="749298"/>
+            <a:ext cx="4781139" cy="749298"/>
           </a:xfrm>
           <a:prstGeom prst="rect">
             <a:avLst/>
@@ -16622,7 +16622,7 @@
         <p:spPr>
           <a:xfrm>
             <a:off x="596899" y="4554725"/>
-            <a:ext cx="5855749" cy="891379"/>
+            <a:ext cx="6369512" cy="891379"/>
           </a:xfrm>
           <a:prstGeom prst="rect">
             <a:avLst/>
@@ -16812,8 +16812,8 @@
         </p:nvSpPr>
         <p:spPr>
           <a:xfrm>
-            <a:off x="8960463" y="2286490"/>
-            <a:ext cx="2621908" cy="1054097"/>
+            <a:off x="8735435" y="2286490"/>
+            <a:ext cx="2846936" cy="1054097"/>
           </a:xfrm>
           <a:prstGeom prst="rect">
             <a:avLst/>
@@ -16851,8 +16851,8 @@
         </p:nvSpPr>
         <p:spPr>
           <a:xfrm>
-            <a:off x="7927336" y="3429488"/>
-            <a:ext cx="3655035" cy="419099"/>
+            <a:off x="7610065" y="3429488"/>
+            <a:ext cx="3972306" cy="419099"/>
           </a:xfrm>
           <a:prstGeom prst="rect">
             <a:avLst/>
@@ -17164,7 +17164,7 @@
         <p:spPr>
           <a:xfrm>
             <a:off x="596899" y="2252458"/>
-            <a:ext cx="7297148" cy="2216343"/>
+            <a:ext cx="7939607" cy="2216343"/>
           </a:xfrm>
           <a:prstGeom prst="rect">
             <a:avLst/>
@@ -17719,7 +17719,7 @@
         <p:spPr>
           <a:xfrm>
             <a:off x="596899" y="647698"/>
-            <a:ext cx="4454911" cy="577849"/>
+            <a:ext cx="4843599" cy="577849"/>
           </a:xfrm>
           <a:prstGeom prst="rect">
             <a:avLst/>
@@ -18549,7 +18549,7 @@
         <p:spPr>
           <a:xfrm>
             <a:off x="596899" y="1771447"/>
-            <a:ext cx="10400417" cy="2231623"/>
+            <a:ext cx="11319954" cy="2231623"/>
           </a:xfrm>
           <a:prstGeom prst="rect">
             <a:avLst/>
@@ -18900,7 +18900,7 @@
         <p:spPr>
           <a:xfrm>
             <a:off x="596899" y="647698"/>
-            <a:ext cx="9765339" cy="577849"/>
+            <a:ext cx="10628173" cy="577849"/>
           </a:xfrm>
           <a:prstGeom prst="rect">
             <a:avLst/>
@@ -19095,7 +19095,7 @@
         <p:spPr>
           <a:xfrm>
             <a:off x="596899" y="5942395"/>
-            <a:ext cx="2664803" cy="342899"/>
+            <a:ext cx="2893660" cy="342899"/>
           </a:xfrm>
           <a:prstGeom prst="rect">
             <a:avLst/>
@@ -20018,7 +20018,7 @@
         <p:spPr>
           <a:xfrm>
             <a:off x="596899" y="647698"/>
-            <a:ext cx="4572258" cy="577849"/>
+            <a:ext cx="4971424" cy="577849"/>
           </a:xfrm>
           <a:prstGeom prst="rect">
             <a:avLst/>
@@ -21259,7 +21259,7 @@
         <p:spPr>
           <a:xfrm>
             <a:off x="596899" y="647698"/>
-            <a:ext cx="10920925" cy="577849"/>
+            <a:ext cx="11886936" cy="577849"/>
           </a:xfrm>
           <a:prstGeom prst="rect">
             <a:avLst/>

</xml_diff>

<commit_message>
deck corso: ogni pezzo di testo col suo stile (small, span colorati)
Co-Authored-By: Claude Fable 5.1 <noreply@anthropic.com>

Antigravity-Session-ID: 0987b7a5-5ad3-4a1c-a0b9-eafe66b303f5
Antigravity-Session-Path: C:\Users\marco\.gemini\antigravity\brain\0987b7a5-5ad3-4a1c-a0b9-eafe66b303f5
</commit_message>
<xml_diff>
--- a/grav-site/root/kit-corso/corso-base-hd.pptx
+++ b/grav-site/root/kit-corso/corso-base-hd.pptx
@@ -3262,7 +3262,7 @@
                 </a:solidFill>
                 <a:latin typeface="Playfair Display"/>
               </a:rPr>
-              <a:t>di Human Design</a:t>
+              <a:t>di Human Design</a:t>
             </a:r>
           </a:p>
         </p:txBody>
@@ -5379,9 +5379,9 @@
               </a:lnSpc>
             </a:pPr>
             <a:r>
-              <a:rPr sz="1400" b="0" i="0">
-                <a:solidFill>
-                  <a:srgbClr val="3A3532"/>
+              <a:rPr sz="1000" b="0" i="0">
+                <a:solidFill>
+                  <a:srgbClr val="6B625D"/>
                 </a:solidFill>
                 <a:latin typeface="Outfit"/>
               </a:rPr>
@@ -5473,9 +5473,9 @@
               </a:lnSpc>
             </a:pPr>
             <a:r>
-              <a:rPr sz="1400" b="0" i="0">
-                <a:solidFill>
-                  <a:srgbClr val="3A3532"/>
+              <a:rPr sz="1000" b="0" i="0">
+                <a:solidFill>
+                  <a:srgbClr val="6B625D"/>
                 </a:solidFill>
                 <a:latin typeface="Outfit"/>
               </a:rPr>
@@ -5567,9 +5567,9 @@
               </a:lnSpc>
             </a:pPr>
             <a:r>
-              <a:rPr sz="1400" b="0" i="0">
-                <a:solidFill>
-                  <a:srgbClr val="3A3532"/>
+              <a:rPr sz="1000" b="0" i="0">
+                <a:solidFill>
+                  <a:srgbClr val="6B625D"/>
                 </a:solidFill>
                 <a:latin typeface="Outfit"/>
               </a:rPr>
@@ -5661,9 +5661,9 @@
               </a:lnSpc>
             </a:pPr>
             <a:r>
-              <a:rPr sz="1400" b="0" i="0">
-                <a:solidFill>
-                  <a:srgbClr val="3A3532"/>
+              <a:rPr sz="1000" b="0" i="0">
+                <a:solidFill>
+                  <a:srgbClr val="6B625D"/>
                 </a:solidFill>
                 <a:latin typeface="Outfit"/>
               </a:rPr>
@@ -5755,9 +5755,9 @@
               </a:lnSpc>
             </a:pPr>
             <a:r>
-              <a:rPr sz="1400" b="0" i="0">
-                <a:solidFill>
-                  <a:srgbClr val="3A3532"/>
+              <a:rPr sz="1000" b="0" i="0">
+                <a:solidFill>
+                  <a:srgbClr val="6B625D"/>
                 </a:solidFill>
                 <a:latin typeface="Outfit"/>
               </a:rPr>
@@ -7618,13 +7618,22 @@
               </a:lnSpc>
             </a:pPr>
             <a:r>
+              <a:rPr sz="1000" b="1" i="0">
+                <a:solidFill>
+                  <a:srgbClr val="C0392B"/>
+                </a:solidFill>
+                <a:latin typeface="Outfit"/>
+              </a:rPr>
+              <a:t>13 porte</a:t>
+            </a:r>
+            <a:r>
               <a:rPr sz="1000" b="0" i="0">
                 <a:solidFill>
                   <a:srgbClr val="6B625D"/>
                 </a:solidFill>
                 <a:latin typeface="Outfit"/>
               </a:rPr>
-              <a:t>13 porte · Mappa genetica inconscia</a:t>
+              <a:t>· Mappa genetica inconscia</a:t>
             </a:r>
           </a:p>
         </p:txBody>
@@ -7696,13 +7705,22 @@
               </a:lnSpc>
             </a:pPr>
             <a:r>
+              <a:rPr sz="1000" b="1" i="0">
+                <a:solidFill>
+                  <a:srgbClr val="1A1A2E"/>
+                </a:solidFill>
+                <a:latin typeface="Outfit"/>
+              </a:rPr>
+              <a:t>13 porte</a:t>
+            </a:r>
+            <a:r>
               <a:rPr sz="1000" b="0" i="0">
                 <a:solidFill>
                   <a:srgbClr val="6B625D"/>
                 </a:solidFill>
                 <a:latin typeface="Outfit"/>
               </a:rPr>
-              <a:t>13 porte · Mappa della personalità conscia</a:t>
+              <a:t>· Mappa della personalità conscia</a:t>
             </a:r>
           </a:p>
         </p:txBody>
@@ -7774,13 +7792,22 @@
               </a:lnSpc>
             </a:pPr>
             <a:r>
+              <a:rPr sz="1000" b="1" i="0">
+                <a:solidFill>
+                  <a:srgbClr val="6B625D"/>
+                </a:solidFill>
+                <a:latin typeface="Outfit"/>
+              </a:rPr>
+              <a:t>26 porte</a:t>
+            </a:r>
+            <a:r>
               <a:rPr sz="1000" b="0" i="0">
                 <a:solidFill>
                   <a:srgbClr val="6B625D"/>
                 </a:solidFill>
                 <a:latin typeface="Outfit"/>
               </a:rPr>
-              <a:t>26 porte · Canali e centri definiti</a:t>
+              <a:t>· Canali e centri definiti</a:t>
             </a:r>
           </a:p>
         </p:txBody>
@@ -9391,7 +9418,7 @@
             <a:r>
               <a:rPr sz="1600" b="1" i="0">
                 <a:solidFill>
-                  <a:srgbClr val="6B625D"/>
+                  <a:srgbClr val="7A4F5E"/>
                 </a:solidFill>
                 <a:latin typeface="Outfit"/>
               </a:rPr>
@@ -9647,7 +9674,7 @@
             <a:r>
               <a:rPr sz="1600" b="1" i="0">
                 <a:solidFill>
-                  <a:srgbClr val="6B625D"/>
+                  <a:srgbClr val="7A4F5E"/>
                 </a:solidFill>
                 <a:latin typeface="Outfit"/>
               </a:rPr>
@@ -10247,7 +10274,16 @@
                 </a:solidFill>
                 <a:latin typeface="Outfit"/>
               </a:rPr>
-              <a:t>Se non ce l'hai, vai su valentinarussobg5.com/calcolo-human-design</a:t>
+              <a:t>Se non ce l'hai, vai su</a:t>
+            </a:r>
+            <a:r>
+              <a:rPr sz="1400" b="1" i="0">
+                <a:solidFill>
+                  <a:srgbClr val="7A4F5E"/>
+                </a:solidFill>
+                <a:latin typeface="Outfit"/>
+              </a:rPr>
+              <a:t>valentinarussobg5.com/calcolo-human-design</a:t>
             </a:r>
           </a:p>
         </p:txBody>
@@ -14114,7 +14150,25 @@
                 </a:solidFill>
                 <a:latin typeface="Outfit"/>
               </a:rPr>
-              <a:t>Guarda le porte che nel tuo Disegno non sono definite e colorale.</a:t>
+              <a:t>Guarda le porte che nel tuo Disegno</a:t>
+            </a:r>
+            <a:r>
+              <a:rPr sz="1400" b="0" i="0">
+                <a:solidFill>
+                  <a:srgbClr val="3A3532"/>
+                </a:solidFill>
+                <a:latin typeface="Outfit"/>
+              </a:rPr>
+              <a:t>non</a:t>
+            </a:r>
+            <a:r>
+              <a:rPr sz="1400" b="0" i="0">
+                <a:solidFill>
+                  <a:srgbClr val="3A3532"/>
+                </a:solidFill>
+                <a:latin typeface="Outfit"/>
+              </a:rPr>
+              <a:t>sono definite e colorale.</a:t>
             </a:r>
           </a:p>
         </p:txBody>
@@ -14664,7 +14718,7 @@
                 </a:solidFill>
                 <a:latin typeface="Playfair Display"/>
               </a:rPr>
-              <a:t>del valore di 210 €</a:t>
+              <a:t>del valore di 210 €</a:t>
             </a:r>
           </a:p>
         </p:txBody>

</xml_diff>

<commit_message>
deck corso: citazione in Playfair corsivo, spazi ai bordi dei run, caselle a capo
Co-Authored-By: Claude Fable 5.1 <noreply@anthropic.com>

Antigravity-Session-ID: 0987b7a5-5ad3-4a1c-a0b9-eafe66b303f5
Antigravity-Session-Path: C:\Users\marco\.gemini\antigravity\brain\0987b7a5-5ad3-4a1c-a0b9-eafe66b303f5
</commit_message>
<xml_diff>
--- a/grav-site/root/kit-corso/corso-base-hd.pptx
+++ b/grav-site/root/kit-corso/corso-base-hd.pptx
@@ -3190,7 +3190,7 @@
           <a:noFill/>
         </p:spPr>
         <p:txBody>
-          <a:bodyPr wrap="none" lIns="0" rIns="0" tIns="0" bIns="0" anchor="t">
+          <a:bodyPr wrap="square" lIns="0" rIns="0" tIns="0" bIns="0" anchor="t">
             <a:spAutoFit/>
           </a:bodyPr>
           <a:lstStyle/>
@@ -3229,7 +3229,7 @@
           <a:noFill/>
         </p:spPr>
         <p:txBody>
-          <a:bodyPr wrap="none" lIns="0" rIns="0" tIns="0" bIns="0" anchor="t">
+          <a:bodyPr wrap="square" lIns="0" rIns="0" tIns="0" bIns="0" anchor="t">
             <a:spAutoFit/>
           </a:bodyPr>
           <a:lstStyle/>
@@ -3246,7 +3246,7 @@
                 </a:solidFill>
                 <a:latin typeface="Playfair Display"/>
               </a:rPr>
-              <a:t>Benvenuti al</a:t>
+              <a:t> Benvenuti al </a:t>
             </a:r>
           </a:p>
           <a:p>
@@ -3278,7 +3278,7 @@
                 </a:solidFill>
                 <a:latin typeface="Playfair Display"/>
               </a:rPr>
-              <a:t>di Human Design</a:t>
+              <a:t>di Human Design </a:t>
             </a:r>
           </a:p>
         </p:txBody>
@@ -3300,7 +3300,7 @@
           <a:noFill/>
         </p:spPr>
         <p:txBody>
-          <a:bodyPr wrap="none" lIns="0" rIns="0" tIns="0" bIns="0" anchor="t">
+          <a:bodyPr wrap="square" lIns="0" rIns="0" tIns="0" bIns="0" anchor="t">
             <a:spAutoFit/>
           </a:bodyPr>
           <a:lstStyle/>
@@ -3339,7 +3339,7 @@
           <a:noFill/>
         </p:spPr>
         <p:txBody>
-          <a:bodyPr wrap="none" lIns="0" rIns="0" tIns="0" bIns="0" anchor="t">
+          <a:bodyPr wrap="square" lIns="0" rIns="0" tIns="0" bIns="0" anchor="t">
             <a:spAutoFit/>
           </a:bodyPr>
           <a:lstStyle/>
@@ -3378,7 +3378,7 @@
           <a:noFill/>
         </p:spPr>
         <p:txBody>
-          <a:bodyPr wrap="none" lIns="0" rIns="0" tIns="0" bIns="0" anchor="t">
+          <a:bodyPr wrap="square" lIns="0" rIns="0" tIns="0" bIns="0" anchor="t">
             <a:spAutoFit/>
           </a:bodyPr>
           <a:lstStyle/>
@@ -3515,7 +3515,7 @@
           <a:noFill/>
         </p:spPr>
         <p:txBody>
-          <a:bodyPr wrap="none" lIns="0" rIns="0" tIns="0" bIns="0" anchor="t">
+          <a:bodyPr wrap="square" lIns="0" rIns="0" tIns="0" bIns="0" anchor="t">
             <a:spAutoFit/>
           </a:bodyPr>
           <a:lstStyle/>
@@ -3554,7 +3554,7 @@
           <a:noFill/>
         </p:spPr>
         <p:txBody>
-          <a:bodyPr wrap="none" lIns="0" rIns="0" tIns="0" bIns="0" anchor="t">
+          <a:bodyPr wrap="square" lIns="0" rIns="0" tIns="0" bIns="0" anchor="t">
             <a:spAutoFit/>
           </a:bodyPr>
           <a:lstStyle/>
@@ -3593,7 +3593,7 @@
           <a:noFill/>
         </p:spPr>
         <p:txBody>
-          <a:bodyPr wrap="none" lIns="0" rIns="0" tIns="0" bIns="0" anchor="t">
+          <a:bodyPr wrap="square" lIns="0" rIns="0" tIns="0" bIns="0" anchor="t">
             <a:spAutoFit/>
           </a:bodyPr>
           <a:lstStyle/>
@@ -3610,7 +3610,7 @@
                 </a:solidFill>
                 <a:latin typeface="Outfit"/>
               </a:rPr>
-              <a:t>Per auto-realizzarci relazionalmente e materialmente abbiamo</a:t>
+              <a:t>Per auto-realizzarci relazionalmente e materialmente abbiamo </a:t>
             </a:r>
           </a:p>
           <a:p>
@@ -3648,7 +3648,7 @@
           <a:noFill/>
         </p:spPr>
         <p:txBody>
-          <a:bodyPr wrap="none" lIns="0" rIns="0" tIns="0" bIns="0" anchor="t">
+          <a:bodyPr wrap="square" lIns="0" rIns="0" tIns="0" bIns="0" anchor="t">
             <a:spAutoFit/>
           </a:bodyPr>
           <a:lstStyle/>
@@ -3665,7 +3665,7 @@
                 </a:solidFill>
                 <a:latin typeface="Outfit"/>
               </a:rPr>
-              <a:t>Quando sei allineato con ciò che è corretto per te, entri in relazione</a:t>
+              <a:t>Quando sei allineato con ciò che è corretto per te, entri in relazione </a:t>
             </a:r>
           </a:p>
           <a:p>
@@ -3681,7 +3681,7 @@
                 </a:solidFill>
                 <a:latin typeface="Outfit"/>
               </a:rPr>
-              <a:t>proprio con chi sei fatto per connetterti. In questo modo ci si può</a:t>
+              <a:t>proprio con chi sei fatto per connetterti. In questo modo ci si può </a:t>
             </a:r>
           </a:p>
           <a:p>
@@ -3719,7 +3719,7 @@
           <a:noFill/>
         </p:spPr>
         <p:txBody>
-          <a:bodyPr wrap="none" lIns="0" rIns="0" tIns="0" bIns="0" anchor="t">
+          <a:bodyPr wrap="square" lIns="0" rIns="0" tIns="0" bIns="0" anchor="t">
             <a:spAutoFit/>
           </a:bodyPr>
           <a:lstStyle/>
@@ -3736,7 +3736,7 @@
                 </a:solidFill>
                 <a:latin typeface="Outfit"/>
               </a:rPr>
-              <a:t>Conoscere sé stessi significa poter ottimizzare la propria energia,</a:t>
+              <a:t>Conoscere sé stessi significa poter ottimizzare la propria energia, </a:t>
             </a:r>
           </a:p>
           <a:p>
@@ -3752,7 +3752,7 @@
                 </a:solidFill>
                 <a:latin typeface="Outfit"/>
               </a:rPr>
-              <a:t>porre i confini sani che servono a ciascuno di noi e raggiungere il</a:t>
+              <a:t>porre i confini sani che servono a ciascuno di noi e raggiungere il </a:t>
             </a:r>
           </a:p>
           <a:p>
@@ -3768,7 +3768,7 @@
                 </a:solidFill>
                 <a:latin typeface="Outfit"/>
               </a:rPr>
-              <a:t>benessere e la prosperità che sostengano la soddisfazione, il</a:t>
+              <a:t>benessere e la prosperità che sostengano la soddisfazione, il </a:t>
             </a:r>
           </a:p>
           <a:p>
@@ -3806,7 +3806,7 @@
           <a:noFill/>
         </p:spPr>
         <p:txBody>
-          <a:bodyPr wrap="none" lIns="0" rIns="0" tIns="0" bIns="0" anchor="t">
+          <a:bodyPr wrap="square" lIns="0" rIns="0" tIns="0" bIns="0" anchor="t">
             <a:spAutoFit/>
           </a:bodyPr>
           <a:lstStyle/>
@@ -3845,7 +3845,7 @@
           <a:noFill/>
         </p:spPr>
         <p:txBody>
-          <a:bodyPr wrap="none" lIns="0" rIns="0" tIns="0" bIns="0" anchor="t">
+          <a:bodyPr wrap="square" lIns="0" rIns="0" tIns="0" bIns="0" anchor="t">
             <a:spAutoFit/>
           </a:bodyPr>
           <a:lstStyle/>
@@ -3982,7 +3982,7 @@
           <a:noFill/>
         </p:spPr>
         <p:txBody>
-          <a:bodyPr wrap="none" lIns="0" rIns="0" tIns="0" bIns="0" anchor="t">
+          <a:bodyPr wrap="square" lIns="0" rIns="0" tIns="0" bIns="0" anchor="t">
             <a:spAutoFit/>
           </a:bodyPr>
           <a:lstStyle/>
@@ -4021,7 +4021,7 @@
           <a:noFill/>
         </p:spPr>
         <p:txBody>
-          <a:bodyPr wrap="none" lIns="0" rIns="0" tIns="0" bIns="0" anchor="t">
+          <a:bodyPr wrap="square" lIns="0" rIns="0" tIns="0" bIns="0" anchor="t">
             <a:spAutoFit/>
           </a:bodyPr>
           <a:lstStyle/>
@@ -4060,7 +4060,7 @@
           <a:noFill/>
         </p:spPr>
         <p:txBody>
-          <a:bodyPr wrap="none" lIns="0" rIns="0" tIns="0" bIns="0" anchor="t">
+          <a:bodyPr wrap="square" lIns="0" rIns="0" tIns="0" bIns="0" anchor="t">
             <a:spAutoFit/>
           </a:bodyPr>
           <a:lstStyle/>
@@ -4077,7 +4077,7 @@
                 </a:solidFill>
                 <a:latin typeface="Outfit"/>
               </a:rPr>
-              <a:t>Non esiste una scorciatoia per diventare bravi in questa materia. Le</a:t>
+              <a:t>Non esiste una scorciatoia per diventare bravi in questa materia. Le </a:t>
             </a:r>
           </a:p>
           <a:p>
@@ -4093,7 +4093,7 @@
                 </a:solidFill>
                 <a:latin typeface="Outfit"/>
               </a:rPr>
-              <a:t>AI possono fornire informazioni sommarie e spesso scorrette, quindi</a:t>
+              <a:t>AI possono fornire informazioni sommarie e spesso scorrette, quindi </a:t>
             </a:r>
           </a:p>
           <a:p>
@@ -4109,7 +4109,7 @@
                 </a:solidFill>
                 <a:latin typeface="Outfit"/>
               </a:rPr>
-              <a:t>l'unica opzione è imparare "alla vecchia maniera": applicando ciò che</a:t>
+              <a:t>l'unica opzione è imparare "alla vecchia maniera": applicando ciò che </a:t>
             </a:r>
           </a:p>
           <a:p>
@@ -4125,7 +4125,7 @@
                 </a:solidFill>
                 <a:latin typeface="Outfit"/>
               </a:rPr>
-              <a:t>si apprende nella vita quotidiana, facendo gli esercizi settimanali e</a:t>
+              <a:t>si apprende nella vita quotidiana, facendo gli esercizi settimanali e </a:t>
             </a:r>
           </a:p>
           <a:p>
@@ -4163,7 +4163,7 @@
           <a:noFill/>
         </p:spPr>
         <p:txBody>
-          <a:bodyPr wrap="none" lIns="0" rIns="0" tIns="0" bIns="0" anchor="t">
+          <a:bodyPr wrap="square" lIns="0" rIns="0" tIns="0" bIns="0" anchor="t">
             <a:spAutoFit/>
           </a:bodyPr>
           <a:lstStyle/>
@@ -4180,7 +4180,7 @@
                 </a:solidFill>
                 <a:latin typeface="Playfair Display"/>
               </a:rPr>
-              <a:t>Non serve essere perfetti. Serve essere</a:t>
+              <a:t>Non serve essere perfetti. Serve essere </a:t>
             </a:r>
           </a:p>
           <a:p>
@@ -4218,7 +4218,7 @@
           <a:noFill/>
         </p:spPr>
         <p:txBody>
-          <a:bodyPr wrap="none" lIns="0" rIns="0" tIns="0" bIns="0" anchor="t">
+          <a:bodyPr wrap="square" lIns="0" rIns="0" tIns="0" bIns="0" anchor="t">
             <a:spAutoFit/>
           </a:bodyPr>
           <a:lstStyle/>
@@ -4257,7 +4257,7 @@
           <a:noFill/>
         </p:spPr>
         <p:txBody>
-          <a:bodyPr wrap="none" lIns="0" rIns="0" tIns="0" bIns="0" anchor="t">
+          <a:bodyPr wrap="square" lIns="0" rIns="0" tIns="0" bIns="0" anchor="t">
             <a:spAutoFit/>
           </a:bodyPr>
           <a:lstStyle/>
@@ -4738,7 +4738,7 @@
           <a:noFill/>
         </p:spPr>
         <p:txBody>
-          <a:bodyPr wrap="none" lIns="0" rIns="0" tIns="0" bIns="0" anchor="t">
+          <a:bodyPr wrap="square" lIns="0" rIns="0" tIns="0" bIns="0" anchor="t">
             <a:spAutoFit/>
           </a:bodyPr>
           <a:lstStyle/>
@@ -4777,7 +4777,7 @@
           <a:noFill/>
         </p:spPr>
         <p:txBody>
-          <a:bodyPr wrap="none" lIns="0" rIns="0" tIns="0" bIns="0" anchor="t">
+          <a:bodyPr wrap="square" lIns="0" rIns="0" tIns="0" bIns="0" anchor="t">
             <a:spAutoFit/>
           </a:bodyPr>
           <a:lstStyle/>
@@ -4816,7 +4816,7 @@
           <a:noFill/>
         </p:spPr>
         <p:txBody>
-          <a:bodyPr wrap="none" lIns="0" rIns="0" tIns="0" bIns="0" anchor="t">
+          <a:bodyPr wrap="square" lIns="0" rIns="0" tIns="0" bIns="0" anchor="t">
             <a:spAutoFit/>
           </a:bodyPr>
           <a:lstStyle/>
@@ -4855,7 +4855,7 @@
           <a:noFill/>
         </p:spPr>
         <p:txBody>
-          <a:bodyPr wrap="none" lIns="0" rIns="0" tIns="0" bIns="0" anchor="t">
+          <a:bodyPr wrap="square" lIns="0" rIns="0" tIns="0" bIns="0" anchor="t">
             <a:spAutoFit/>
           </a:bodyPr>
           <a:lstStyle/>
@@ -4894,7 +4894,7 @@
           <a:noFill/>
         </p:spPr>
         <p:txBody>
-          <a:bodyPr wrap="none" lIns="0" rIns="0" tIns="0" bIns="0" anchor="t">
+          <a:bodyPr wrap="square" lIns="0" rIns="0" tIns="0" bIns="0" anchor="t">
             <a:spAutoFit/>
           </a:bodyPr>
           <a:lstStyle/>
@@ -4933,7 +4933,7 @@
           <a:noFill/>
         </p:spPr>
         <p:txBody>
-          <a:bodyPr wrap="none" lIns="0" rIns="0" tIns="0" bIns="0" anchor="t">
+          <a:bodyPr wrap="square" lIns="0" rIns="0" tIns="0" bIns="0" anchor="t">
             <a:spAutoFit/>
           </a:bodyPr>
           <a:lstStyle/>
@@ -4950,7 +4950,7 @@
                 </a:solidFill>
                 <a:latin typeface="Outfit"/>
               </a:rPr>
-              <a:t>Fig. 2 — La carta di Valentina Russo, 21 giugno 1988,</a:t>
+              <a:t>Fig. 2 — La carta di Valentina Russo, 21 giugno 1988, </a:t>
             </a:r>
           </a:p>
           <a:p>
@@ -4988,7 +4988,7 @@
           <a:noFill/>
         </p:spPr>
         <p:txBody>
-          <a:bodyPr wrap="none" lIns="0" rIns="0" tIns="0" bIns="0" anchor="t">
+          <a:bodyPr wrap="square" lIns="0" rIns="0" tIns="0" bIns="0" anchor="t">
             <a:spAutoFit/>
           </a:bodyPr>
           <a:lstStyle/>
@@ -5027,7 +5027,7 @@
           <a:noFill/>
         </p:spPr>
         <p:txBody>
-          <a:bodyPr wrap="none" lIns="0" rIns="0" tIns="0" bIns="0" anchor="t">
+          <a:bodyPr wrap="square" lIns="0" rIns="0" tIns="0" bIns="0" anchor="t">
             <a:spAutoFit/>
           </a:bodyPr>
           <a:lstStyle/>
@@ -5066,7 +5066,7 @@
           <a:noFill/>
         </p:spPr>
         <p:txBody>
-          <a:bodyPr wrap="none" lIns="0" rIns="0" tIns="0" bIns="0" anchor="t">
+          <a:bodyPr wrap="square" lIns="0" rIns="0" tIns="0" bIns="0" anchor="t">
             <a:spAutoFit/>
           </a:bodyPr>
           <a:lstStyle/>
@@ -5105,7 +5105,7 @@
           <a:noFill/>
         </p:spPr>
         <p:txBody>
-          <a:bodyPr wrap="none" lIns="0" rIns="0" tIns="0" bIns="0" anchor="t">
+          <a:bodyPr wrap="square" lIns="0" rIns="0" tIns="0" bIns="0" anchor="t">
             <a:spAutoFit/>
           </a:bodyPr>
           <a:lstStyle/>
@@ -5144,7 +5144,7 @@
           <a:noFill/>
         </p:spPr>
         <p:txBody>
-          <a:bodyPr wrap="none" lIns="0" rIns="0" tIns="0" bIns="0" anchor="t">
+          <a:bodyPr wrap="square" lIns="0" rIns="0" tIns="0" bIns="0" anchor="t">
             <a:spAutoFit/>
           </a:bodyPr>
           <a:lstStyle/>
@@ -5161,7 +5161,7 @@
                 </a:solidFill>
                 <a:latin typeface="Outfit"/>
               </a:rPr>
-              <a:t>Ci dice se il Disegno è tutto collegato, e come</a:t>
+              <a:t>Ci dice se il Disegno è tutto collegato, e come </a:t>
             </a:r>
           </a:p>
           <a:p>
@@ -5205,7 +5205,7 @@
           </a:ln>
         </p:spPr>
         <p:txBody>
-          <a:bodyPr wrap="none" lIns="114300" rIns="114300" tIns="57150" bIns="57150" anchor="t">
+          <a:bodyPr wrap="square" lIns="114300" rIns="114300" tIns="57150" bIns="57150" anchor="t">
             <a:spAutoFit/>
           </a:bodyPr>
           <a:lstStyle/>
@@ -5244,7 +5244,7 @@
           <a:noFill/>
         </p:spPr>
         <p:txBody>
-          <a:bodyPr wrap="none" lIns="0" rIns="0" tIns="0" bIns="0" anchor="t">
+          <a:bodyPr wrap="square" lIns="0" rIns="0" tIns="0" bIns="0" anchor="t">
             <a:spAutoFit/>
           </a:bodyPr>
           <a:lstStyle/>
@@ -5283,7 +5283,7 @@
           <a:noFill/>
         </p:spPr>
         <p:txBody>
-          <a:bodyPr wrap="none" lIns="0" rIns="0" tIns="0" bIns="0" anchor="t">
+          <a:bodyPr wrap="square" lIns="0" rIns="0" tIns="0" bIns="0" anchor="t">
             <a:spAutoFit/>
           </a:bodyPr>
           <a:lstStyle/>
@@ -5420,7 +5420,7 @@
           <a:noFill/>
         </p:spPr>
         <p:txBody>
-          <a:bodyPr wrap="none" lIns="0" rIns="0" tIns="0" bIns="0" anchor="t">
+          <a:bodyPr wrap="square" lIns="0" rIns="0" tIns="0" bIns="0" anchor="t">
             <a:spAutoFit/>
           </a:bodyPr>
           <a:lstStyle/>
@@ -5459,7 +5459,7 @@
           <a:noFill/>
         </p:spPr>
         <p:txBody>
-          <a:bodyPr wrap="none" lIns="0" rIns="0" tIns="0" bIns="0" anchor="t">
+          <a:bodyPr wrap="square" lIns="0" rIns="0" tIns="0" bIns="0" anchor="t">
             <a:spAutoFit/>
           </a:bodyPr>
           <a:lstStyle/>
@@ -5498,7 +5498,7 @@
           <a:noFill/>
         </p:spPr>
         <p:txBody>
-          <a:bodyPr wrap="none" lIns="0" rIns="0" tIns="0" bIns="0" anchor="t">
+          <a:bodyPr wrap="square" lIns="0" rIns="0" tIns="0" bIns="0" anchor="t">
             <a:spAutoFit/>
           </a:bodyPr>
           <a:lstStyle/>
@@ -5537,7 +5537,7 @@
           <a:noFill/>
         </p:spPr>
         <p:txBody>
-          <a:bodyPr wrap="none" lIns="0" rIns="0" tIns="0" bIns="0" anchor="t">
+          <a:bodyPr wrap="square" lIns="0" rIns="0" tIns="0" bIns="0" anchor="t">
             <a:spAutoFit/>
           </a:bodyPr>
           <a:lstStyle/>
@@ -5576,7 +5576,7 @@
           <a:noFill/>
         </p:spPr>
         <p:txBody>
-          <a:bodyPr wrap="none" lIns="0" rIns="0" tIns="0" bIns="0" anchor="t">
+          <a:bodyPr wrap="square" lIns="0" rIns="0" tIns="0" bIns="0" anchor="t">
             <a:spAutoFit/>
           </a:bodyPr>
           <a:lstStyle/>
@@ -5631,7 +5631,7 @@
           <a:noFill/>
         </p:spPr>
         <p:txBody>
-          <a:bodyPr wrap="none" lIns="0" rIns="0" tIns="0" bIns="0" anchor="t">
+          <a:bodyPr wrap="square" lIns="0" rIns="0" tIns="0" bIns="0" anchor="t">
             <a:spAutoFit/>
           </a:bodyPr>
           <a:lstStyle/>
@@ -5670,7 +5670,7 @@
           <a:noFill/>
         </p:spPr>
         <p:txBody>
-          <a:bodyPr wrap="none" lIns="0" rIns="0" tIns="0" bIns="0" anchor="t">
+          <a:bodyPr wrap="square" lIns="0" rIns="0" tIns="0" bIns="0" anchor="t">
             <a:spAutoFit/>
           </a:bodyPr>
           <a:lstStyle/>
@@ -5725,7 +5725,7 @@
           <a:noFill/>
         </p:spPr>
         <p:txBody>
-          <a:bodyPr wrap="none" lIns="0" rIns="0" tIns="0" bIns="0" anchor="t">
+          <a:bodyPr wrap="square" lIns="0" rIns="0" tIns="0" bIns="0" anchor="t">
             <a:spAutoFit/>
           </a:bodyPr>
           <a:lstStyle/>
@@ -5764,7 +5764,7 @@
           <a:noFill/>
         </p:spPr>
         <p:txBody>
-          <a:bodyPr wrap="none" lIns="0" rIns="0" tIns="0" bIns="0" anchor="t">
+          <a:bodyPr wrap="square" lIns="0" rIns="0" tIns="0" bIns="0" anchor="t">
             <a:spAutoFit/>
           </a:bodyPr>
           <a:lstStyle/>
@@ -5819,7 +5819,7 @@
           <a:noFill/>
         </p:spPr>
         <p:txBody>
-          <a:bodyPr wrap="none" lIns="0" rIns="0" tIns="0" bIns="0" anchor="t">
+          <a:bodyPr wrap="square" lIns="0" rIns="0" tIns="0" bIns="0" anchor="t">
             <a:spAutoFit/>
           </a:bodyPr>
           <a:lstStyle/>
@@ -5858,7 +5858,7 @@
           <a:noFill/>
         </p:spPr>
         <p:txBody>
-          <a:bodyPr wrap="none" lIns="0" rIns="0" tIns="0" bIns="0" anchor="t">
+          <a:bodyPr wrap="square" lIns="0" rIns="0" tIns="0" bIns="0" anchor="t">
             <a:spAutoFit/>
           </a:bodyPr>
           <a:lstStyle/>
@@ -5913,7 +5913,7 @@
           <a:noFill/>
         </p:spPr>
         <p:txBody>
-          <a:bodyPr wrap="none" lIns="0" rIns="0" tIns="0" bIns="0" anchor="t">
+          <a:bodyPr wrap="square" lIns="0" rIns="0" tIns="0" bIns="0" anchor="t">
             <a:spAutoFit/>
           </a:bodyPr>
           <a:lstStyle/>
@@ -5952,7 +5952,7 @@
           <a:noFill/>
         </p:spPr>
         <p:txBody>
-          <a:bodyPr wrap="none" lIns="0" rIns="0" tIns="0" bIns="0" anchor="t">
+          <a:bodyPr wrap="square" lIns="0" rIns="0" tIns="0" bIns="0" anchor="t">
             <a:spAutoFit/>
           </a:bodyPr>
           <a:lstStyle/>
@@ -6007,7 +6007,7 @@
           <a:noFill/>
         </p:spPr>
         <p:txBody>
-          <a:bodyPr wrap="none" lIns="0" rIns="0" tIns="0" bIns="0" anchor="t">
+          <a:bodyPr wrap="square" lIns="0" rIns="0" tIns="0" bIns="0" anchor="t">
             <a:spAutoFit/>
           </a:bodyPr>
           <a:lstStyle/>
@@ -6046,7 +6046,7 @@
           <a:noFill/>
         </p:spPr>
         <p:txBody>
-          <a:bodyPr wrap="none" lIns="0" rIns="0" tIns="0" bIns="0" anchor="t">
+          <a:bodyPr wrap="square" lIns="0" rIns="0" tIns="0" bIns="0" anchor="t">
             <a:spAutoFit/>
           </a:bodyPr>
           <a:lstStyle/>
@@ -6546,7 +6546,7 @@
           <a:noFill/>
         </p:spPr>
         <p:txBody>
-          <a:bodyPr wrap="none" lIns="0" rIns="0" tIns="0" bIns="0" anchor="t">
+          <a:bodyPr wrap="square" lIns="0" rIns="0" tIns="0" bIns="0" anchor="t">
             <a:spAutoFit/>
           </a:bodyPr>
           <a:lstStyle/>
@@ -6585,7 +6585,7 @@
           <a:noFill/>
         </p:spPr>
         <p:txBody>
-          <a:bodyPr wrap="none" lIns="0" rIns="0" tIns="0" bIns="0" anchor="t">
+          <a:bodyPr wrap="square" lIns="0" rIns="0" tIns="0" bIns="0" anchor="t">
             <a:spAutoFit/>
           </a:bodyPr>
           <a:lstStyle/>
@@ -6624,7 +6624,7 @@
           <a:noFill/>
         </p:spPr>
         <p:txBody>
-          <a:bodyPr wrap="none" lIns="0" rIns="0" tIns="0" bIns="0" anchor="t">
+          <a:bodyPr wrap="square" lIns="0" rIns="0" tIns="0" bIns="0" anchor="t">
             <a:spAutoFit/>
           </a:bodyPr>
           <a:lstStyle/>
@@ -6663,7 +6663,7 @@
           <a:noFill/>
         </p:spPr>
         <p:txBody>
-          <a:bodyPr wrap="none" lIns="0" rIns="0" tIns="0" bIns="0" anchor="t">
+          <a:bodyPr wrap="square" lIns="0" rIns="0" tIns="0" bIns="0" anchor="t">
             <a:spAutoFit/>
           </a:bodyPr>
           <a:lstStyle/>
@@ -6702,7 +6702,7 @@
           <a:noFill/>
         </p:spPr>
         <p:txBody>
-          <a:bodyPr wrap="none" lIns="0" rIns="0" tIns="0" bIns="0" anchor="t">
+          <a:bodyPr wrap="square" lIns="0" rIns="0" tIns="0" bIns="0" anchor="t">
             <a:spAutoFit/>
           </a:bodyPr>
           <a:lstStyle/>
@@ -6741,7 +6741,7 @@
           <a:noFill/>
         </p:spPr>
         <p:txBody>
-          <a:bodyPr wrap="none" lIns="0" rIns="0" tIns="0" bIns="0" anchor="t">
+          <a:bodyPr wrap="square" lIns="0" rIns="0" tIns="0" bIns="0" anchor="t">
             <a:spAutoFit/>
           </a:bodyPr>
           <a:lstStyle/>
@@ -6780,7 +6780,7 @@
           <a:noFill/>
         </p:spPr>
         <p:txBody>
-          <a:bodyPr wrap="none" lIns="0" rIns="0" tIns="0" bIns="0" anchor="t">
+          <a:bodyPr wrap="square" lIns="0" rIns="0" tIns="0" bIns="0" anchor="t">
             <a:spAutoFit/>
           </a:bodyPr>
           <a:lstStyle/>
@@ -6819,7 +6819,7 @@
           <a:noFill/>
         </p:spPr>
         <p:txBody>
-          <a:bodyPr wrap="none" lIns="0" rIns="0" tIns="0" bIns="0" anchor="t">
+          <a:bodyPr wrap="square" lIns="0" rIns="0" tIns="0" bIns="0" anchor="t">
             <a:spAutoFit/>
           </a:bodyPr>
           <a:lstStyle/>
@@ -6858,7 +6858,7 @@
           <a:noFill/>
         </p:spPr>
         <p:txBody>
-          <a:bodyPr wrap="none" lIns="0" rIns="0" tIns="0" bIns="0" anchor="t">
+          <a:bodyPr wrap="square" lIns="0" rIns="0" tIns="0" bIns="0" anchor="t">
             <a:spAutoFit/>
           </a:bodyPr>
           <a:lstStyle/>
@@ -6897,7 +6897,7 @@
           <a:noFill/>
         </p:spPr>
         <p:txBody>
-          <a:bodyPr wrap="none" lIns="0" rIns="0" tIns="0" bIns="0" anchor="t">
+          <a:bodyPr wrap="square" lIns="0" rIns="0" tIns="0" bIns="0" anchor="t">
             <a:spAutoFit/>
           </a:bodyPr>
           <a:lstStyle/>
@@ -6936,7 +6936,7 @@
           <a:noFill/>
         </p:spPr>
         <p:txBody>
-          <a:bodyPr wrap="none" lIns="0" rIns="0" tIns="0" bIns="0" anchor="t">
+          <a:bodyPr wrap="square" lIns="0" rIns="0" tIns="0" bIns="0" anchor="t">
             <a:spAutoFit/>
           </a:bodyPr>
           <a:lstStyle/>
@@ -6975,7 +6975,7 @@
           <a:noFill/>
         </p:spPr>
         <p:txBody>
-          <a:bodyPr wrap="none" lIns="0" rIns="0" tIns="0" bIns="0" anchor="t">
+          <a:bodyPr wrap="square" lIns="0" rIns="0" tIns="0" bIns="0" anchor="t">
             <a:spAutoFit/>
           </a:bodyPr>
           <a:lstStyle/>
@@ -7014,7 +7014,7 @@
           <a:noFill/>
         </p:spPr>
         <p:txBody>
-          <a:bodyPr wrap="none" lIns="0" rIns="0" tIns="0" bIns="0" anchor="t">
+          <a:bodyPr wrap="square" lIns="0" rIns="0" tIns="0" bIns="0" anchor="t">
             <a:spAutoFit/>
           </a:bodyPr>
           <a:lstStyle/>
@@ -7053,7 +7053,7 @@
           <a:noFill/>
         </p:spPr>
         <p:txBody>
-          <a:bodyPr wrap="none" lIns="0" rIns="0" tIns="0" bIns="0" anchor="t">
+          <a:bodyPr wrap="square" lIns="0" rIns="0" tIns="0" bIns="0" anchor="t">
             <a:spAutoFit/>
           </a:bodyPr>
           <a:lstStyle/>
@@ -7190,7 +7190,7 @@
           <a:noFill/>
         </p:spPr>
         <p:txBody>
-          <a:bodyPr wrap="none" lIns="0" rIns="0" tIns="0" bIns="0" anchor="t">
+          <a:bodyPr wrap="square" lIns="0" rIns="0" tIns="0" bIns="0" anchor="t">
             <a:spAutoFit/>
           </a:bodyPr>
           <a:lstStyle/>
@@ -7229,7 +7229,7 @@
           <a:noFill/>
         </p:spPr>
         <p:txBody>
-          <a:bodyPr wrap="none" lIns="0" rIns="0" tIns="0" bIns="0" anchor="t">
+          <a:bodyPr wrap="square" lIns="0" rIns="0" tIns="0" bIns="0" anchor="t">
             <a:spAutoFit/>
           </a:bodyPr>
           <a:lstStyle/>
@@ -7268,7 +7268,7 @@
           <a:noFill/>
         </p:spPr>
         <p:txBody>
-          <a:bodyPr wrap="none" lIns="0" rIns="0" tIns="0" bIns="0" anchor="t">
+          <a:bodyPr wrap="square" lIns="0" rIns="0" tIns="0" bIns="0" anchor="t">
             <a:spAutoFit/>
           </a:bodyPr>
           <a:lstStyle/>
@@ -7285,7 +7285,7 @@
                 </a:solidFill>
                 <a:latin typeface="Outfit"/>
               </a:rPr>
-              <a:t>ESISTONO DIVERSI STRATI DI SINTESI, DI CUI TRE SONO QUELLI</a:t>
+              <a:t>ESISTONO DIVERSI STRATI DI SINTESI, DI CUI TRE SONO QUELLI </a:t>
             </a:r>
           </a:p>
           <a:p>
@@ -7323,7 +7323,7 @@
           <a:noFill/>
         </p:spPr>
         <p:txBody>
-          <a:bodyPr wrap="none" lIns="0" rIns="0" tIns="0" bIns="0" anchor="t">
+          <a:bodyPr wrap="square" lIns="0" rIns="0" tIns="0" bIns="0" anchor="t">
             <a:spAutoFit/>
           </a:bodyPr>
           <a:lstStyle/>
@@ -7362,7 +7362,7 @@
           <a:noFill/>
         </p:spPr>
         <p:txBody>
-          <a:bodyPr wrap="none" lIns="0" rIns="0" tIns="0" bIns="0" anchor="t">
+          <a:bodyPr wrap="square" lIns="0" rIns="0" tIns="0" bIns="0" anchor="t">
             <a:spAutoFit/>
           </a:bodyPr>
           <a:lstStyle/>
@@ -7397,7 +7397,7 @@
           <a:noFill/>
         </p:spPr>
         <p:txBody>
-          <a:bodyPr wrap="none" lIns="0" rIns="0" tIns="0" bIns="0" anchor="t">
+          <a:bodyPr wrap="square" lIns="0" rIns="0" tIns="0" bIns="0" anchor="t">
             <a:spAutoFit/>
           </a:bodyPr>
           <a:lstStyle/>
@@ -7436,7 +7436,7 @@
           <a:noFill/>
         </p:spPr>
         <p:txBody>
-          <a:bodyPr wrap="none" lIns="0" rIns="0" tIns="0" bIns="0" anchor="t">
+          <a:bodyPr wrap="square" lIns="0" rIns="0" tIns="0" bIns="0" anchor="t">
             <a:spAutoFit/>
           </a:bodyPr>
           <a:lstStyle/>
@@ -7471,7 +7471,7 @@
           <a:noFill/>
         </p:spPr>
         <p:txBody>
-          <a:bodyPr wrap="none" lIns="0" rIns="0" tIns="0" bIns="0" anchor="t">
+          <a:bodyPr wrap="square" lIns="0" rIns="0" tIns="0" bIns="0" anchor="t">
             <a:spAutoFit/>
           </a:bodyPr>
           <a:lstStyle/>
@@ -7510,7 +7510,7 @@
           <a:noFill/>
         </p:spPr>
         <p:txBody>
-          <a:bodyPr wrap="none" lIns="0" rIns="0" tIns="0" bIns="0" anchor="t">
+          <a:bodyPr wrap="square" lIns="0" rIns="0" tIns="0" bIns="0" anchor="t">
             <a:spAutoFit/>
           </a:bodyPr>
           <a:lstStyle/>
@@ -7545,7 +7545,7 @@
           <a:noFill/>
         </p:spPr>
         <p:txBody>
-          <a:bodyPr wrap="none" lIns="0" rIns="0" tIns="0" bIns="0" anchor="t">
+          <a:bodyPr wrap="square" lIns="0" rIns="0" tIns="0" bIns="0" anchor="t">
             <a:spAutoFit/>
           </a:bodyPr>
           <a:lstStyle/>
@@ -7584,7 +7584,7 @@
           <a:noFill/>
         </p:spPr>
         <p:txBody>
-          <a:bodyPr wrap="none" lIns="0" rIns="0" tIns="0" bIns="0" anchor="t">
+          <a:bodyPr wrap="square" lIns="0" rIns="0" tIns="0" bIns="0" anchor="t">
             <a:spAutoFit/>
           </a:bodyPr>
           <a:lstStyle/>
@@ -7769,7 +7769,7 @@
           <a:noFill/>
         </p:spPr>
         <p:txBody>
-          <a:bodyPr wrap="none" lIns="0" rIns="0" tIns="0" bIns="0" anchor="t">
+          <a:bodyPr wrap="square" lIns="0" rIns="0" tIns="0" bIns="0" anchor="t">
             <a:spAutoFit/>
           </a:bodyPr>
           <a:lstStyle/>
@@ -7808,7 +7808,7 @@
           <a:noFill/>
         </p:spPr>
         <p:txBody>
-          <a:bodyPr wrap="none" lIns="0" rIns="0" tIns="0" bIns="0" anchor="t">
+          <a:bodyPr wrap="square" lIns="0" rIns="0" tIns="0" bIns="0" anchor="t">
             <a:spAutoFit/>
           </a:bodyPr>
           <a:lstStyle/>
@@ -7847,7 +7847,7 @@
           <a:noFill/>
         </p:spPr>
         <p:txBody>
-          <a:bodyPr wrap="none" lIns="0" rIns="0" tIns="0" bIns="0" anchor="t">
+          <a:bodyPr wrap="square" lIns="0" rIns="0" tIns="0" bIns="0" anchor="t">
             <a:spAutoFit/>
           </a:bodyPr>
           <a:lstStyle/>
@@ -7873,7 +7873,7 @@
                 </a:solidFill>
                 <a:latin typeface="Outfit"/>
               </a:rPr>
-              <a:t>· Mappa genetica inconscia</a:t>
+              <a:t> · Mappa genetica inconscia</a:t>
             </a:r>
           </a:p>
         </p:txBody>
@@ -7895,7 +7895,7 @@
           <a:noFill/>
         </p:spPr>
         <p:txBody>
-          <a:bodyPr wrap="none" lIns="0" rIns="0" tIns="0" bIns="0" anchor="t">
+          <a:bodyPr wrap="square" lIns="0" rIns="0" tIns="0" bIns="0" anchor="t">
             <a:spAutoFit/>
           </a:bodyPr>
           <a:lstStyle/>
@@ -7934,7 +7934,7 @@
           <a:noFill/>
         </p:spPr>
         <p:txBody>
-          <a:bodyPr wrap="none" lIns="0" rIns="0" tIns="0" bIns="0" anchor="t">
+          <a:bodyPr wrap="square" lIns="0" rIns="0" tIns="0" bIns="0" anchor="t">
             <a:spAutoFit/>
           </a:bodyPr>
           <a:lstStyle/>
@@ -7960,7 +7960,7 @@
                 </a:solidFill>
                 <a:latin typeface="Outfit"/>
               </a:rPr>
-              <a:t>· Mappa della personalità conscia</a:t>
+              <a:t> · Mappa della personalità conscia</a:t>
             </a:r>
           </a:p>
         </p:txBody>
@@ -7982,7 +7982,7 @@
           <a:noFill/>
         </p:spPr>
         <p:txBody>
-          <a:bodyPr wrap="none" lIns="0" rIns="0" tIns="0" bIns="0" anchor="t">
+          <a:bodyPr wrap="square" lIns="0" rIns="0" tIns="0" bIns="0" anchor="t">
             <a:spAutoFit/>
           </a:bodyPr>
           <a:lstStyle/>
@@ -8021,7 +8021,7 @@
           <a:noFill/>
         </p:spPr>
         <p:txBody>
-          <a:bodyPr wrap="none" lIns="0" rIns="0" tIns="0" bIns="0" anchor="t">
+          <a:bodyPr wrap="square" lIns="0" rIns="0" tIns="0" bIns="0" anchor="t">
             <a:spAutoFit/>
           </a:bodyPr>
           <a:lstStyle/>
@@ -8047,7 +8047,7 @@
                 </a:solidFill>
                 <a:latin typeface="Outfit"/>
               </a:rPr>
-              <a:t>· Canali e centri definiti</a:t>
+              <a:t> · Canali e centri definiti</a:t>
             </a:r>
           </a:p>
         </p:txBody>
@@ -8069,7 +8069,7 @@
           <a:noFill/>
         </p:spPr>
         <p:txBody>
-          <a:bodyPr wrap="none" lIns="0" rIns="0" tIns="0" bIns="0" anchor="t">
+          <a:bodyPr wrap="square" lIns="0" rIns="0" tIns="0" bIns="0" anchor="t">
             <a:spAutoFit/>
           </a:bodyPr>
           <a:lstStyle/>
@@ -8108,7 +8108,7 @@
           <a:noFill/>
         </p:spPr>
         <p:txBody>
-          <a:bodyPr wrap="none" lIns="0" rIns="0" tIns="0" bIns="0" anchor="t">
+          <a:bodyPr wrap="square" lIns="0" rIns="0" tIns="0" bIns="0" anchor="t">
             <a:spAutoFit/>
           </a:bodyPr>
           <a:lstStyle/>
@@ -8245,7 +8245,7 @@
           <a:noFill/>
         </p:spPr>
         <p:txBody>
-          <a:bodyPr wrap="none" lIns="0" rIns="0" tIns="0" bIns="0" anchor="t">
+          <a:bodyPr wrap="square" lIns="0" rIns="0" tIns="0" bIns="0" anchor="t">
             <a:spAutoFit/>
           </a:bodyPr>
           <a:lstStyle/>
@@ -8284,7 +8284,7 @@
           <a:noFill/>
         </p:spPr>
         <p:txBody>
-          <a:bodyPr wrap="none" lIns="0" rIns="0" tIns="0" bIns="0" anchor="t">
+          <a:bodyPr wrap="square" lIns="0" rIns="0" tIns="0" bIns="0" anchor="t">
             <a:spAutoFit/>
           </a:bodyPr>
           <a:lstStyle/>
@@ -8323,7 +8323,7 @@
           <a:noFill/>
         </p:spPr>
         <p:txBody>
-          <a:bodyPr wrap="none" lIns="0" rIns="0" tIns="0" bIns="0" anchor="t">
+          <a:bodyPr wrap="square" lIns="0" rIns="0" tIns="0" bIns="0" anchor="t">
             <a:spAutoFit/>
           </a:bodyPr>
           <a:lstStyle/>
@@ -8362,7 +8362,7 @@
           <a:noFill/>
         </p:spPr>
         <p:txBody>
-          <a:bodyPr wrap="none" lIns="0" rIns="0" tIns="0" bIns="0" anchor="t">
+          <a:bodyPr wrap="square" lIns="0" rIns="0" tIns="0" bIns="0" anchor="t">
             <a:spAutoFit/>
           </a:bodyPr>
           <a:lstStyle/>
@@ -8379,7 +8379,7 @@
                 </a:solidFill>
                 <a:latin typeface="Outfit"/>
               </a:rPr>
-              <a:t>Quando due porte definite si incontrano, creano un</a:t>
+              <a:t>Quando due porte definite si incontrano, creano un </a:t>
             </a:r>
           </a:p>
           <a:p>
@@ -8395,7 +8395,7 @@
                 </a:solidFill>
                 <a:latin typeface="Outfit"/>
               </a:rPr>
-              <a:t>canale. Quel canale determina un punto di forza, definito</a:t>
+              <a:t>canale. Quel canale determina un punto di forza, definito </a:t>
             </a:r>
           </a:p>
           <a:p>
@@ -8411,7 +8411,7 @@
                 </a:solidFill>
                 <a:latin typeface="Outfit"/>
               </a:rPr>
-              <a:t>da un circuito di energia coerente, che a sua volta</a:t>
+              <a:t>da un circuito di energia coerente, che a sua volta </a:t>
             </a:r>
           </a:p>
           <a:p>
@@ -8455,7 +8455,7 @@
           </a:ln>
         </p:spPr>
         <p:txBody>
-          <a:bodyPr wrap="none" lIns="114300" rIns="114300" tIns="57150" bIns="57150" anchor="t">
+          <a:bodyPr wrap="square" lIns="114300" rIns="114300" tIns="57150" bIns="57150" anchor="t">
             <a:spAutoFit/>
           </a:bodyPr>
           <a:lstStyle/>
@@ -8494,7 +8494,7 @@
           <a:noFill/>
         </p:spPr>
         <p:txBody>
-          <a:bodyPr wrap="none" lIns="0" rIns="0" tIns="0" bIns="0" anchor="t">
+          <a:bodyPr wrap="square" lIns="0" rIns="0" tIns="0" bIns="0" anchor="t">
             <a:spAutoFit/>
           </a:bodyPr>
           <a:lstStyle/>
@@ -8533,7 +8533,7 @@
           <a:noFill/>
         </p:spPr>
         <p:txBody>
-          <a:bodyPr wrap="none" lIns="0" rIns="0" tIns="0" bIns="0" anchor="t">
+          <a:bodyPr wrap="square" lIns="0" rIns="0" tIns="0" bIns="0" anchor="t">
             <a:spAutoFit/>
           </a:bodyPr>
           <a:lstStyle/>
@@ -8742,7 +8742,7 @@
           <a:noFill/>
         </p:spPr>
         <p:txBody>
-          <a:bodyPr wrap="none" lIns="0" rIns="0" tIns="0" bIns="0" anchor="t">
+          <a:bodyPr wrap="square" lIns="0" rIns="0" tIns="0" bIns="0" anchor="t">
             <a:spAutoFit/>
           </a:bodyPr>
           <a:lstStyle/>
@@ -8781,7 +8781,7 @@
           <a:noFill/>
         </p:spPr>
         <p:txBody>
-          <a:bodyPr wrap="none" lIns="0" rIns="0" tIns="0" bIns="0" anchor="t">
+          <a:bodyPr wrap="square" lIns="0" rIns="0" tIns="0" bIns="0" anchor="t">
             <a:spAutoFit/>
           </a:bodyPr>
           <a:lstStyle/>
@@ -8820,7 +8820,7 @@
           <a:noFill/>
         </p:spPr>
         <p:txBody>
-          <a:bodyPr wrap="none" lIns="0" rIns="0" tIns="0" bIns="0" anchor="t">
+          <a:bodyPr wrap="square" lIns="0" rIns="0" tIns="0" bIns="0" anchor="t">
             <a:spAutoFit/>
           </a:bodyPr>
           <a:lstStyle/>
@@ -8875,7 +8875,7 @@
           <a:noFill/>
         </p:spPr>
         <p:txBody>
-          <a:bodyPr wrap="none" lIns="0" rIns="0" tIns="0" bIns="0" anchor="t">
+          <a:bodyPr wrap="square" lIns="0" rIns="0" tIns="0" bIns="0" anchor="t">
             <a:spAutoFit/>
           </a:bodyPr>
           <a:lstStyle/>
@@ -8930,7 +8930,7 @@
           <a:noFill/>
         </p:spPr>
         <p:txBody>
-          <a:bodyPr wrap="none" lIns="0" rIns="0" tIns="0" bIns="0" anchor="t">
+          <a:bodyPr wrap="square" lIns="0" rIns="0" tIns="0" bIns="0" anchor="t">
             <a:spAutoFit/>
           </a:bodyPr>
           <a:lstStyle/>
@@ -8985,7 +8985,7 @@
           <a:noFill/>
         </p:spPr>
         <p:txBody>
-          <a:bodyPr wrap="none" lIns="0" rIns="0" tIns="0" bIns="0" anchor="t">
+          <a:bodyPr wrap="square" lIns="0" rIns="0" tIns="0" bIns="0" anchor="t">
             <a:spAutoFit/>
           </a:bodyPr>
           <a:lstStyle/>
@@ -9040,7 +9040,7 @@
           <a:noFill/>
         </p:spPr>
         <p:txBody>
-          <a:bodyPr wrap="none" lIns="0" rIns="0" tIns="0" bIns="0" anchor="t">
+          <a:bodyPr wrap="square" lIns="0" rIns="0" tIns="0" bIns="0" anchor="t">
             <a:spAutoFit/>
           </a:bodyPr>
           <a:lstStyle/>
@@ -9079,7 +9079,7 @@
           <a:noFill/>
         </p:spPr>
         <p:txBody>
-          <a:bodyPr wrap="none" lIns="0" rIns="0" tIns="0" bIns="0" anchor="t">
+          <a:bodyPr wrap="square" lIns="0" rIns="0" tIns="0" bIns="0" anchor="t">
             <a:spAutoFit/>
           </a:bodyPr>
           <a:lstStyle/>
@@ -9118,7 +9118,7 @@
           <a:noFill/>
         </p:spPr>
         <p:txBody>
-          <a:bodyPr wrap="none" lIns="0" rIns="0" tIns="0" bIns="0" anchor="t">
+          <a:bodyPr wrap="square" lIns="0" rIns="0" tIns="0" bIns="0" anchor="t">
             <a:spAutoFit/>
           </a:bodyPr>
           <a:lstStyle/>
@@ -9599,7 +9599,7 @@
           <a:noFill/>
         </p:spPr>
         <p:txBody>
-          <a:bodyPr wrap="none" lIns="0" rIns="0" tIns="0" bIns="0" anchor="t">
+          <a:bodyPr wrap="square" lIns="0" rIns="0" tIns="0" bIns="0" anchor="t">
             <a:spAutoFit/>
           </a:bodyPr>
           <a:lstStyle/>
@@ -9638,7 +9638,7 @@
           <a:noFill/>
         </p:spPr>
         <p:txBody>
-          <a:bodyPr wrap="none" lIns="0" rIns="0" tIns="0" bIns="0" anchor="t">
+          <a:bodyPr wrap="square" lIns="0" rIns="0" tIns="0" bIns="0" anchor="t">
             <a:spAutoFit/>
           </a:bodyPr>
           <a:lstStyle/>
@@ -9677,7 +9677,7 @@
           <a:noFill/>
         </p:spPr>
         <p:txBody>
-          <a:bodyPr wrap="none" lIns="0" rIns="0" tIns="0" bIns="0" anchor="t">
+          <a:bodyPr wrap="square" lIns="0" rIns="0" tIns="0" bIns="0" anchor="t">
             <a:spAutoFit/>
           </a:bodyPr>
           <a:lstStyle/>
@@ -9732,7 +9732,7 @@
           <a:noFill/>
         </p:spPr>
         <p:txBody>
-          <a:bodyPr wrap="none" lIns="0" rIns="0" tIns="0" bIns="0" anchor="t">
+          <a:bodyPr wrap="square" lIns="0" rIns="0" tIns="0" bIns="0" anchor="t">
             <a:spAutoFit/>
           </a:bodyPr>
           <a:lstStyle/>
@@ -9771,7 +9771,7 @@
           <a:noFill/>
         </p:spPr>
         <p:txBody>
-          <a:bodyPr wrap="none" lIns="0" rIns="0" tIns="0" bIns="0" anchor="t">
+          <a:bodyPr wrap="square" lIns="0" rIns="0" tIns="0" bIns="0" anchor="t">
             <a:spAutoFit/>
           </a:bodyPr>
           <a:lstStyle/>
@@ -9810,7 +9810,7 @@
           <a:noFill/>
         </p:spPr>
         <p:txBody>
-          <a:bodyPr wrap="none" lIns="0" rIns="0" tIns="0" bIns="0" anchor="t">
+          <a:bodyPr wrap="square" lIns="0" rIns="0" tIns="0" bIns="0" anchor="t">
             <a:spAutoFit/>
           </a:bodyPr>
           <a:lstStyle/>
@@ -9849,7 +9849,7 @@
           <a:noFill/>
         </p:spPr>
         <p:txBody>
-          <a:bodyPr wrap="none" lIns="0" rIns="0" tIns="0" bIns="0" anchor="t">
+          <a:bodyPr wrap="square" lIns="0" rIns="0" tIns="0" bIns="0" anchor="t">
             <a:spAutoFit/>
           </a:bodyPr>
           <a:lstStyle/>
@@ -9894,7 +9894,7 @@
           </a:ln>
         </p:spPr>
         <p:txBody>
-          <a:bodyPr wrap="none" lIns="114300" rIns="114300" tIns="57150" bIns="57150" anchor="t">
+          <a:bodyPr wrap="square" lIns="114300" rIns="114300" tIns="57150" bIns="57150" anchor="t">
             <a:spAutoFit/>
           </a:bodyPr>
           <a:lstStyle/>
@@ -9933,7 +9933,7 @@
           <a:noFill/>
         </p:spPr>
         <p:txBody>
-          <a:bodyPr wrap="none" lIns="0" rIns="0" tIns="0" bIns="0" anchor="t">
+          <a:bodyPr wrap="square" lIns="0" rIns="0" tIns="0" bIns="0" anchor="t">
             <a:spAutoFit/>
           </a:bodyPr>
           <a:lstStyle/>
@@ -9988,7 +9988,7 @@
           <a:noFill/>
         </p:spPr>
         <p:txBody>
-          <a:bodyPr wrap="none" lIns="0" rIns="0" tIns="0" bIns="0" anchor="t">
+          <a:bodyPr wrap="square" lIns="0" rIns="0" tIns="0" bIns="0" anchor="t">
             <a:spAutoFit/>
           </a:bodyPr>
           <a:lstStyle/>
@@ -10027,7 +10027,7 @@
           <a:noFill/>
         </p:spPr>
         <p:txBody>
-          <a:bodyPr wrap="none" lIns="0" rIns="0" tIns="0" bIns="0" anchor="t">
+          <a:bodyPr wrap="square" lIns="0" rIns="0" tIns="0" bIns="0" anchor="t">
             <a:spAutoFit/>
           </a:bodyPr>
           <a:lstStyle/>
@@ -10066,7 +10066,7 @@
           <a:noFill/>
         </p:spPr>
         <p:txBody>
-          <a:bodyPr wrap="none" lIns="0" rIns="0" tIns="0" bIns="0" anchor="t">
+          <a:bodyPr wrap="square" lIns="0" rIns="0" tIns="0" bIns="0" anchor="t">
             <a:spAutoFit/>
           </a:bodyPr>
           <a:lstStyle/>
@@ -10083,7 +10083,7 @@
                 </a:solidFill>
                 <a:latin typeface="Outfit"/>
               </a:rPr>
-              <a:t>Una forma incoerente e inaffidabile di</a:t>
+              <a:t>Una forma incoerente e inaffidabile di </a:t>
             </a:r>
           </a:p>
           <a:p>
@@ -10121,7 +10121,7 @@
           <a:noFill/>
         </p:spPr>
         <p:txBody>
-          <a:bodyPr wrap="none" lIns="0" rIns="0" tIns="0" bIns="0" anchor="t">
+          <a:bodyPr wrap="square" lIns="0" rIns="0" tIns="0" bIns="0" anchor="t">
             <a:spAutoFit/>
           </a:bodyPr>
           <a:lstStyle/>
@@ -10166,7 +10166,7 @@
           </a:ln>
         </p:spPr>
         <p:txBody>
-          <a:bodyPr wrap="none" lIns="114300" rIns="114300" tIns="57150" bIns="57150" anchor="t">
+          <a:bodyPr wrap="square" lIns="114300" rIns="114300" tIns="57150" bIns="57150" anchor="t">
             <a:spAutoFit/>
           </a:bodyPr>
           <a:lstStyle/>
@@ -10205,7 +10205,7 @@
           <a:noFill/>
         </p:spPr>
         <p:txBody>
-          <a:bodyPr wrap="none" lIns="0" rIns="0" tIns="0" bIns="0" anchor="t">
+          <a:bodyPr wrap="square" lIns="0" rIns="0" tIns="0" bIns="0" anchor="t">
             <a:spAutoFit/>
           </a:bodyPr>
           <a:lstStyle/>
@@ -10244,7 +10244,7 @@
           <a:noFill/>
         </p:spPr>
         <p:txBody>
-          <a:bodyPr wrap="none" lIns="0" rIns="0" tIns="0" bIns="0" anchor="t">
+          <a:bodyPr wrap="square" lIns="0" rIns="0" tIns="0" bIns="0" anchor="t">
             <a:spAutoFit/>
           </a:bodyPr>
           <a:lstStyle/>
@@ -10405,7 +10405,7 @@
           <a:noFill/>
         </p:spPr>
         <p:txBody>
-          <a:bodyPr wrap="none" lIns="0" rIns="0" tIns="0" bIns="0" anchor="t">
+          <a:bodyPr wrap="square" lIns="0" rIns="0" tIns="0" bIns="0" anchor="t">
             <a:spAutoFit/>
           </a:bodyPr>
           <a:lstStyle/>
@@ -10444,7 +10444,7 @@
           <a:noFill/>
         </p:spPr>
         <p:txBody>
-          <a:bodyPr wrap="none" lIns="0" rIns="0" tIns="0" bIns="0" anchor="t">
+          <a:bodyPr wrap="square" lIns="0" rIns="0" tIns="0" bIns="0" anchor="t">
             <a:spAutoFit/>
           </a:bodyPr>
           <a:lstStyle/>
@@ -10483,7 +10483,7 @@
           <a:noFill/>
         </p:spPr>
         <p:txBody>
-          <a:bodyPr wrap="none" lIns="0" rIns="0" tIns="0" bIns="0" anchor="t">
+          <a:bodyPr wrap="square" lIns="0" rIns="0" tIns="0" bIns="0" anchor="t">
             <a:spAutoFit/>
           </a:bodyPr>
           <a:lstStyle/>
@@ -10522,7 +10522,7 @@
           <a:noFill/>
         </p:spPr>
         <p:txBody>
-          <a:bodyPr wrap="none" lIns="0" rIns="0" tIns="0" bIns="0" anchor="t">
+          <a:bodyPr wrap="square" lIns="0" rIns="0" tIns="0" bIns="0" anchor="t">
             <a:spAutoFit/>
           </a:bodyPr>
           <a:lstStyle/>
@@ -10539,7 +10539,7 @@
                 </a:solidFill>
                 <a:latin typeface="Outfit"/>
               </a:rPr>
-              <a:t>Per ottenere il massimo dalla lezione di oggi, assicurati di avere il tuo</a:t>
+              <a:t>Per ottenere il massimo dalla lezione di oggi, assicurati di avere il tuo </a:t>
             </a:r>
           </a:p>
           <a:p>
@@ -10577,7 +10577,7 @@
           <a:noFill/>
         </p:spPr>
         <p:txBody>
-          <a:bodyPr wrap="none" lIns="0" rIns="0" tIns="0" bIns="0" anchor="t">
+          <a:bodyPr wrap="square" lIns="0" rIns="0" tIns="0" bIns="0" anchor="t">
             <a:spAutoFit/>
           </a:bodyPr>
           <a:lstStyle/>
@@ -10594,7 +10594,7 @@
                 </a:solidFill>
                 <a:latin typeface="Outfit"/>
               </a:rPr>
-              <a:t>Se non ce l'hai, vai su</a:t>
+              <a:t>Se non ce l'hai, vai su </a:t>
             </a:r>
             <a:r>
               <a:rPr sz="1400" b="1" i="0">
@@ -10625,7 +10625,7 @@
           <a:noFill/>
         </p:spPr>
         <p:txBody>
-          <a:bodyPr wrap="none" lIns="0" rIns="0" tIns="0" bIns="0" anchor="t">
+          <a:bodyPr wrap="square" lIns="0" rIns="0" tIns="0" bIns="0" anchor="t">
             <a:spAutoFit/>
           </a:bodyPr>
           <a:lstStyle/>
@@ -10664,7 +10664,7 @@
           <a:noFill/>
         </p:spPr>
         <p:txBody>
-          <a:bodyPr wrap="none" lIns="0" rIns="0" tIns="0" bIns="0" anchor="t">
+          <a:bodyPr wrap="square" lIns="0" rIns="0" tIns="0" bIns="0" anchor="t">
             <a:spAutoFit/>
           </a:bodyPr>
           <a:lstStyle/>
@@ -10887,7 +10887,7 @@
           <a:noFill/>
         </p:spPr>
         <p:txBody>
-          <a:bodyPr wrap="none" lIns="0" rIns="0" tIns="0" bIns="0" anchor="t">
+          <a:bodyPr wrap="square" lIns="0" rIns="0" tIns="0" bIns="0" anchor="t">
             <a:spAutoFit/>
           </a:bodyPr>
           <a:lstStyle/>
@@ -10926,7 +10926,7 @@
           <a:noFill/>
         </p:spPr>
         <p:txBody>
-          <a:bodyPr wrap="none" lIns="0" rIns="0" tIns="0" bIns="0" anchor="t">
+          <a:bodyPr wrap="square" lIns="0" rIns="0" tIns="0" bIns="0" anchor="t">
             <a:spAutoFit/>
           </a:bodyPr>
           <a:lstStyle/>
@@ -10965,7 +10965,7 @@
           <a:noFill/>
         </p:spPr>
         <p:txBody>
-          <a:bodyPr wrap="none" lIns="0" rIns="0" tIns="0" bIns="0" anchor="t">
+          <a:bodyPr wrap="square" lIns="0" rIns="0" tIns="0" bIns="0" anchor="t">
             <a:spAutoFit/>
           </a:bodyPr>
           <a:lstStyle/>
@@ -10982,7 +10982,7 @@
                 </a:solidFill>
                 <a:latin typeface="Outfit"/>
               </a:rPr>
-              <a:t>Il BG5 (Business Group 5) approfondisce proprio</a:t>
+              <a:t>Il BG5 (Business Group 5) approfondisce proprio </a:t>
             </a:r>
           </a:p>
           <a:p>
@@ -11020,7 +11020,7 @@
           <a:noFill/>
         </p:spPr>
         <p:txBody>
-          <a:bodyPr wrap="none" lIns="0" rIns="0" tIns="0" bIns="0" anchor="t">
+          <a:bodyPr wrap="square" lIns="0" rIns="0" tIns="0" bIns="0" anchor="t">
             <a:spAutoFit/>
           </a:bodyPr>
           <a:lstStyle/>
@@ -11059,7 +11059,7 @@
           <a:noFill/>
         </p:spPr>
         <p:txBody>
-          <a:bodyPr wrap="none" lIns="0" rIns="0" tIns="0" bIns="0" anchor="t">
+          <a:bodyPr wrap="square" lIns="0" rIns="0" tIns="0" bIns="0" anchor="t">
             <a:spAutoFit/>
           </a:bodyPr>
           <a:lstStyle/>
@@ -11098,7 +11098,7 @@
           <a:noFill/>
         </p:spPr>
         <p:txBody>
-          <a:bodyPr wrap="none" lIns="0" rIns="0" tIns="0" bIns="0" anchor="t">
+          <a:bodyPr wrap="square" lIns="0" rIns="0" tIns="0" bIns="0" anchor="t">
             <a:spAutoFit/>
           </a:bodyPr>
           <a:lstStyle/>
@@ -11137,7 +11137,7 @@
           <a:noFill/>
         </p:spPr>
         <p:txBody>
-          <a:bodyPr wrap="none" lIns="0" rIns="0" tIns="0" bIns="0" anchor="t">
+          <a:bodyPr wrap="square" lIns="0" rIns="0" tIns="0" bIns="0" anchor="t">
             <a:spAutoFit/>
           </a:bodyPr>
           <a:lstStyle/>
@@ -11274,7 +11274,7 @@
           <a:noFill/>
         </p:spPr>
         <p:txBody>
-          <a:bodyPr wrap="none" lIns="0" rIns="0" tIns="0" bIns="0" anchor="t">
+          <a:bodyPr wrap="square" lIns="0" rIns="0" tIns="0" bIns="0" anchor="t">
             <a:spAutoFit/>
           </a:bodyPr>
           <a:lstStyle/>
@@ -11313,7 +11313,7 @@
           <a:noFill/>
         </p:spPr>
         <p:txBody>
-          <a:bodyPr wrap="none" lIns="0" rIns="0" tIns="0" bIns="0" anchor="t">
+          <a:bodyPr wrap="square" lIns="0" rIns="0" tIns="0" bIns="0" anchor="t">
             <a:spAutoFit/>
           </a:bodyPr>
           <a:lstStyle/>
@@ -11354,7 +11354,7 @@
           </a:solidFill>
         </p:spPr>
         <p:txBody>
-          <a:bodyPr wrap="none" lIns="114300" rIns="114300" tIns="57150" bIns="57150" anchor="t">
+          <a:bodyPr wrap="square" lIns="114300" rIns="114300" tIns="57150" bIns="57150" anchor="t">
             <a:spAutoFit/>
           </a:bodyPr>
           <a:lstStyle/>
@@ -11393,7 +11393,7 @@
           <a:noFill/>
         </p:spPr>
         <p:txBody>
-          <a:bodyPr wrap="none" lIns="0" rIns="0" tIns="0" bIns="0" anchor="t">
+          <a:bodyPr wrap="square" lIns="0" rIns="0" tIns="0" bIns="0" anchor="t">
             <a:spAutoFit/>
           </a:bodyPr>
           <a:lstStyle/>
@@ -11410,7 +11410,7 @@
                 </a:solidFill>
                 <a:latin typeface="Outfit"/>
               </a:rPr>
-              <a:t>Stampa quattro copie della risorsa del corso, la trovi nella tua area riservata,</a:t>
+              <a:t>Stampa quattro copie della risorsa del corso, la trovi nella tua area riservata, </a:t>
             </a:r>
           </a:p>
           <a:p>
@@ -11448,7 +11448,7 @@
           <a:noFill/>
         </p:spPr>
         <p:txBody>
-          <a:bodyPr wrap="none" lIns="0" rIns="0" tIns="0" bIns="0" anchor="t">
+          <a:bodyPr wrap="square" lIns="0" rIns="0" tIns="0" bIns="0" anchor="t">
             <a:spAutoFit/>
           </a:bodyPr>
           <a:lstStyle/>
@@ -11487,7 +11487,7 @@
           <a:noFill/>
         </p:spPr>
         <p:txBody>
-          <a:bodyPr wrap="none" lIns="0" rIns="0" tIns="0" bIns="0" anchor="t">
+          <a:bodyPr wrap="square" lIns="0" rIns="0" tIns="0" bIns="0" anchor="t">
             <a:spAutoFit/>
           </a:bodyPr>
           <a:lstStyle/>
@@ -11522,7 +11522,7 @@
           <a:noFill/>
         </p:spPr>
         <p:txBody>
-          <a:bodyPr wrap="none" lIns="0" rIns="0" tIns="0" bIns="0" anchor="t">
+          <a:bodyPr wrap="square" lIns="0" rIns="0" tIns="0" bIns="0" anchor="t">
             <a:spAutoFit/>
           </a:bodyPr>
           <a:lstStyle/>
@@ -11561,7 +11561,7 @@
           <a:noFill/>
         </p:spPr>
         <p:txBody>
-          <a:bodyPr wrap="none" lIns="0" rIns="0" tIns="0" bIns="0" anchor="t">
+          <a:bodyPr wrap="square" lIns="0" rIns="0" tIns="0" bIns="0" anchor="t">
             <a:spAutoFit/>
           </a:bodyPr>
           <a:lstStyle/>
@@ -11596,7 +11596,7 @@
           <a:noFill/>
         </p:spPr>
         <p:txBody>
-          <a:bodyPr wrap="none" lIns="0" rIns="0" tIns="0" bIns="0" anchor="t">
+          <a:bodyPr wrap="square" lIns="0" rIns="0" tIns="0" bIns="0" anchor="t">
             <a:spAutoFit/>
           </a:bodyPr>
           <a:lstStyle/>
@@ -11635,7 +11635,7 @@
           <a:noFill/>
         </p:spPr>
         <p:txBody>
-          <a:bodyPr wrap="none" lIns="0" rIns="0" tIns="0" bIns="0" anchor="t">
+          <a:bodyPr wrap="square" lIns="0" rIns="0" tIns="0" bIns="0" anchor="t">
             <a:spAutoFit/>
           </a:bodyPr>
           <a:lstStyle/>
@@ -11670,7 +11670,7 @@
           <a:noFill/>
         </p:spPr>
         <p:txBody>
-          <a:bodyPr wrap="none" lIns="0" rIns="0" tIns="0" bIns="0" anchor="t">
+          <a:bodyPr wrap="square" lIns="0" rIns="0" tIns="0" bIns="0" anchor="t">
             <a:spAutoFit/>
           </a:bodyPr>
           <a:lstStyle/>
@@ -11709,7 +11709,7 @@
           <a:noFill/>
         </p:spPr>
         <p:txBody>
-          <a:bodyPr wrap="none" lIns="0" rIns="0" tIns="0" bIns="0" anchor="t">
+          <a:bodyPr wrap="square" lIns="0" rIns="0" tIns="0" bIns="0" anchor="t">
             <a:spAutoFit/>
           </a:bodyPr>
           <a:lstStyle/>
@@ -11744,7 +11744,7 @@
           <a:noFill/>
         </p:spPr>
         <p:txBody>
-          <a:bodyPr wrap="none" lIns="0" rIns="0" tIns="0" bIns="0" anchor="t">
+          <a:bodyPr wrap="square" lIns="0" rIns="0" tIns="0" bIns="0" anchor="t">
             <a:spAutoFit/>
           </a:bodyPr>
           <a:lstStyle/>
@@ -11761,7 +11761,7 @@
                 </a:solidFill>
                 <a:latin typeface="Outfit"/>
               </a:rPr>
-              <a:t>Carica le foto o le scansioni dei quattro grafici nel forum e commenta con le</a:t>
+              <a:t>Carica le foto o le scansioni dei quattro grafici nel forum e commenta con le </a:t>
             </a:r>
           </a:p>
           <a:p>
@@ -11799,7 +11799,7 @@
           <a:noFill/>
         </p:spPr>
         <p:txBody>
-          <a:bodyPr wrap="none" lIns="0" rIns="0" tIns="0" bIns="0" anchor="t">
+          <a:bodyPr wrap="square" lIns="0" rIns="0" tIns="0" bIns="0" anchor="t">
             <a:spAutoFit/>
           </a:bodyPr>
           <a:lstStyle/>
@@ -11838,7 +11838,7 @@
           <a:noFill/>
         </p:spPr>
         <p:txBody>
-          <a:bodyPr wrap="none" lIns="0" rIns="0" tIns="0" bIns="0" anchor="t">
+          <a:bodyPr wrap="square" lIns="0" rIns="0" tIns="0" bIns="0" anchor="t">
             <a:spAutoFit/>
           </a:bodyPr>
           <a:lstStyle/>
@@ -11877,7 +11877,7 @@
           <a:noFill/>
         </p:spPr>
         <p:txBody>
-          <a:bodyPr wrap="none" lIns="0" rIns="0" tIns="0" bIns="0" anchor="t">
+          <a:bodyPr wrap="square" lIns="0" rIns="0" tIns="0" bIns="0" anchor="t">
             <a:spAutoFit/>
           </a:bodyPr>
           <a:lstStyle/>
@@ -12038,7 +12038,7 @@
           <a:noFill/>
         </p:spPr>
         <p:txBody>
-          <a:bodyPr wrap="none" lIns="0" rIns="0" tIns="0" bIns="0" anchor="t">
+          <a:bodyPr wrap="square" lIns="0" rIns="0" tIns="0" bIns="0" anchor="t">
             <a:spAutoFit/>
           </a:bodyPr>
           <a:lstStyle/>
@@ -12077,7 +12077,7 @@
           <a:noFill/>
         </p:spPr>
         <p:txBody>
-          <a:bodyPr wrap="none" lIns="0" rIns="0" tIns="0" bIns="0" anchor="t">
+          <a:bodyPr wrap="square" lIns="0" rIns="0" tIns="0" bIns="0" anchor="t">
             <a:spAutoFit/>
           </a:bodyPr>
           <a:lstStyle/>
@@ -12116,7 +12116,7 @@
           <a:noFill/>
         </p:spPr>
         <p:txBody>
-          <a:bodyPr wrap="none" lIns="0" rIns="0" tIns="0" bIns="0" anchor="t">
+          <a:bodyPr wrap="square" lIns="0" rIns="0" tIns="0" bIns="0" anchor="t">
             <a:spAutoFit/>
           </a:bodyPr>
           <a:lstStyle/>
@@ -12157,7 +12157,7 @@
           </a:solidFill>
         </p:spPr>
         <p:txBody>
-          <a:bodyPr wrap="none" lIns="114300" rIns="114300" tIns="57150" bIns="57150" anchor="t">
+          <a:bodyPr wrap="square" lIns="114300" rIns="114300" tIns="57150" bIns="57150" anchor="t">
             <a:spAutoFit/>
           </a:bodyPr>
           <a:lstStyle/>
@@ -12196,7 +12196,7 @@
           <a:noFill/>
         </p:spPr>
         <p:txBody>
-          <a:bodyPr wrap="none" lIns="0" rIns="0" tIns="0" bIns="0" anchor="t">
+          <a:bodyPr wrap="square" lIns="0" rIns="0" tIns="0" bIns="0" anchor="t">
             <a:spAutoFit/>
           </a:bodyPr>
           <a:lstStyle/>
@@ -12213,7 +12213,7 @@
                 </a:solidFill>
                 <a:latin typeface="Outfit"/>
               </a:rPr>
-              <a:t>Prendi una penna nera, una rossa e una del</a:t>
+              <a:t>Prendi una penna nera, una rossa e una del </a:t>
             </a:r>
           </a:p>
           <a:p>
@@ -12251,7 +12251,7 @@
           <a:noFill/>
         </p:spPr>
         <p:txBody>
-          <a:bodyPr wrap="none" lIns="0" rIns="0" tIns="0" bIns="0" anchor="t">
+          <a:bodyPr wrap="square" lIns="0" rIns="0" tIns="0" bIns="0" anchor="t">
             <a:spAutoFit/>
           </a:bodyPr>
           <a:lstStyle/>
@@ -12286,7 +12286,7 @@
           <a:noFill/>
         </p:spPr>
         <p:txBody>
-          <a:bodyPr wrap="none" lIns="0" rIns="0" tIns="0" bIns="0" anchor="t">
+          <a:bodyPr wrap="square" lIns="0" rIns="0" tIns="0" bIns="0" anchor="t">
             <a:spAutoFit/>
           </a:bodyPr>
           <a:lstStyle/>
@@ -12303,7 +12303,7 @@
                 </a:solidFill>
                 <a:latin typeface="Outfit"/>
               </a:rPr>
-              <a:t>Guarda le porte del tuo Disegno, sia rosse che</a:t>
+              <a:t>Guarda le porte del tuo Disegno, sia rosse che </a:t>
             </a:r>
           </a:p>
           <a:p>
@@ -12341,7 +12341,7 @@
           <a:noFill/>
         </p:spPr>
         <p:txBody>
-          <a:bodyPr wrap="none" lIns="0" rIns="0" tIns="0" bIns="0" anchor="t">
+          <a:bodyPr wrap="square" lIns="0" rIns="0" tIns="0" bIns="0" anchor="t">
             <a:spAutoFit/>
           </a:bodyPr>
           <a:lstStyle/>
@@ -12376,7 +12376,7 @@
           <a:noFill/>
         </p:spPr>
         <p:txBody>
-          <a:bodyPr wrap="none" lIns="0" rIns="0" tIns="0" bIns="0" anchor="t">
+          <a:bodyPr wrap="square" lIns="0" rIns="0" tIns="0" bIns="0" anchor="t">
             <a:spAutoFit/>
           </a:bodyPr>
           <a:lstStyle/>
@@ -12415,7 +12415,7 @@
           <a:noFill/>
         </p:spPr>
         <p:txBody>
-          <a:bodyPr wrap="none" lIns="0" rIns="0" tIns="0" bIns="0" anchor="t">
+          <a:bodyPr wrap="square" lIns="0" rIns="0" tIns="0" bIns="0" anchor="t">
             <a:spAutoFit/>
           </a:bodyPr>
           <a:lstStyle/>
@@ -12450,7 +12450,7 @@
           <a:noFill/>
         </p:spPr>
         <p:txBody>
-          <a:bodyPr wrap="none" lIns="0" rIns="0" tIns="0" bIns="0" anchor="t">
+          <a:bodyPr wrap="square" lIns="0" rIns="0" tIns="0" bIns="0" anchor="t">
             <a:spAutoFit/>
           </a:bodyPr>
           <a:lstStyle/>
@@ -12467,7 +12467,7 @@
                 </a:solidFill>
                 <a:latin typeface="Outfit"/>
               </a:rPr>
-              <a:t>Colora col terzo colore i centri che si</a:t>
+              <a:t>Colora col terzo colore i centri che si </a:t>
             </a:r>
           </a:p>
           <a:p>
@@ -12505,7 +12505,7 @@
           <a:noFill/>
         </p:spPr>
         <p:txBody>
-          <a:bodyPr wrap="none" lIns="0" rIns="0" tIns="0" bIns="0" anchor="t">
+          <a:bodyPr wrap="square" lIns="0" rIns="0" tIns="0" bIns="0" anchor="t">
             <a:spAutoFit/>
           </a:bodyPr>
           <a:lstStyle/>
@@ -12540,7 +12540,7 @@
           <a:noFill/>
         </p:spPr>
         <p:txBody>
-          <a:bodyPr wrap="none" lIns="0" rIns="0" tIns="0" bIns="0" anchor="t">
+          <a:bodyPr wrap="square" lIns="0" rIns="0" tIns="0" bIns="0" anchor="t">
             <a:spAutoFit/>
           </a:bodyPr>
           <a:lstStyle/>
@@ -12557,7 +12557,7 @@
                 </a:solidFill>
                 <a:latin typeface="Outfit"/>
               </a:rPr>
-              <a:t>Verifica che il Disegno combaci con quello di</a:t>
+              <a:t>Verifica che il Disegno combaci con quello di </a:t>
             </a:r>
           </a:p>
           <a:p>
@@ -12595,7 +12595,7 @@
           <a:noFill/>
         </p:spPr>
         <p:txBody>
-          <a:bodyPr wrap="none" lIns="0" rIns="0" tIns="0" bIns="0" anchor="t">
+          <a:bodyPr wrap="square" lIns="0" rIns="0" tIns="0" bIns="0" anchor="t">
             <a:spAutoFit/>
           </a:bodyPr>
           <a:lstStyle/>
@@ -12630,7 +12630,7 @@
           <a:noFill/>
         </p:spPr>
         <p:txBody>
-          <a:bodyPr wrap="none" lIns="0" rIns="0" tIns="0" bIns="0" anchor="t">
+          <a:bodyPr wrap="square" lIns="0" rIns="0" tIns="0" bIns="0" anchor="t">
             <a:spAutoFit/>
           </a:bodyPr>
           <a:lstStyle/>
@@ -12669,7 +12669,7 @@
           <a:noFill/>
         </p:spPr>
         <p:txBody>
-          <a:bodyPr wrap="none" lIns="0" rIns="0" tIns="0" bIns="0" anchor="t">
+          <a:bodyPr wrap="square" lIns="0" rIns="0" tIns="0" bIns="0" anchor="t">
             <a:spAutoFit/>
           </a:bodyPr>
           <a:lstStyle/>
@@ -12708,7 +12708,7 @@
           <a:noFill/>
         </p:spPr>
         <p:txBody>
-          <a:bodyPr wrap="none" lIns="0" rIns="0" tIns="0" bIns="0" anchor="t">
+          <a:bodyPr wrap="square" lIns="0" rIns="0" tIns="0" bIns="0" anchor="t">
             <a:spAutoFit/>
           </a:bodyPr>
           <a:lstStyle/>
@@ -12869,7 +12869,7 @@
           <a:noFill/>
         </p:spPr>
         <p:txBody>
-          <a:bodyPr wrap="none" lIns="0" rIns="0" tIns="0" bIns="0" anchor="t">
+          <a:bodyPr wrap="square" lIns="0" rIns="0" tIns="0" bIns="0" anchor="t">
             <a:spAutoFit/>
           </a:bodyPr>
           <a:lstStyle/>
@@ -12908,7 +12908,7 @@
           <a:noFill/>
         </p:spPr>
         <p:txBody>
-          <a:bodyPr wrap="none" lIns="0" rIns="0" tIns="0" bIns="0" anchor="t">
+          <a:bodyPr wrap="square" lIns="0" rIns="0" tIns="0" bIns="0" anchor="t">
             <a:spAutoFit/>
           </a:bodyPr>
           <a:lstStyle/>
@@ -12947,7 +12947,7 @@
           <a:noFill/>
         </p:spPr>
         <p:txBody>
-          <a:bodyPr wrap="none" lIns="0" rIns="0" tIns="0" bIns="0" anchor="t">
+          <a:bodyPr wrap="square" lIns="0" rIns="0" tIns="0" bIns="0" anchor="t">
             <a:spAutoFit/>
           </a:bodyPr>
           <a:lstStyle/>
@@ -12988,7 +12988,7 @@
           </a:solidFill>
         </p:spPr>
         <p:txBody>
-          <a:bodyPr wrap="none" lIns="114300" rIns="114300" tIns="57150" bIns="57150" anchor="t">
+          <a:bodyPr wrap="square" lIns="114300" rIns="114300" tIns="57150" bIns="57150" anchor="t">
             <a:spAutoFit/>
           </a:bodyPr>
           <a:lstStyle/>
@@ -13027,7 +13027,7 @@
           <a:noFill/>
         </p:spPr>
         <p:txBody>
-          <a:bodyPr wrap="none" lIns="0" rIns="0" tIns="0" bIns="0" anchor="t">
+          <a:bodyPr wrap="square" lIns="0" rIns="0" tIns="0" bIns="0" anchor="t">
             <a:spAutoFit/>
           </a:bodyPr>
           <a:lstStyle/>
@@ -13066,7 +13066,7 @@
           <a:noFill/>
         </p:spPr>
         <p:txBody>
-          <a:bodyPr wrap="none" lIns="0" rIns="0" tIns="0" bIns="0" anchor="t">
+          <a:bodyPr wrap="square" lIns="0" rIns="0" tIns="0" bIns="0" anchor="t">
             <a:spAutoFit/>
           </a:bodyPr>
           <a:lstStyle/>
@@ -13101,7 +13101,7 @@
           <a:noFill/>
         </p:spPr>
         <p:txBody>
-          <a:bodyPr wrap="none" lIns="0" rIns="0" tIns="0" bIns="0" anchor="t">
+          <a:bodyPr wrap="square" lIns="0" rIns="0" tIns="0" bIns="0" anchor="t">
             <a:spAutoFit/>
           </a:bodyPr>
           <a:lstStyle/>
@@ -13118,7 +13118,7 @@
                 </a:solidFill>
                 <a:latin typeface="Outfit"/>
               </a:rPr>
-              <a:t>Guarda le porte rosse del tuo Disegno e</a:t>
+              <a:t>Guarda le porte rosse del tuo Disegno e </a:t>
             </a:r>
           </a:p>
           <a:p>
@@ -13156,7 +13156,7 @@
           <a:noFill/>
         </p:spPr>
         <p:txBody>
-          <a:bodyPr wrap="none" lIns="0" rIns="0" tIns="0" bIns="0" anchor="t">
+          <a:bodyPr wrap="square" lIns="0" rIns="0" tIns="0" bIns="0" anchor="t">
             <a:spAutoFit/>
           </a:bodyPr>
           <a:lstStyle/>
@@ -13191,7 +13191,7 @@
           <a:noFill/>
         </p:spPr>
         <p:txBody>
-          <a:bodyPr wrap="none" lIns="0" rIns="0" tIns="0" bIns="0" anchor="t">
+          <a:bodyPr wrap="square" lIns="0" rIns="0" tIns="0" bIns="0" anchor="t">
             <a:spAutoFit/>
           </a:bodyPr>
           <a:lstStyle/>
@@ -13230,7 +13230,7 @@
           <a:noFill/>
         </p:spPr>
         <p:txBody>
-          <a:bodyPr wrap="none" lIns="0" rIns="0" tIns="0" bIns="0" anchor="t">
+          <a:bodyPr wrap="square" lIns="0" rIns="0" tIns="0" bIns="0" anchor="t">
             <a:spAutoFit/>
           </a:bodyPr>
           <a:lstStyle/>
@@ -13265,7 +13265,7 @@
           <a:noFill/>
         </p:spPr>
         <p:txBody>
-          <a:bodyPr wrap="none" lIns="0" rIns="0" tIns="0" bIns="0" anchor="t">
+          <a:bodyPr wrap="square" lIns="0" rIns="0" tIns="0" bIns="0" anchor="t">
             <a:spAutoFit/>
           </a:bodyPr>
           <a:lstStyle/>
@@ -13282,7 +13282,7 @@
                 </a:solidFill>
                 <a:latin typeface="Outfit"/>
               </a:rPr>
-              <a:t>Colora gli eventuali centri che si definiscono</a:t>
+              <a:t>Colora gli eventuali centri che si definiscono </a:t>
             </a:r>
           </a:p>
           <a:p>
@@ -13320,7 +13320,7 @@
           <a:noFill/>
         </p:spPr>
         <p:txBody>
-          <a:bodyPr wrap="none" lIns="0" rIns="0" tIns="0" bIns="0" anchor="t">
+          <a:bodyPr wrap="square" lIns="0" rIns="0" tIns="0" bIns="0" anchor="t">
             <a:spAutoFit/>
           </a:bodyPr>
           <a:lstStyle/>
@@ -13355,7 +13355,7 @@
           <a:noFill/>
         </p:spPr>
         <p:txBody>
-          <a:bodyPr wrap="none" lIns="0" rIns="0" tIns="0" bIns="0" anchor="t">
+          <a:bodyPr wrap="square" lIns="0" rIns="0" tIns="0" bIns="0" anchor="t">
             <a:spAutoFit/>
           </a:bodyPr>
           <a:lstStyle/>
@@ -13372,7 +13372,7 @@
                 </a:solidFill>
                 <a:latin typeface="Playfair Display"/>
               </a:rPr>
-              <a:t>Questa è la mappa genetica del tuo</a:t>
+              <a:t>Questa è la mappa genetica del tuo </a:t>
             </a:r>
           </a:p>
           <a:p>
@@ -13410,7 +13410,7 @@
           <a:noFill/>
         </p:spPr>
         <p:txBody>
-          <a:bodyPr wrap="none" lIns="0" rIns="0" tIns="0" bIns="0" anchor="t">
+          <a:bodyPr wrap="square" lIns="0" rIns="0" tIns="0" bIns="0" anchor="t">
             <a:spAutoFit/>
           </a:bodyPr>
           <a:lstStyle/>
@@ -13449,7 +13449,7 @@
           <a:noFill/>
         </p:spPr>
         <p:txBody>
-          <a:bodyPr wrap="none" lIns="0" rIns="0" tIns="0" bIns="0" anchor="t">
+          <a:bodyPr wrap="square" lIns="0" rIns="0" tIns="0" bIns="0" anchor="t">
             <a:spAutoFit/>
           </a:bodyPr>
           <a:lstStyle/>
@@ -13488,7 +13488,7 @@
           <a:noFill/>
         </p:spPr>
         <p:txBody>
-          <a:bodyPr wrap="none" lIns="0" rIns="0" tIns="0" bIns="0" anchor="t">
+          <a:bodyPr wrap="square" lIns="0" rIns="0" tIns="0" bIns="0" anchor="t">
             <a:spAutoFit/>
           </a:bodyPr>
           <a:lstStyle/>
@@ -13649,7 +13649,7 @@
           <a:noFill/>
         </p:spPr>
         <p:txBody>
-          <a:bodyPr wrap="none" lIns="0" rIns="0" tIns="0" bIns="0" anchor="t">
+          <a:bodyPr wrap="square" lIns="0" rIns="0" tIns="0" bIns="0" anchor="t">
             <a:spAutoFit/>
           </a:bodyPr>
           <a:lstStyle/>
@@ -13688,7 +13688,7 @@
           <a:noFill/>
         </p:spPr>
         <p:txBody>
-          <a:bodyPr wrap="none" lIns="0" rIns="0" tIns="0" bIns="0" anchor="t">
+          <a:bodyPr wrap="square" lIns="0" rIns="0" tIns="0" bIns="0" anchor="t">
             <a:spAutoFit/>
           </a:bodyPr>
           <a:lstStyle/>
@@ -13727,7 +13727,7 @@
           <a:noFill/>
         </p:spPr>
         <p:txBody>
-          <a:bodyPr wrap="none" lIns="0" rIns="0" tIns="0" bIns="0" anchor="t">
+          <a:bodyPr wrap="square" lIns="0" rIns="0" tIns="0" bIns="0" anchor="t">
             <a:spAutoFit/>
           </a:bodyPr>
           <a:lstStyle/>
@@ -13768,7 +13768,7 @@
           </a:solidFill>
         </p:spPr>
         <p:txBody>
-          <a:bodyPr wrap="none" lIns="114300" rIns="114300" tIns="57150" bIns="57150" anchor="t">
+          <a:bodyPr wrap="square" lIns="114300" rIns="114300" tIns="57150" bIns="57150" anchor="t">
             <a:spAutoFit/>
           </a:bodyPr>
           <a:lstStyle/>
@@ -13807,7 +13807,7 @@
           <a:noFill/>
         </p:spPr>
         <p:txBody>
-          <a:bodyPr wrap="none" lIns="0" rIns="0" tIns="0" bIns="0" anchor="t">
+          <a:bodyPr wrap="square" lIns="0" rIns="0" tIns="0" bIns="0" anchor="t">
             <a:spAutoFit/>
           </a:bodyPr>
           <a:lstStyle/>
@@ -13846,7 +13846,7 @@
           <a:noFill/>
         </p:spPr>
         <p:txBody>
-          <a:bodyPr wrap="none" lIns="0" rIns="0" tIns="0" bIns="0" anchor="t">
+          <a:bodyPr wrap="square" lIns="0" rIns="0" tIns="0" bIns="0" anchor="t">
             <a:spAutoFit/>
           </a:bodyPr>
           <a:lstStyle/>
@@ -13881,7 +13881,7 @@
           <a:noFill/>
         </p:spPr>
         <p:txBody>
-          <a:bodyPr wrap="none" lIns="0" rIns="0" tIns="0" bIns="0" anchor="t">
+          <a:bodyPr wrap="square" lIns="0" rIns="0" tIns="0" bIns="0" anchor="t">
             <a:spAutoFit/>
           </a:bodyPr>
           <a:lstStyle/>
@@ -13898,7 +13898,7 @@
                 </a:solidFill>
                 <a:latin typeface="Outfit"/>
               </a:rPr>
-              <a:t>Guarda le porte nere del tuo Disegno e</a:t>
+              <a:t>Guarda le porte nere del tuo Disegno e </a:t>
             </a:r>
           </a:p>
           <a:p>
@@ -13936,7 +13936,7 @@
           <a:noFill/>
         </p:spPr>
         <p:txBody>
-          <a:bodyPr wrap="none" lIns="0" rIns="0" tIns="0" bIns="0" anchor="t">
+          <a:bodyPr wrap="square" lIns="0" rIns="0" tIns="0" bIns="0" anchor="t">
             <a:spAutoFit/>
           </a:bodyPr>
           <a:lstStyle/>
@@ -13971,7 +13971,7 @@
           <a:noFill/>
         </p:spPr>
         <p:txBody>
-          <a:bodyPr wrap="none" lIns="0" rIns="0" tIns="0" bIns="0" anchor="t">
+          <a:bodyPr wrap="square" lIns="0" rIns="0" tIns="0" bIns="0" anchor="t">
             <a:spAutoFit/>
           </a:bodyPr>
           <a:lstStyle/>
@@ -14010,7 +14010,7 @@
           <a:noFill/>
         </p:spPr>
         <p:txBody>
-          <a:bodyPr wrap="none" lIns="0" rIns="0" tIns="0" bIns="0" anchor="t">
+          <a:bodyPr wrap="square" lIns="0" rIns="0" tIns="0" bIns="0" anchor="t">
             <a:spAutoFit/>
           </a:bodyPr>
           <a:lstStyle/>
@@ -14045,7 +14045,7 @@
           <a:noFill/>
         </p:spPr>
         <p:txBody>
-          <a:bodyPr wrap="none" lIns="0" rIns="0" tIns="0" bIns="0" anchor="t">
+          <a:bodyPr wrap="square" lIns="0" rIns="0" tIns="0" bIns="0" anchor="t">
             <a:spAutoFit/>
           </a:bodyPr>
           <a:lstStyle/>
@@ -14062,7 +14062,7 @@
                 </a:solidFill>
                 <a:latin typeface="Outfit"/>
               </a:rPr>
-              <a:t>Colora gli eventuali centri che si definiscono</a:t>
+              <a:t>Colora gli eventuali centri che si definiscono </a:t>
             </a:r>
           </a:p>
           <a:p>
@@ -14100,7 +14100,7 @@
           <a:noFill/>
         </p:spPr>
         <p:txBody>
-          <a:bodyPr wrap="none" lIns="0" rIns="0" tIns="0" bIns="0" anchor="t">
+          <a:bodyPr wrap="square" lIns="0" rIns="0" tIns="0" bIns="0" anchor="t">
             <a:spAutoFit/>
           </a:bodyPr>
           <a:lstStyle/>
@@ -14135,7 +14135,7 @@
           <a:noFill/>
         </p:spPr>
         <p:txBody>
-          <a:bodyPr wrap="none" lIns="0" rIns="0" tIns="0" bIns="0" anchor="t">
+          <a:bodyPr wrap="square" lIns="0" rIns="0" tIns="0" bIns="0" anchor="t">
             <a:spAutoFit/>
           </a:bodyPr>
           <a:lstStyle/>
@@ -14152,7 +14152,7 @@
                 </a:solidFill>
                 <a:latin typeface="Playfair Display"/>
               </a:rPr>
-              <a:t>Questa è la mappa della tua personalità</a:t>
+              <a:t>Questa è la mappa della tua personalità </a:t>
             </a:r>
           </a:p>
           <a:p>
@@ -14190,7 +14190,7 @@
           <a:noFill/>
         </p:spPr>
         <p:txBody>
-          <a:bodyPr wrap="none" lIns="0" rIns="0" tIns="0" bIns="0" anchor="t">
+          <a:bodyPr wrap="square" lIns="0" rIns="0" tIns="0" bIns="0" anchor="t">
             <a:spAutoFit/>
           </a:bodyPr>
           <a:lstStyle/>
@@ -14229,7 +14229,7 @@
           <a:noFill/>
         </p:spPr>
         <p:txBody>
-          <a:bodyPr wrap="none" lIns="0" rIns="0" tIns="0" bIns="0" anchor="t">
+          <a:bodyPr wrap="square" lIns="0" rIns="0" tIns="0" bIns="0" anchor="t">
             <a:spAutoFit/>
           </a:bodyPr>
           <a:lstStyle/>
@@ -14268,7 +14268,7 @@
           <a:noFill/>
         </p:spPr>
         <p:txBody>
-          <a:bodyPr wrap="none" lIns="0" rIns="0" tIns="0" bIns="0" anchor="t">
+          <a:bodyPr wrap="square" lIns="0" rIns="0" tIns="0" bIns="0" anchor="t">
             <a:spAutoFit/>
           </a:bodyPr>
           <a:lstStyle/>
@@ -14429,7 +14429,7 @@
           <a:noFill/>
         </p:spPr>
         <p:txBody>
-          <a:bodyPr wrap="none" lIns="0" rIns="0" tIns="0" bIns="0" anchor="t">
+          <a:bodyPr wrap="square" lIns="0" rIns="0" tIns="0" bIns="0" anchor="t">
             <a:spAutoFit/>
           </a:bodyPr>
           <a:lstStyle/>
@@ -14468,7 +14468,7 @@
           <a:noFill/>
         </p:spPr>
         <p:txBody>
-          <a:bodyPr wrap="none" lIns="0" rIns="0" tIns="0" bIns="0" anchor="t">
+          <a:bodyPr wrap="square" lIns="0" rIns="0" tIns="0" bIns="0" anchor="t">
             <a:spAutoFit/>
           </a:bodyPr>
           <a:lstStyle/>
@@ -14507,7 +14507,7 @@
           <a:noFill/>
         </p:spPr>
         <p:txBody>
-          <a:bodyPr wrap="none" lIns="0" rIns="0" tIns="0" bIns="0" anchor="t">
+          <a:bodyPr wrap="square" lIns="0" rIns="0" tIns="0" bIns="0" anchor="t">
             <a:spAutoFit/>
           </a:bodyPr>
           <a:lstStyle/>
@@ -14548,7 +14548,7 @@
           </a:solidFill>
         </p:spPr>
         <p:txBody>
-          <a:bodyPr wrap="none" lIns="114300" rIns="114300" tIns="57150" bIns="57150" anchor="t">
+          <a:bodyPr wrap="square" lIns="114300" rIns="114300" tIns="57150" bIns="57150" anchor="t">
             <a:spAutoFit/>
           </a:bodyPr>
           <a:lstStyle/>
@@ -14587,7 +14587,7 @@
           <a:noFill/>
         </p:spPr>
         <p:txBody>
-          <a:bodyPr wrap="none" lIns="0" rIns="0" tIns="0" bIns="0" anchor="t">
+          <a:bodyPr wrap="square" lIns="0" rIns="0" tIns="0" bIns="0" anchor="t">
             <a:spAutoFit/>
           </a:bodyPr>
           <a:lstStyle/>
@@ -14626,7 +14626,7 @@
           <a:noFill/>
         </p:spPr>
         <p:txBody>
-          <a:bodyPr wrap="none" lIns="0" rIns="0" tIns="0" bIns="0" anchor="t">
+          <a:bodyPr wrap="square" lIns="0" rIns="0" tIns="0" bIns="0" anchor="t">
             <a:spAutoFit/>
           </a:bodyPr>
           <a:lstStyle/>
@@ -14661,7 +14661,7 @@
           <a:noFill/>
         </p:spPr>
         <p:txBody>
-          <a:bodyPr wrap="none" lIns="0" rIns="0" tIns="0" bIns="0" anchor="t">
+          <a:bodyPr wrap="square" lIns="0" rIns="0" tIns="0" bIns="0" anchor="t">
             <a:spAutoFit/>
           </a:bodyPr>
           <a:lstStyle/>
@@ -14678,7 +14678,7 @@
                 </a:solidFill>
                 <a:latin typeface="Outfit"/>
               </a:rPr>
-              <a:t>Guarda le porte che nel tuo Disegno</a:t>
+              <a:t>Guarda le porte che nel tuo Disegno </a:t>
             </a:r>
             <a:r>
               <a:rPr sz="1400" b="0" i="0">
@@ -14696,7 +14696,7 @@
                 </a:solidFill>
                 <a:latin typeface="Outfit"/>
               </a:rPr>
-              <a:t>sono</a:t>
+              <a:t> sono </a:t>
             </a:r>
           </a:p>
           <a:p>
@@ -14734,7 +14734,7 @@
           <a:noFill/>
         </p:spPr>
         <p:txBody>
-          <a:bodyPr wrap="none" lIns="0" rIns="0" tIns="0" bIns="0" anchor="t">
+          <a:bodyPr wrap="square" lIns="0" rIns="0" tIns="0" bIns="0" anchor="t">
             <a:spAutoFit/>
           </a:bodyPr>
           <a:lstStyle/>
@@ -14769,7 +14769,7 @@
           <a:noFill/>
         </p:spPr>
         <p:txBody>
-          <a:bodyPr wrap="none" lIns="0" rIns="0" tIns="0" bIns="0" anchor="t">
+          <a:bodyPr wrap="square" lIns="0" rIns="0" tIns="0" bIns="0" anchor="t">
             <a:spAutoFit/>
           </a:bodyPr>
           <a:lstStyle/>
@@ -14808,7 +14808,7 @@
           <a:noFill/>
         </p:spPr>
         <p:txBody>
-          <a:bodyPr wrap="none" lIns="0" rIns="0" tIns="0" bIns="0" anchor="t">
+          <a:bodyPr wrap="square" lIns="0" rIns="0" tIns="0" bIns="0" anchor="t">
             <a:spAutoFit/>
           </a:bodyPr>
           <a:lstStyle/>
@@ -14843,7 +14843,7 @@
           <a:noFill/>
         </p:spPr>
         <p:txBody>
-          <a:bodyPr wrap="none" lIns="0" rIns="0" tIns="0" bIns="0" anchor="t">
+          <a:bodyPr wrap="square" lIns="0" rIns="0" tIns="0" bIns="0" anchor="t">
             <a:spAutoFit/>
           </a:bodyPr>
           <a:lstStyle/>
@@ -14860,7 +14860,7 @@
                 </a:solidFill>
                 <a:latin typeface="Outfit"/>
               </a:rPr>
-              <a:t>Colora gli eventuali centri che si definiscono</a:t>
+              <a:t>Colora gli eventuali centri che si definiscono </a:t>
             </a:r>
           </a:p>
           <a:p>
@@ -14898,7 +14898,7 @@
           <a:noFill/>
         </p:spPr>
         <p:txBody>
-          <a:bodyPr wrap="none" lIns="0" rIns="0" tIns="0" bIns="0" anchor="t">
+          <a:bodyPr wrap="square" lIns="0" rIns="0" tIns="0" bIns="0" anchor="t">
             <a:spAutoFit/>
           </a:bodyPr>
           <a:lstStyle/>
@@ -14933,7 +14933,7 @@
           <a:noFill/>
         </p:spPr>
         <p:txBody>
-          <a:bodyPr wrap="none" lIns="0" rIns="0" tIns="0" bIns="0" anchor="t">
+          <a:bodyPr wrap="square" lIns="0" rIns="0" tIns="0" bIns="0" anchor="t">
             <a:spAutoFit/>
           </a:bodyPr>
           <a:lstStyle/>
@@ -14950,7 +14950,7 @@
                 </a:solidFill>
                 <a:latin typeface="Playfair Display"/>
               </a:rPr>
-              <a:t>Questo è ciò che non è la tua natura, ed è</a:t>
+              <a:t>Questo è ciò che non è la tua natura, ed è </a:t>
             </a:r>
           </a:p>
           <a:p>
@@ -14988,7 +14988,7 @@
           <a:noFill/>
         </p:spPr>
         <p:txBody>
-          <a:bodyPr wrap="none" lIns="0" rIns="0" tIns="0" bIns="0" anchor="t">
+          <a:bodyPr wrap="square" lIns="0" rIns="0" tIns="0" bIns="0" anchor="t">
             <a:spAutoFit/>
           </a:bodyPr>
           <a:lstStyle/>
@@ -15027,7 +15027,7 @@
           <a:noFill/>
         </p:spPr>
         <p:txBody>
-          <a:bodyPr wrap="none" lIns="0" rIns="0" tIns="0" bIns="0" anchor="t">
+          <a:bodyPr wrap="square" lIns="0" rIns="0" tIns="0" bIns="0" anchor="t">
             <a:spAutoFit/>
           </a:bodyPr>
           <a:lstStyle/>
@@ -15066,7 +15066,7 @@
           <a:noFill/>
         </p:spPr>
         <p:txBody>
-          <a:bodyPr wrap="none" lIns="0" rIns="0" tIns="0" bIns="0" anchor="t">
+          <a:bodyPr wrap="square" lIns="0" rIns="0" tIns="0" bIns="0" anchor="t">
             <a:spAutoFit/>
           </a:bodyPr>
           <a:lstStyle/>
@@ -15222,7 +15222,7 @@
           <a:noFill/>
         </p:spPr>
         <p:txBody>
-          <a:bodyPr wrap="none" lIns="0" rIns="0" tIns="0" bIns="0" anchor="t">
+          <a:bodyPr wrap="square" lIns="0" rIns="0" tIns="0" bIns="0" anchor="t">
             <a:spAutoFit/>
           </a:bodyPr>
           <a:lstStyle/>
@@ -15261,7 +15261,7 @@
           <a:noFill/>
         </p:spPr>
         <p:txBody>
-          <a:bodyPr wrap="none" lIns="0" rIns="0" tIns="0" bIns="0" anchor="t">
+          <a:bodyPr wrap="square" lIns="0" rIns="0" tIns="0" bIns="0" anchor="t">
             <a:spAutoFit/>
           </a:bodyPr>
           <a:lstStyle/>
@@ -15316,7 +15316,7 @@
           <a:noFill/>
         </p:spPr>
         <p:txBody>
-          <a:bodyPr wrap="none" lIns="0" rIns="0" tIns="0" bIns="0" anchor="t">
+          <a:bodyPr wrap="square" lIns="0" rIns="0" tIns="0" bIns="0" anchor="t">
             <a:spAutoFit/>
           </a:bodyPr>
           <a:lstStyle/>
@@ -15355,7 +15355,7 @@
           <a:noFill/>
         </p:spPr>
         <p:txBody>
-          <a:bodyPr wrap="none" lIns="0" rIns="0" tIns="0" bIns="0" anchor="t">
+          <a:bodyPr wrap="square" lIns="0" rIns="0" tIns="0" bIns="0" anchor="t">
             <a:spAutoFit/>
           </a:bodyPr>
           <a:lstStyle/>
@@ -15394,7 +15394,7 @@
           <a:noFill/>
         </p:spPr>
         <p:txBody>
-          <a:bodyPr wrap="none" lIns="0" rIns="0" tIns="0" bIns="0" anchor="t">
+          <a:bodyPr wrap="square" lIns="0" rIns="0" tIns="0" bIns="0" anchor="t">
             <a:spAutoFit/>
           </a:bodyPr>
           <a:lstStyle/>
@@ -15679,7 +15679,7 @@
           <a:noFill/>
         </p:spPr>
         <p:txBody>
-          <a:bodyPr wrap="none" lIns="0" rIns="0" tIns="0" bIns="0" anchor="t">
+          <a:bodyPr wrap="square" lIns="0" rIns="0" tIns="0" bIns="0" anchor="t">
             <a:spAutoFit/>
           </a:bodyPr>
           <a:lstStyle/>
@@ -15718,7 +15718,7 @@
           <a:noFill/>
         </p:spPr>
         <p:txBody>
-          <a:bodyPr wrap="none" lIns="0" rIns="0" tIns="0" bIns="0" anchor="t">
+          <a:bodyPr wrap="square" lIns="0" rIns="0" tIns="0" bIns="0" anchor="t">
             <a:spAutoFit/>
           </a:bodyPr>
           <a:lstStyle/>
@@ -15757,7 +15757,7 @@
           <a:noFill/>
         </p:spPr>
         <p:txBody>
-          <a:bodyPr wrap="none" lIns="0" rIns="0" tIns="0" bIns="0" anchor="t">
+          <a:bodyPr wrap="square" lIns="0" rIns="0" tIns="0" bIns="0" anchor="t">
             <a:spAutoFit/>
           </a:bodyPr>
           <a:lstStyle/>
@@ -15774,7 +15774,7 @@
                 </a:solidFill>
                 <a:latin typeface="Outfit"/>
               </a:rPr>
-              <a:t>Vai sulla pagina del corso e scegli:</a:t>
+              <a:t>Vai sulla pagina del corso e scegli: </a:t>
             </a:r>
           </a:p>
           <a:p>
@@ -15790,7 +15790,7 @@
                 </a:solidFill>
                 <a:latin typeface="Outfit"/>
               </a:rPr>
-              <a:t>un semestre, oppure il percorso</a:t>
+              <a:t>un semestre, oppure il percorso </a:t>
             </a:r>
           </a:p>
           <a:p>
@@ -15828,7 +15828,7 @@
           <a:noFill/>
         </p:spPr>
         <p:txBody>
-          <a:bodyPr wrap="none" lIns="0" rIns="0" tIns="0" bIns="0" anchor="t">
+          <a:bodyPr wrap="square" lIns="0" rIns="0" tIns="0" bIns="0" anchor="t">
             <a:spAutoFit/>
           </a:bodyPr>
           <a:lstStyle/>
@@ -15863,7 +15863,7 @@
           <a:noFill/>
         </p:spPr>
         <p:txBody>
-          <a:bodyPr wrap="none" lIns="0" rIns="0" tIns="0" bIns="0" anchor="t">
+          <a:bodyPr wrap="square" lIns="0" rIns="0" tIns="0" bIns="0" anchor="t">
             <a:spAutoFit/>
           </a:bodyPr>
           <a:lstStyle/>
@@ -15880,7 +15880,7 @@
                 </a:solidFill>
                 <a:latin typeface="Outfit"/>
               </a:rPr>
-              <a:t>Paghi con la carta, in modo sicuro:</a:t>
+              <a:t>Paghi con la carta, in modo sicuro: </a:t>
             </a:r>
           </a:p>
           <a:p>
@@ -15896,7 +15896,7 @@
                 </a:solidFill>
                 <a:latin typeface="Outfit"/>
               </a:rPr>
-              <a:t>il pagamento passa da Stripe, noi</a:t>
+              <a:t>il pagamento passa da Stripe, noi </a:t>
             </a:r>
           </a:p>
           <a:p>
@@ -15934,7 +15934,7 @@
           <a:noFill/>
         </p:spPr>
         <p:txBody>
-          <a:bodyPr wrap="none" lIns="0" rIns="0" tIns="0" bIns="0" anchor="t">
+          <a:bodyPr wrap="square" lIns="0" rIns="0" tIns="0" bIns="0" anchor="t">
             <a:spAutoFit/>
           </a:bodyPr>
           <a:lstStyle/>
@@ -15969,7 +15969,7 @@
           <a:noFill/>
         </p:spPr>
         <p:txBody>
-          <a:bodyPr wrap="none" lIns="0" rIns="0" tIns="0" bIns="0" anchor="t">
+          <a:bodyPr wrap="square" lIns="0" rIns="0" tIns="0" bIns="0" anchor="t">
             <a:spAutoFit/>
           </a:bodyPr>
           <a:lstStyle/>
@@ -15986,7 +15986,7 @@
                 </a:solidFill>
                 <a:latin typeface="Outfit"/>
               </a:rPr>
-              <a:t>Ricevi subito una mail con il link per</a:t>
+              <a:t>Ricevi subito una mail con il link per </a:t>
             </a:r>
           </a:p>
           <a:p>
@@ -16002,7 +16002,7 @@
                 </a:solidFill>
                 <a:latin typeface="Outfit"/>
               </a:rPr>
-              <a:t>attivare il tuo accesso e scegliere la</a:t>
+              <a:t>attivare il tuo accesso e scegliere la </a:t>
             </a:r>
           </a:p>
           <a:p>
@@ -16040,7 +16040,7 @@
           <a:noFill/>
         </p:spPr>
         <p:txBody>
-          <a:bodyPr wrap="none" lIns="0" rIns="0" tIns="0" bIns="0" anchor="t">
+          <a:bodyPr wrap="square" lIns="0" rIns="0" tIns="0" bIns="0" anchor="t">
             <a:spAutoFit/>
           </a:bodyPr>
           <a:lstStyle/>
@@ -16075,7 +16075,7 @@
           <a:noFill/>
         </p:spPr>
         <p:txBody>
-          <a:bodyPr wrap="none" lIns="0" rIns="0" tIns="0" bIns="0" anchor="t">
+          <a:bodyPr wrap="square" lIns="0" rIns="0" tIns="0" bIns="0" anchor="t">
             <a:spAutoFit/>
           </a:bodyPr>
           <a:lstStyle/>
@@ -16092,7 +16092,7 @@
                 </a:solidFill>
                 <a:latin typeface="Outfit"/>
               </a:rPr>
-              <a:t>Sei dentro: lezioni, registrazioni,</a:t>
+              <a:t>Sei dentro: lezioni, registrazioni, </a:t>
             </a:r>
           </a:p>
           <a:p>
@@ -16108,7 +16108,7 @@
                 </a:solidFill>
                 <a:latin typeface="Outfit"/>
               </a:rPr>
-              <a:t>materiali e forum nella tua area</a:t>
+              <a:t>materiali e forum nella tua area </a:t>
             </a:r>
           </a:p>
           <a:p>
@@ -16146,7 +16146,7 @@
           <a:noFill/>
         </p:spPr>
         <p:txBody>
-          <a:bodyPr wrap="none" lIns="0" rIns="0" tIns="0" bIns="0" anchor="t">
+          <a:bodyPr wrap="square" lIns="0" rIns="0" tIns="0" bIns="0" anchor="t">
             <a:spAutoFit/>
           </a:bodyPr>
           <a:lstStyle/>
@@ -16181,7 +16181,7 @@
           <a:noFill/>
         </p:spPr>
         <p:txBody>
-          <a:bodyPr wrap="none" lIns="0" rIns="0" tIns="0" bIns="0" anchor="t">
+          <a:bodyPr wrap="square" lIns="0" rIns="0" tIns="0" bIns="0" anchor="t">
             <a:spAutoFit/>
           </a:bodyPr>
           <a:lstStyle/>
@@ -16220,7 +16220,7 @@
           <a:noFill/>
         </p:spPr>
         <p:txBody>
-          <a:bodyPr wrap="none" lIns="0" rIns="0" tIns="0" bIns="0" anchor="t">
+          <a:bodyPr wrap="square" lIns="0" rIns="0" tIns="0" bIns="0" anchor="t">
             <a:spAutoFit/>
           </a:bodyPr>
           <a:lstStyle/>
@@ -16259,7 +16259,7 @@
           <a:noFill/>
         </p:spPr>
         <p:txBody>
-          <a:bodyPr wrap="none" lIns="0" rIns="0" tIns="0" bIns="0" anchor="t">
+          <a:bodyPr wrap="square" lIns="0" rIns="0" tIns="0" bIns="0" anchor="t">
             <a:spAutoFit/>
           </a:bodyPr>
           <a:lstStyle/>
@@ -16298,7 +16298,7 @@
           <a:noFill/>
         </p:spPr>
         <p:txBody>
-          <a:bodyPr wrap="none" lIns="0" rIns="0" tIns="0" bIns="0" anchor="t">
+          <a:bodyPr wrap="square" lIns="0" rIns="0" tIns="0" bIns="0" anchor="t">
             <a:spAutoFit/>
           </a:bodyPr>
           <a:lstStyle/>
@@ -16337,7 +16337,7 @@
           <a:noFill/>
         </p:spPr>
         <p:txBody>
-          <a:bodyPr wrap="none" lIns="0" rIns="0" tIns="0" bIns="0" anchor="t">
+          <a:bodyPr wrap="square" lIns="0" rIns="0" tIns="0" bIns="0" anchor="t">
             <a:spAutoFit/>
           </a:bodyPr>
           <a:lstStyle/>
@@ -16376,7 +16376,7 @@
           <a:noFill/>
         </p:spPr>
         <p:txBody>
-          <a:bodyPr wrap="none" lIns="0" rIns="0" tIns="0" bIns="0" anchor="t">
+          <a:bodyPr wrap="square" lIns="0" rIns="0" tIns="0" bIns="0" anchor="t">
             <a:spAutoFit/>
           </a:bodyPr>
           <a:lstStyle/>
@@ -16415,7 +16415,7 @@
           <a:noFill/>
         </p:spPr>
         <p:txBody>
-          <a:bodyPr wrap="none" lIns="0" rIns="0" tIns="0" bIns="0" anchor="t">
+          <a:bodyPr wrap="square" lIns="0" rIns="0" tIns="0" bIns="0" anchor="t">
             <a:spAutoFit/>
           </a:bodyPr>
           <a:lstStyle/>
@@ -16576,7 +16576,7 @@
           <a:noFill/>
         </p:spPr>
         <p:txBody>
-          <a:bodyPr wrap="none" lIns="0" rIns="0" tIns="0" bIns="0" anchor="t">
+          <a:bodyPr wrap="square" lIns="0" rIns="0" tIns="0" bIns="0" anchor="t">
             <a:spAutoFit/>
           </a:bodyPr>
           <a:lstStyle/>
@@ -16615,7 +16615,7 @@
           <a:noFill/>
         </p:spPr>
         <p:txBody>
-          <a:bodyPr wrap="none" lIns="0" rIns="0" tIns="0" bIns="0" anchor="t">
+          <a:bodyPr wrap="square" lIns="0" rIns="0" tIns="0" bIns="0" anchor="t">
             <a:spAutoFit/>
           </a:bodyPr>
           <a:lstStyle/>
@@ -16654,7 +16654,7 @@
           <a:noFill/>
         </p:spPr>
         <p:txBody>
-          <a:bodyPr wrap="none" lIns="0" rIns="0" tIns="0" bIns="0" anchor="t">
+          <a:bodyPr wrap="square" lIns="0" rIns="0" tIns="0" bIns="0" anchor="t">
             <a:spAutoFit/>
           </a:bodyPr>
           <a:lstStyle/>
@@ -16671,7 +16671,7 @@
                 </a:solidFill>
                 <a:latin typeface="Outfit"/>
               </a:rPr>
-              <a:t>La tua classe: le lezioni in ordine, ognuna con la registrazione da rivedere e</a:t>
+              <a:t>La tua classe: le lezioni in ordine, ognuna con la registrazione da rivedere e </a:t>
             </a:r>
           </a:p>
           <a:p>
@@ -16709,7 +16709,7 @@
           <a:noFill/>
         </p:spPr>
         <p:txBody>
-          <a:bodyPr wrap="none" lIns="0" rIns="0" tIns="0" bIns="0" anchor="t">
+          <a:bodyPr wrap="square" lIns="0" rIns="0" tIns="0" bIns="0" anchor="t">
             <a:spAutoFit/>
           </a:bodyPr>
           <a:lstStyle/>
@@ -16748,7 +16748,7 @@
           <a:noFill/>
         </p:spPr>
         <p:txBody>
-          <a:bodyPr wrap="none" lIns="0" rIns="0" tIns="0" bIns="0" anchor="t">
+          <a:bodyPr wrap="square" lIns="0" rIns="0" tIns="0" bIns="0" anchor="t">
             <a:spAutoFit/>
           </a:bodyPr>
           <a:lstStyle/>
@@ -16787,7 +16787,7 @@
           <a:noFill/>
         </p:spPr>
         <p:txBody>
-          <a:bodyPr wrap="none" lIns="0" rIns="0" tIns="0" bIns="0" anchor="t">
+          <a:bodyPr wrap="square" lIns="0" rIns="0" tIns="0" bIns="0" anchor="t">
             <a:spAutoFit/>
           </a:bodyPr>
           <a:lstStyle/>
@@ -16826,7 +16826,7 @@
           <a:noFill/>
         </p:spPr>
         <p:txBody>
-          <a:bodyPr wrap="none" lIns="0" rIns="0" tIns="0" bIns="0" anchor="t">
+          <a:bodyPr wrap="square" lIns="0" rIns="0" tIns="0" bIns="0" anchor="t">
             <a:spAutoFit/>
           </a:bodyPr>
           <a:lstStyle/>
@@ -16939,7 +16939,7 @@
           <a:noFill/>
         </p:spPr>
         <p:txBody>
-          <a:bodyPr wrap="none" lIns="0" rIns="0" tIns="0" bIns="0" anchor="t">
+          <a:bodyPr wrap="square" lIns="0" rIns="0" tIns="0" bIns="0" anchor="t">
             <a:spAutoFit/>
           </a:bodyPr>
           <a:lstStyle/>
@@ -16978,7 +16978,7 @@
           <a:noFill/>
         </p:spPr>
         <p:txBody>
-          <a:bodyPr wrap="none" lIns="0" rIns="0" tIns="0" bIns="0" anchor="t">
+          <a:bodyPr wrap="square" lIns="0" rIns="0" tIns="0" bIns="0" anchor="t">
             <a:spAutoFit/>
           </a:bodyPr>
           <a:lstStyle/>
@@ -17017,7 +17017,7 @@
           <a:noFill/>
         </p:spPr>
         <p:txBody>
-          <a:bodyPr wrap="none" lIns="0" rIns="0" tIns="0" bIns="0" anchor="t">
+          <a:bodyPr wrap="square" lIns="0" rIns="0" tIns="0" bIns="0" anchor="t">
             <a:spAutoFit/>
           </a:bodyPr>
           <a:lstStyle/>
@@ -17056,7 +17056,7 @@
           <a:noFill/>
         </p:spPr>
         <p:txBody>
-          <a:bodyPr wrap="none" lIns="0" rIns="0" tIns="0" bIns="0" anchor="t">
+          <a:bodyPr wrap="square" lIns="0" rIns="0" tIns="0" bIns="0" anchor="t">
             <a:spAutoFit/>
           </a:bodyPr>
           <a:lstStyle/>
@@ -17193,7 +17193,7 @@
           <a:noFill/>
         </p:spPr>
         <p:txBody>
-          <a:bodyPr wrap="none" lIns="0" rIns="0" tIns="0" bIns="0" anchor="t">
+          <a:bodyPr wrap="square" lIns="0" rIns="0" tIns="0" bIns="0" anchor="t">
             <a:spAutoFit/>
           </a:bodyPr>
           <a:lstStyle/>
@@ -17232,7 +17232,7 @@
           <a:noFill/>
         </p:spPr>
         <p:txBody>
-          <a:bodyPr wrap="none" lIns="0" rIns="0" tIns="0" bIns="0" anchor="t">
+          <a:bodyPr wrap="square" lIns="0" rIns="0" tIns="0" bIns="0" anchor="t">
             <a:spAutoFit/>
           </a:bodyPr>
           <a:lstStyle/>
@@ -17271,7 +17271,7 @@
           <a:noFill/>
         </p:spPr>
         <p:txBody>
-          <a:bodyPr wrap="none" lIns="0" rIns="0" tIns="0" bIns="0" anchor="t">
+          <a:bodyPr wrap="square" lIns="0" rIns="0" tIns="0" bIns="0" anchor="t">
             <a:spAutoFit/>
           </a:bodyPr>
           <a:lstStyle/>
@@ -17326,7 +17326,7 @@
           <a:noFill/>
         </p:spPr>
         <p:txBody>
-          <a:bodyPr wrap="none" lIns="0" rIns="0" tIns="0" bIns="0" anchor="t">
+          <a:bodyPr wrap="square" lIns="0" rIns="0" tIns="0" bIns="0" anchor="t">
             <a:spAutoFit/>
           </a:bodyPr>
           <a:lstStyle/>
@@ -17343,7 +17343,7 @@
                 </a:solidFill>
                 <a:latin typeface="Outfit"/>
               </a:rPr>
-              <a:t>Questo corso arriva da diversi inviti che mi sono arrivati attraverso</a:t>
+              <a:t>Questo corso arriva da diversi inviti che mi sono arrivati attraverso </a:t>
             </a:r>
           </a:p>
           <a:p>
@@ -17359,7 +17359,7 @@
                 </a:solidFill>
                 <a:latin typeface="Outfit"/>
               </a:rPr>
-              <a:t>la divulgazione dello Human Design e del BG5 sul mio canale</a:t>
+              <a:t>la divulgazione dello Human Design e del BG5 sul mio canale </a:t>
             </a:r>
           </a:p>
           <a:p>
@@ -17397,7 +17397,7 @@
           <a:noFill/>
         </p:spPr>
         <p:txBody>
-          <a:bodyPr wrap="none" lIns="0" rIns="0" tIns="0" bIns="0" anchor="t">
+          <a:bodyPr wrap="square" lIns="0" rIns="0" tIns="0" bIns="0" anchor="t">
             <a:spAutoFit/>
           </a:bodyPr>
           <a:lstStyle/>
@@ -17414,7 +17414,7 @@
                 </a:solidFill>
                 <a:latin typeface="Outfit"/>
               </a:rPr>
-              <a:t>Mi sento chiamata ad essere al servizio delle persone, ma fuori dal</a:t>
+              <a:t>Mi sento chiamata ad essere al servizio delle persone, ma fuori dal </a:t>
             </a:r>
           </a:p>
           <a:p>
@@ -17452,7 +17452,7 @@
           <a:noFill/>
         </p:spPr>
         <p:txBody>
-          <a:bodyPr wrap="none" lIns="0" rIns="0" tIns="0" bIns="0" anchor="t">
+          <a:bodyPr wrap="square" lIns="0" rIns="0" tIns="0" bIns="0" anchor="t">
             <a:spAutoFit/>
           </a:bodyPr>
           <a:lstStyle/>
@@ -17469,7 +17469,7 @@
                 </a:solidFill>
                 <a:latin typeface="Playfair Display"/>
               </a:rPr>
-              <a:t>Il mio obiettivo, con questo corso, è fornire gli</a:t>
+              <a:t>Il mio obiettivo, con questo corso, è fornire gli </a:t>
             </a:r>
           </a:p>
           <a:p>
@@ -17485,7 +17485,7 @@
                 </a:solidFill>
                 <a:latin typeface="Playfair Display"/>
               </a:rPr>
-              <a:t>strumenti base per leggere in autonomia qualsiasi</a:t>
+              <a:t>strumenti base per leggere in autonomia qualsiasi </a:t>
             </a:r>
           </a:p>
           <a:p>
@@ -17523,7 +17523,7 @@
           <a:noFill/>
         </p:spPr>
         <p:txBody>
-          <a:bodyPr wrap="none" lIns="0" rIns="0" tIns="0" bIns="0" anchor="t">
+          <a:bodyPr wrap="square" lIns="0" rIns="0" tIns="0" bIns="0" anchor="t">
             <a:spAutoFit/>
           </a:bodyPr>
           <a:lstStyle/>
@@ -17562,7 +17562,7 @@
           <a:noFill/>
         </p:spPr>
         <p:txBody>
-          <a:bodyPr wrap="none" lIns="0" rIns="0" tIns="0" bIns="0" anchor="t">
+          <a:bodyPr wrap="square" lIns="0" rIns="0" tIns="0" bIns="0" anchor="t">
             <a:spAutoFit/>
           </a:bodyPr>
           <a:lstStyle/>
@@ -17675,7 +17675,7 @@
           <a:noFill/>
         </p:spPr>
         <p:txBody>
-          <a:bodyPr wrap="none" lIns="0" rIns="0" tIns="0" bIns="0" anchor="t">
+          <a:bodyPr wrap="square" lIns="0" rIns="0" tIns="0" bIns="0" anchor="t">
             <a:spAutoFit/>
           </a:bodyPr>
           <a:lstStyle/>
@@ -17705,16 +17705,16 @@
         </p:nvSpPr>
         <p:spPr>
           <a:xfrm>
-            <a:off x="7514884" y="3429488"/>
-            <a:ext cx="4067487" cy="419099"/>
-          </a:xfrm>
-          <a:prstGeom prst="rect">
-            <a:avLst/>
-          </a:prstGeom>
-          <a:noFill/>
-        </p:spPr>
-        <p:txBody>
-          <a:bodyPr wrap="none" lIns="0" rIns="0" tIns="0" bIns="0" anchor="t">
+            <a:off x="6664457" y="3416788"/>
+            <a:ext cx="4917914" cy="444499"/>
+          </a:xfrm>
+          <a:prstGeom prst="rect">
+            <a:avLst/>
+          </a:prstGeom>
+          <a:noFill/>
+        </p:spPr>
+        <p:txBody>
+          <a:bodyPr wrap="square" lIns="0" rIns="0" tIns="0" bIns="0" anchor="t">
             <a:spAutoFit/>
           </a:bodyPr>
           <a:lstStyle/>
@@ -17753,7 +17753,7 @@
           <a:noFill/>
         </p:spPr>
         <p:txBody>
-          <a:bodyPr wrap="none" lIns="0" rIns="0" tIns="0" bIns="0" anchor="t">
+          <a:bodyPr wrap="square" lIns="0" rIns="0" tIns="0" bIns="0" anchor="t">
             <a:spAutoFit/>
           </a:bodyPr>
           <a:lstStyle/>
@@ -17792,7 +17792,7 @@
           <a:noFill/>
         </p:spPr>
         <p:txBody>
-          <a:bodyPr wrap="none" lIns="0" rIns="0" tIns="0" bIns="0" anchor="t">
+          <a:bodyPr wrap="square" lIns="0" rIns="0" tIns="0" bIns="0" anchor="t">
             <a:spAutoFit/>
           </a:bodyPr>
           <a:lstStyle/>
@@ -17831,7 +17831,7 @@
           <a:noFill/>
         </p:spPr>
         <p:txBody>
-          <a:bodyPr wrap="none" lIns="0" rIns="0" tIns="0" bIns="0" anchor="t">
+          <a:bodyPr wrap="square" lIns="0" rIns="0" tIns="0" bIns="0" anchor="t">
             <a:spAutoFit/>
           </a:bodyPr>
           <a:lstStyle/>
@@ -17987,7 +17987,7 @@
           <a:noFill/>
         </p:spPr>
         <p:txBody>
-          <a:bodyPr wrap="none" lIns="0" rIns="0" tIns="0" bIns="0" anchor="t">
+          <a:bodyPr wrap="square" lIns="0" rIns="0" tIns="0" bIns="0" anchor="t">
             <a:spAutoFit/>
           </a:bodyPr>
           <a:lstStyle/>
@@ -18026,7 +18026,7 @@
           <a:noFill/>
         </p:spPr>
         <p:txBody>
-          <a:bodyPr wrap="none" lIns="0" rIns="0" tIns="0" bIns="0" anchor="t">
+          <a:bodyPr wrap="square" lIns="0" rIns="0" tIns="0" bIns="0" anchor="t">
             <a:spAutoFit/>
           </a:bodyPr>
           <a:lstStyle/>
@@ -18043,7 +18043,7 @@
                 </a:solidFill>
                 <a:latin typeface="Playfair Display"/>
               </a:rPr>
-              <a:t>Ascolta come se fosse la</a:t>
+              <a:t>Ascolta come se fosse la </a:t>
             </a:r>
           </a:p>
           <a:p>
@@ -18059,7 +18059,7 @@
                 </a:solidFill>
                 <a:latin typeface="Playfair Display"/>
               </a:rPr>
-              <a:t>prima volta che senti</a:t>
+              <a:t>prima volta che senti </a:t>
             </a:r>
           </a:p>
           <a:p>
@@ -18097,7 +18097,7 @@
           <a:noFill/>
         </p:spPr>
         <p:txBody>
-          <a:bodyPr wrap="none" lIns="0" rIns="0" tIns="0" bIns="0" anchor="t">
+          <a:bodyPr wrap="square" lIns="0" rIns="0" tIns="0" bIns="0" anchor="t">
             <a:spAutoFit/>
           </a:bodyPr>
           <a:lstStyle/>
@@ -18136,7 +18136,7 @@
           <a:noFill/>
         </p:spPr>
         <p:txBody>
-          <a:bodyPr wrap="none" lIns="0" rIns="0" tIns="0" bIns="0" anchor="t">
+          <a:bodyPr wrap="square" lIns="0" rIns="0" tIns="0" bIns="0" anchor="t">
             <a:spAutoFit/>
           </a:bodyPr>
           <a:lstStyle/>
@@ -18574,7 +18574,7 @@
           <a:noFill/>
         </p:spPr>
         <p:txBody>
-          <a:bodyPr wrap="none" lIns="0" rIns="0" tIns="0" bIns="0" anchor="t">
+          <a:bodyPr wrap="square" lIns="0" rIns="0" tIns="0" bIns="0" anchor="t">
             <a:spAutoFit/>
           </a:bodyPr>
           <a:lstStyle/>
@@ -18613,7 +18613,7 @@
           <a:noFill/>
         </p:spPr>
         <p:txBody>
-          <a:bodyPr wrap="none" lIns="0" rIns="0" tIns="0" bIns="0" anchor="t">
+          <a:bodyPr wrap="square" lIns="0" rIns="0" tIns="0" bIns="0" anchor="t">
             <a:spAutoFit/>
           </a:bodyPr>
           <a:lstStyle/>
@@ -18652,7 +18652,7 @@
           <a:noFill/>
         </p:spPr>
         <p:txBody>
-          <a:bodyPr wrap="none" lIns="0" rIns="0" tIns="0" bIns="0" anchor="t">
+          <a:bodyPr wrap="square" lIns="0" rIns="0" tIns="0" bIns="0" anchor="t">
             <a:spAutoFit/>
           </a:bodyPr>
           <a:lstStyle/>
@@ -18691,7 +18691,7 @@
           <a:noFill/>
         </p:spPr>
         <p:txBody>
-          <a:bodyPr wrap="none" lIns="0" rIns="0" tIns="0" bIns="0" anchor="t">
+          <a:bodyPr wrap="square" lIns="0" rIns="0" tIns="0" bIns="0" anchor="t">
             <a:spAutoFit/>
           </a:bodyPr>
           <a:lstStyle/>
@@ -18726,7 +18726,7 @@
           <a:noFill/>
         </p:spPr>
         <p:txBody>
-          <a:bodyPr wrap="none" lIns="0" rIns="0" tIns="0" bIns="0" anchor="t">
+          <a:bodyPr wrap="square" lIns="0" rIns="0" tIns="0" bIns="0" anchor="t">
             <a:spAutoFit/>
           </a:bodyPr>
           <a:lstStyle/>
@@ -18765,7 +18765,7 @@
           <a:noFill/>
         </p:spPr>
         <p:txBody>
-          <a:bodyPr wrap="none" lIns="0" rIns="0" tIns="0" bIns="0" anchor="t">
+          <a:bodyPr wrap="square" lIns="0" rIns="0" tIns="0" bIns="0" anchor="t">
             <a:spAutoFit/>
           </a:bodyPr>
           <a:lstStyle/>
@@ -18800,7 +18800,7 @@
           <a:noFill/>
         </p:spPr>
         <p:txBody>
-          <a:bodyPr wrap="none" lIns="0" rIns="0" tIns="0" bIns="0" anchor="t">
+          <a:bodyPr wrap="square" lIns="0" rIns="0" tIns="0" bIns="0" anchor="t">
             <a:spAutoFit/>
           </a:bodyPr>
           <a:lstStyle/>
@@ -18839,7 +18839,7 @@
           <a:noFill/>
         </p:spPr>
         <p:txBody>
-          <a:bodyPr wrap="none" lIns="0" rIns="0" tIns="0" bIns="0" anchor="t">
+          <a:bodyPr wrap="square" lIns="0" rIns="0" tIns="0" bIns="0" anchor="t">
             <a:spAutoFit/>
           </a:bodyPr>
           <a:lstStyle/>
@@ -18874,7 +18874,7 @@
           <a:noFill/>
         </p:spPr>
         <p:txBody>
-          <a:bodyPr wrap="none" lIns="0" rIns="0" tIns="0" bIns="0" anchor="t">
+          <a:bodyPr wrap="square" lIns="0" rIns="0" tIns="0" bIns="0" anchor="t">
             <a:spAutoFit/>
           </a:bodyPr>
           <a:lstStyle/>
@@ -18913,7 +18913,7 @@
           <a:noFill/>
         </p:spPr>
         <p:txBody>
-          <a:bodyPr wrap="none" lIns="0" rIns="0" tIns="0" bIns="0" anchor="t">
+          <a:bodyPr wrap="square" lIns="0" rIns="0" tIns="0" bIns="0" anchor="t">
             <a:spAutoFit/>
           </a:bodyPr>
           <a:lstStyle/>
@@ -18948,7 +18948,7 @@
           <a:noFill/>
         </p:spPr>
         <p:txBody>
-          <a:bodyPr wrap="none" lIns="0" rIns="0" tIns="0" bIns="0" anchor="t">
+          <a:bodyPr wrap="square" lIns="0" rIns="0" tIns="0" bIns="0" anchor="t">
             <a:spAutoFit/>
           </a:bodyPr>
           <a:lstStyle/>
@@ -18987,7 +18987,7 @@
           <a:noFill/>
         </p:spPr>
         <p:txBody>
-          <a:bodyPr wrap="none" lIns="0" rIns="0" tIns="0" bIns="0" anchor="t">
+          <a:bodyPr wrap="square" lIns="0" rIns="0" tIns="0" bIns="0" anchor="t">
             <a:spAutoFit/>
           </a:bodyPr>
           <a:lstStyle/>
@@ -19022,7 +19022,7 @@
           <a:noFill/>
         </p:spPr>
         <p:txBody>
-          <a:bodyPr wrap="none" lIns="0" rIns="0" tIns="0" bIns="0" anchor="t">
+          <a:bodyPr wrap="square" lIns="0" rIns="0" tIns="0" bIns="0" anchor="t">
             <a:spAutoFit/>
           </a:bodyPr>
           <a:lstStyle/>
@@ -19061,7 +19061,7 @@
           <a:noFill/>
         </p:spPr>
         <p:txBody>
-          <a:bodyPr wrap="none" lIns="0" rIns="0" tIns="0" bIns="0" anchor="t">
+          <a:bodyPr wrap="square" lIns="0" rIns="0" tIns="0" bIns="0" anchor="t">
             <a:spAutoFit/>
           </a:bodyPr>
           <a:lstStyle/>
@@ -19096,7 +19096,7 @@
           <a:noFill/>
         </p:spPr>
         <p:txBody>
-          <a:bodyPr wrap="none" lIns="0" rIns="0" tIns="0" bIns="0" anchor="t">
+          <a:bodyPr wrap="square" lIns="0" rIns="0" tIns="0" bIns="0" anchor="t">
             <a:spAutoFit/>
           </a:bodyPr>
           <a:lstStyle/>
@@ -19135,7 +19135,7 @@
           <a:noFill/>
         </p:spPr>
         <p:txBody>
-          <a:bodyPr wrap="none" lIns="0" rIns="0" tIns="0" bIns="0" anchor="t">
+          <a:bodyPr wrap="square" lIns="0" rIns="0" tIns="0" bIns="0" anchor="t">
             <a:spAutoFit/>
           </a:bodyPr>
           <a:lstStyle/>
@@ -19170,7 +19170,7 @@
           <a:noFill/>
         </p:spPr>
         <p:txBody>
-          <a:bodyPr wrap="none" lIns="0" rIns="0" tIns="0" bIns="0" anchor="t">
+          <a:bodyPr wrap="square" lIns="0" rIns="0" tIns="0" bIns="0" anchor="t">
             <a:spAutoFit/>
           </a:bodyPr>
           <a:lstStyle/>
@@ -19209,7 +19209,7 @@
           <a:noFill/>
         </p:spPr>
         <p:txBody>
-          <a:bodyPr wrap="none" lIns="0" rIns="0" tIns="0" bIns="0" anchor="t">
+          <a:bodyPr wrap="square" lIns="0" rIns="0" tIns="0" bIns="0" anchor="t">
             <a:spAutoFit/>
           </a:bodyPr>
           <a:lstStyle/>
@@ -19248,7 +19248,7 @@
           <a:noFill/>
         </p:spPr>
         <p:txBody>
-          <a:bodyPr wrap="none" lIns="0" rIns="0" tIns="0" bIns="0" anchor="t">
+          <a:bodyPr wrap="square" lIns="0" rIns="0" tIns="0" bIns="0" anchor="t">
             <a:spAutoFit/>
           </a:bodyPr>
           <a:lstStyle/>
@@ -19404,7 +19404,7 @@
           <a:noFill/>
         </p:spPr>
         <p:txBody>
-          <a:bodyPr wrap="none" lIns="0" rIns="0" tIns="0" bIns="0" anchor="t">
+          <a:bodyPr wrap="square" lIns="0" rIns="0" tIns="0" bIns="0" anchor="t">
             <a:spAutoFit/>
           </a:bodyPr>
           <a:lstStyle/>
@@ -19434,16 +19434,16 @@
         </p:nvSpPr>
         <p:spPr>
           <a:xfrm>
-            <a:off x="596899" y="1771447"/>
-            <a:ext cx="11595815" cy="2231623"/>
-          </a:xfrm>
-          <a:prstGeom prst="rect">
-            <a:avLst/>
-          </a:prstGeom>
-          <a:noFill/>
-        </p:spPr>
-        <p:txBody>
-          <a:bodyPr wrap="none" lIns="0" rIns="0" tIns="0" bIns="0" anchor="t">
+            <a:off x="596899" y="1758747"/>
+            <a:ext cx="11917159" cy="2250672"/>
+          </a:xfrm>
+          <a:prstGeom prst="rect">
+            <a:avLst/>
+          </a:prstGeom>
+          <a:noFill/>
+        </p:spPr>
+        <p:txBody>
+          <a:bodyPr wrap="square" lIns="0" rIns="0" tIns="0" bIns="0" anchor="t">
             <a:spAutoFit/>
           </a:bodyPr>
           <a:lstStyle/>
@@ -19460,7 +19460,7 @@
                 </a:solidFill>
                 <a:latin typeface="Playfair Display"/>
               </a:rPr>
-              <a:t>L'attuale direzione verso la quale stiamo andando è, e sarà, uno shock. È un</a:t>
+              <a:t>L'attuale direzione verso la quale stiamo andando è, e sarà, uno </a:t>
             </a:r>
           </a:p>
           <a:p>
@@ -19476,7 +19476,7 @@
                 </a:solidFill>
                 <a:latin typeface="Playfair Display"/>
               </a:rPr>
-              <a:t>mondo che abbraccerà coloro che vivono e operano come loro stessi. Ciò</a:t>
+              <a:t>shock. È un mondo che abbraccerà coloro che vivono e operano </a:t>
             </a:r>
           </a:p>
           <a:p>
@@ -19492,7 +19492,7 @@
                 </a:solidFill>
                 <a:latin typeface="Playfair Display"/>
               </a:rPr>
-              <a:t>significherà molto disordine, caos e confusione per coloro che sono persi nella</a:t>
+              <a:t>come loro stessi. Ciò significherà molto disordine, caos e </a:t>
             </a:r>
           </a:p>
           <a:p>
@@ -19508,7 +19508,7 @@
                 </a:solidFill>
                 <a:latin typeface="Playfair Display"/>
               </a:rPr>
-              <a:t>dipendenza da schemi e relazioni. Tutto nella nostra specie è radicato nella</a:t>
+              <a:t>confusione per coloro che sono persi nella dipendenza da schemi </a:t>
             </a:r>
           </a:p>
           <a:p>
@@ -19524,7 +19524,7 @@
                 </a:solidFill>
                 <a:latin typeface="Playfair Display"/>
               </a:rPr>
-              <a:t>dipendenza.</a:t>
+              <a:t>e relazioni. Tutto nella nostra specie è radicato nella dipendenza.</a:t>
             </a:r>
           </a:p>
         </p:txBody>
@@ -19546,7 +19546,7 @@
           <a:noFill/>
         </p:spPr>
         <p:txBody>
-          <a:bodyPr wrap="none" lIns="0" rIns="0" tIns="0" bIns="0" anchor="t">
+          <a:bodyPr wrap="square" lIns="0" rIns="0" tIns="0" bIns="0" anchor="t">
             <a:spAutoFit/>
           </a:bodyPr>
           <a:lstStyle/>
@@ -19585,7 +19585,7 @@
           <a:noFill/>
         </p:spPr>
         <p:txBody>
-          <a:bodyPr wrap="none" lIns="0" rIns="0" tIns="0" bIns="0" anchor="t">
+          <a:bodyPr wrap="square" lIns="0" rIns="0" tIns="0" bIns="0" anchor="t">
             <a:spAutoFit/>
           </a:bodyPr>
           <a:lstStyle/>
@@ -19624,7 +19624,7 @@
           <a:noFill/>
         </p:spPr>
         <p:txBody>
-          <a:bodyPr wrap="none" lIns="0" rIns="0" tIns="0" bIns="0" anchor="t">
+          <a:bodyPr wrap="square" lIns="0" rIns="0" tIns="0" bIns="0" anchor="t">
             <a:spAutoFit/>
           </a:bodyPr>
           <a:lstStyle/>
@@ -19663,7 +19663,7 @@
           <a:noFill/>
         </p:spPr>
         <p:txBody>
-          <a:bodyPr wrap="none" lIns="0" rIns="0" tIns="0" bIns="0" anchor="t">
+          <a:bodyPr wrap="square" lIns="0" rIns="0" tIns="0" bIns="0" anchor="t">
             <a:spAutoFit/>
           </a:bodyPr>
           <a:lstStyle/>
@@ -19819,7 +19819,7 @@
           <a:noFill/>
         </p:spPr>
         <p:txBody>
-          <a:bodyPr wrap="none" lIns="0" rIns="0" tIns="0" bIns="0" anchor="t">
+          <a:bodyPr wrap="square" lIns="0" rIns="0" tIns="0" bIns="0" anchor="t">
             <a:spAutoFit/>
           </a:bodyPr>
           <a:lstStyle/>
@@ -19858,7 +19858,7 @@
           <a:noFill/>
         </p:spPr>
         <p:txBody>
-          <a:bodyPr wrap="none" lIns="0" rIns="0" tIns="0" bIns="0" anchor="t">
+          <a:bodyPr wrap="square" lIns="0" rIns="0" tIns="0" bIns="0" anchor="t">
             <a:spAutoFit/>
           </a:bodyPr>
           <a:lstStyle/>
@@ -19897,7 +19897,7 @@
           <a:noFill/>
         </p:spPr>
         <p:txBody>
-          <a:bodyPr wrap="none" lIns="0" rIns="0" tIns="0" bIns="0" anchor="t">
+          <a:bodyPr wrap="square" lIns="0" rIns="0" tIns="0" bIns="0" anchor="t">
             <a:spAutoFit/>
           </a:bodyPr>
           <a:lstStyle/>
@@ -19936,7 +19936,7 @@
           <a:noFill/>
         </p:spPr>
         <p:txBody>
-          <a:bodyPr wrap="none" lIns="0" rIns="0" tIns="0" bIns="0" anchor="t">
+          <a:bodyPr wrap="square" lIns="0" rIns="0" tIns="0" bIns="0" anchor="t">
             <a:spAutoFit/>
           </a:bodyPr>
           <a:lstStyle/>
@@ -19953,7 +19953,7 @@
                 </a:solidFill>
                 <a:latin typeface="Outfit"/>
               </a:rPr>
-              <a:t>Falso entusiasmo. La comunicazione si basa su pretese</a:t>
+              <a:t>Falso entusiasmo. La comunicazione si basa su pretese </a:t>
             </a:r>
           </a:p>
           <a:p>
@@ -19969,7 +19969,7 @@
                 </a:solidFill>
                 <a:latin typeface="Outfit"/>
               </a:rPr>
-              <a:t>inevitabilmente non realizzate. Tendenza ad esprimere la</a:t>
+              <a:t>inevitabilmente non realizzate. Tendenza ad esprimere la </a:t>
             </a:r>
           </a:p>
           <a:p>
@@ -20007,7 +20007,7 @@
           <a:noFill/>
         </p:spPr>
         <p:txBody>
-          <a:bodyPr wrap="none" lIns="0" rIns="0" tIns="0" bIns="0" anchor="t">
+          <a:bodyPr wrap="square" lIns="0" rIns="0" tIns="0" bIns="0" anchor="t">
             <a:spAutoFit/>
           </a:bodyPr>
           <a:lstStyle/>
@@ -20046,7 +20046,7 @@
           <a:noFill/>
         </p:spPr>
         <p:txBody>
-          <a:bodyPr wrap="none" lIns="0" rIns="0" tIns="0" bIns="0" anchor="t">
+          <a:bodyPr wrap="square" lIns="0" rIns="0" tIns="0" bIns="0" anchor="t">
             <a:spAutoFit/>
           </a:bodyPr>
           <a:lstStyle/>
@@ -20063,7 +20063,7 @@
                 </a:solidFill>
                 <a:latin typeface="Outfit"/>
               </a:rPr>
-              <a:t>Contemplazione nell'adesso che si traduce nella capacità di</a:t>
+              <a:t>Contemplazione nell'adesso che si traduce nella capacità di </a:t>
             </a:r>
           </a:p>
           <a:p>
@@ -20079,7 +20079,7 @@
                 </a:solidFill>
                 <a:latin typeface="Outfit"/>
               </a:rPr>
-              <a:t>applicare la comprensione. Le istituzioni lavorano a beneficio</a:t>
+              <a:t>applicare la comprensione. Le istituzioni lavorano a beneficio </a:t>
             </a:r>
           </a:p>
           <a:p>
@@ -20095,7 +20095,7 @@
                 </a:solidFill>
                 <a:latin typeface="Outfit"/>
               </a:rPr>
-              <a:t>della società, dei valori, degli ideali e dei loro modelli, e di come</a:t>
+              <a:t>della società, dei valori, degli ideali e dei loro modelli, e di come </a:t>
             </a:r>
           </a:p>
           <a:p>
@@ -20111,7 +20111,7 @@
                 </a:solidFill>
                 <a:latin typeface="Outfit"/>
               </a:rPr>
-              <a:t>questi possono essere compresi e applicati. La capacità di</a:t>
+              <a:t>questi possono essere compresi e applicati. La capacità di </a:t>
             </a:r>
           </a:p>
           <a:p>
@@ -20127,7 +20127,7 @@
                 </a:solidFill>
                 <a:latin typeface="Outfit"/>
               </a:rPr>
-              <a:t>trasformare la consapevolezza individuale in impegno e</a:t>
+              <a:t>trasformare la consapevolezza individuale in impegno e </a:t>
             </a:r>
           </a:p>
           <a:p>
@@ -20165,7 +20165,7 @@
           <a:noFill/>
         </p:spPr>
         <p:txBody>
-          <a:bodyPr wrap="none" lIns="0" rIns="0" tIns="0" bIns="0" anchor="t">
+          <a:bodyPr wrap="square" lIns="0" rIns="0" tIns="0" bIns="0" anchor="t">
             <a:spAutoFit/>
           </a:bodyPr>
           <a:lstStyle/>
@@ -20204,7 +20204,7 @@
           <a:noFill/>
         </p:spPr>
         <p:txBody>
-          <a:bodyPr wrap="none" lIns="0" rIns="0" tIns="0" bIns="0" anchor="t">
+          <a:bodyPr wrap="square" lIns="0" rIns="0" tIns="0" bIns="0" anchor="t">
             <a:spAutoFit/>
           </a:bodyPr>
           <a:lstStyle/>
@@ -20243,7 +20243,7 @@
           <a:noFill/>
         </p:spPr>
         <p:txBody>
-          <a:bodyPr wrap="none" lIns="0" rIns="0" tIns="0" bIns="0" anchor="t">
+          <a:bodyPr wrap="square" lIns="0" rIns="0" tIns="0" bIns="0" anchor="t">
             <a:spAutoFit/>
           </a:bodyPr>
           <a:lstStyle/>
@@ -21049,7 +21049,7 @@
           <a:noFill/>
         </p:spPr>
         <p:txBody>
-          <a:bodyPr wrap="none" lIns="0" rIns="0" tIns="0" bIns="0" anchor="t">
+          <a:bodyPr wrap="square" lIns="0" rIns="0" tIns="0" bIns="0" anchor="t">
             <a:spAutoFit/>
           </a:bodyPr>
           <a:lstStyle/>
@@ -21088,7 +21088,7 @@
           <a:noFill/>
         </p:spPr>
         <p:txBody>
-          <a:bodyPr wrap="none" lIns="0" rIns="0" tIns="0" bIns="0" anchor="t">
+          <a:bodyPr wrap="square" lIns="0" rIns="0" tIns="0" bIns="0" anchor="t">
             <a:spAutoFit/>
           </a:bodyPr>
           <a:lstStyle/>
@@ -21127,7 +21127,7 @@
           <a:noFill/>
         </p:spPr>
         <p:txBody>
-          <a:bodyPr wrap="none" lIns="0" rIns="0" tIns="0" bIns="0" anchor="t">
+          <a:bodyPr wrap="square" lIns="0" rIns="0" tIns="0" bIns="0" anchor="t">
             <a:spAutoFit/>
           </a:bodyPr>
           <a:lstStyle/>
@@ -21166,7 +21166,7 @@
           <a:noFill/>
         </p:spPr>
         <p:txBody>
-          <a:bodyPr wrap="none" lIns="0" rIns="0" tIns="0" bIns="0" anchor="t">
+          <a:bodyPr wrap="square" lIns="0" rIns="0" tIns="0" bIns="0" anchor="t">
             <a:spAutoFit/>
           </a:bodyPr>
           <a:lstStyle/>
@@ -21205,7 +21205,7 @@
           <a:noFill/>
         </p:spPr>
         <p:txBody>
-          <a:bodyPr wrap="none" lIns="0" rIns="0" tIns="0" bIns="0" anchor="t">
+          <a:bodyPr wrap="square" lIns="0" rIns="0" tIns="0" bIns="0" anchor="t">
             <a:spAutoFit/>
           </a:bodyPr>
           <a:lstStyle/>
@@ -21244,7 +21244,7 @@
           <a:noFill/>
         </p:spPr>
         <p:txBody>
-          <a:bodyPr wrap="none" lIns="0" rIns="0" tIns="0" bIns="0" anchor="t">
+          <a:bodyPr wrap="square" lIns="0" rIns="0" tIns="0" bIns="0" anchor="t">
             <a:spAutoFit/>
           </a:bodyPr>
           <a:lstStyle/>
@@ -21283,7 +21283,7 @@
           <a:noFill/>
         </p:spPr>
         <p:txBody>
-          <a:bodyPr wrap="none" lIns="0" rIns="0" tIns="0" bIns="0" anchor="t">
+          <a:bodyPr wrap="square" lIns="0" rIns="0" tIns="0" bIns="0" anchor="t">
             <a:spAutoFit/>
           </a:bodyPr>
           <a:lstStyle/>
@@ -21322,7 +21322,7 @@
           <a:noFill/>
         </p:spPr>
         <p:txBody>
-          <a:bodyPr wrap="none" lIns="0" rIns="0" tIns="0" bIns="0" anchor="t">
+          <a:bodyPr wrap="square" lIns="0" rIns="0" tIns="0" bIns="0" anchor="t">
             <a:spAutoFit/>
           </a:bodyPr>
           <a:lstStyle/>
@@ -21361,7 +21361,7 @@
           <a:noFill/>
         </p:spPr>
         <p:txBody>
-          <a:bodyPr wrap="none" lIns="0" rIns="0" tIns="0" bIns="0" anchor="t">
+          <a:bodyPr wrap="square" lIns="0" rIns="0" tIns="0" bIns="0" anchor="t">
             <a:spAutoFit/>
           </a:bodyPr>
           <a:lstStyle/>
@@ -21400,7 +21400,7 @@
           <a:noFill/>
         </p:spPr>
         <p:txBody>
-          <a:bodyPr wrap="none" lIns="0" rIns="0" tIns="0" bIns="0" anchor="t">
+          <a:bodyPr wrap="square" lIns="0" rIns="0" tIns="0" bIns="0" anchor="t">
             <a:spAutoFit/>
           </a:bodyPr>
           <a:lstStyle/>
@@ -21439,7 +21439,7 @@
           <a:noFill/>
         </p:spPr>
         <p:txBody>
-          <a:bodyPr wrap="none" lIns="0" rIns="0" tIns="0" bIns="0" anchor="t">
+          <a:bodyPr wrap="square" lIns="0" rIns="0" tIns="0" bIns="0" anchor="t">
             <a:spAutoFit/>
           </a:bodyPr>
           <a:lstStyle/>
@@ -21478,7 +21478,7 @@
           <a:noFill/>
         </p:spPr>
         <p:txBody>
-          <a:bodyPr wrap="none" lIns="0" rIns="0" tIns="0" bIns="0" anchor="t">
+          <a:bodyPr wrap="square" lIns="0" rIns="0" tIns="0" bIns="0" anchor="t">
             <a:spAutoFit/>
           </a:bodyPr>
           <a:lstStyle/>
@@ -21517,7 +21517,7 @@
           <a:noFill/>
         </p:spPr>
         <p:txBody>
-          <a:bodyPr wrap="none" lIns="0" rIns="0" tIns="0" bIns="0" anchor="t">
+          <a:bodyPr wrap="square" lIns="0" rIns="0" tIns="0" bIns="0" anchor="t">
             <a:spAutoFit/>
           </a:bodyPr>
           <a:lstStyle/>
@@ -21556,7 +21556,7 @@
           <a:noFill/>
         </p:spPr>
         <p:txBody>
-          <a:bodyPr wrap="none" lIns="0" rIns="0" tIns="0" bIns="0" anchor="t">
+          <a:bodyPr wrap="square" lIns="0" rIns="0" tIns="0" bIns="0" anchor="t">
             <a:spAutoFit/>
           </a:bodyPr>
           <a:lstStyle/>
@@ -21595,7 +21595,7 @@
           <a:noFill/>
         </p:spPr>
         <p:txBody>
-          <a:bodyPr wrap="none" lIns="0" rIns="0" tIns="0" bIns="0" anchor="t">
+          <a:bodyPr wrap="square" lIns="0" rIns="0" tIns="0" bIns="0" anchor="t">
             <a:spAutoFit/>
           </a:bodyPr>
           <a:lstStyle/>
@@ -21634,7 +21634,7 @@
           <a:noFill/>
         </p:spPr>
         <p:txBody>
-          <a:bodyPr wrap="none" lIns="0" rIns="0" tIns="0" bIns="0" anchor="t">
+          <a:bodyPr wrap="square" lIns="0" rIns="0" tIns="0" bIns="0" anchor="t">
             <a:spAutoFit/>
           </a:bodyPr>
           <a:lstStyle/>
@@ -21673,7 +21673,7 @@
           <a:noFill/>
         </p:spPr>
         <p:txBody>
-          <a:bodyPr wrap="none" lIns="0" rIns="0" tIns="0" bIns="0" anchor="t">
+          <a:bodyPr wrap="square" lIns="0" rIns="0" tIns="0" bIns="0" anchor="t">
             <a:spAutoFit/>
           </a:bodyPr>
           <a:lstStyle/>
@@ -21712,7 +21712,7 @@
           <a:noFill/>
         </p:spPr>
         <p:txBody>
-          <a:bodyPr wrap="none" lIns="0" rIns="0" tIns="0" bIns="0" anchor="t">
+          <a:bodyPr wrap="square" lIns="0" rIns="0" tIns="0" bIns="0" anchor="t">
             <a:spAutoFit/>
           </a:bodyPr>
           <a:lstStyle/>
@@ -21751,7 +21751,7 @@
           <a:noFill/>
         </p:spPr>
         <p:txBody>
-          <a:bodyPr wrap="none" lIns="0" rIns="0" tIns="0" bIns="0" anchor="t">
+          <a:bodyPr wrap="square" lIns="0" rIns="0" tIns="0" bIns="0" anchor="t">
             <a:spAutoFit/>
           </a:bodyPr>
           <a:lstStyle/>
@@ -21790,7 +21790,7 @@
           <a:noFill/>
         </p:spPr>
         <p:txBody>
-          <a:bodyPr wrap="none" lIns="0" rIns="0" tIns="0" bIns="0" anchor="t">
+          <a:bodyPr wrap="square" lIns="0" rIns="0" tIns="0" bIns="0" anchor="t">
             <a:spAutoFit/>
           </a:bodyPr>
           <a:lstStyle/>
@@ -22290,7 +22290,7 @@
           <a:noFill/>
         </p:spPr>
         <p:txBody>
-          <a:bodyPr wrap="none" lIns="0" rIns="0" tIns="0" bIns="0" anchor="t">
+          <a:bodyPr wrap="square" lIns="0" rIns="0" tIns="0" bIns="0" anchor="t">
             <a:spAutoFit/>
           </a:bodyPr>
           <a:lstStyle/>
@@ -22329,7 +22329,7 @@
           <a:noFill/>
         </p:spPr>
         <p:txBody>
-          <a:bodyPr wrap="none" lIns="0" rIns="0" tIns="0" bIns="0" anchor="t">
+          <a:bodyPr wrap="square" lIns="0" rIns="0" tIns="0" bIns="0" anchor="t">
             <a:spAutoFit/>
           </a:bodyPr>
           <a:lstStyle/>
@@ -22368,7 +22368,7 @@
           <a:noFill/>
         </p:spPr>
         <p:txBody>
-          <a:bodyPr wrap="none" lIns="0" rIns="0" tIns="0" bIns="0" anchor="t">
+          <a:bodyPr wrap="square" lIns="0" rIns="0" tIns="0" bIns="0" anchor="t">
             <a:spAutoFit/>
           </a:bodyPr>
           <a:lstStyle/>
@@ -22385,7 +22385,7 @@
                 </a:solidFill>
                 <a:latin typeface="Outfit"/>
               </a:rPr>
-              <a:t>Lo Human Design si occupa della trasformazione</a:t>
+              <a:t>Lo Human Design si occupa della trasformazione </a:t>
             </a:r>
           </a:p>
           <a:p>
@@ -22423,7 +22423,7 @@
           <a:noFill/>
         </p:spPr>
         <p:txBody>
-          <a:bodyPr wrap="none" lIns="0" rIns="0" tIns="0" bIns="0" anchor="t">
+          <a:bodyPr wrap="square" lIns="0" rIns="0" tIns="0" bIns="0" anchor="t">
             <a:spAutoFit/>
           </a:bodyPr>
           <a:lstStyle/>
@@ -22440,7 +22440,7 @@
                 </a:solidFill>
                 <a:latin typeface="Outfit"/>
               </a:rPr>
-              <a:t>Il BG5 (Business Group 5) è l'applicazione pratica dello</a:t>
+              <a:t>Il BG5 (Business Group 5) è l'applicazione pratica dello </a:t>
             </a:r>
           </a:p>
           <a:p>
@@ -22478,7 +22478,7 @@
           <a:noFill/>
         </p:spPr>
         <p:txBody>
-          <a:bodyPr wrap="none" lIns="0" rIns="0" tIns="0" bIns="0" anchor="t">
+          <a:bodyPr wrap="square" lIns="0" rIns="0" tIns="0" bIns="0" anchor="t">
             <a:spAutoFit/>
           </a:bodyPr>
           <a:lstStyle/>
@@ -22495,7 +22495,7 @@
                 </a:solidFill>
                 <a:latin typeface="Outfit"/>
               </a:rPr>
-              <a:t>Il mio approccio nasce dall'unione di queste due visioni</a:t>
+              <a:t>Il mio approccio nasce dall'unione di queste due visioni </a:t>
             </a:r>
           </a:p>
           <a:p>
@@ -22533,7 +22533,7 @@
           <a:noFill/>
         </p:spPr>
         <p:txBody>
-          <a:bodyPr wrap="none" lIns="0" rIns="0" tIns="0" bIns="0" anchor="t">
+          <a:bodyPr wrap="square" lIns="0" rIns="0" tIns="0" bIns="0" anchor="t">
             <a:spAutoFit/>
           </a:bodyPr>
           <a:lstStyle/>
@@ -22550,7 +22550,7 @@
                 </a:solidFill>
                 <a:latin typeface="Outfit"/>
               </a:rPr>
-              <a:t>CON QUESTO CORSO INTENDO FORNIRE GLI</a:t>
+              <a:t>CON QUESTO CORSO INTENDO FORNIRE GLI </a:t>
             </a:r>
           </a:p>
           <a:p>
@@ -22588,7 +22588,7 @@
           <a:noFill/>
         </p:spPr>
         <p:txBody>
-          <a:bodyPr wrap="none" lIns="0" rIns="0" tIns="0" bIns="0" anchor="t">
+          <a:bodyPr wrap="square" lIns="0" rIns="0" tIns="0" bIns="0" anchor="t">
             <a:spAutoFit/>
           </a:bodyPr>
           <a:lstStyle/>
@@ -22627,7 +22627,7 @@
           <a:noFill/>
         </p:spPr>
         <p:txBody>
-          <a:bodyPr wrap="none" lIns="0" rIns="0" tIns="0" bIns="0" anchor="t">
+          <a:bodyPr wrap="square" lIns="0" rIns="0" tIns="0" bIns="0" anchor="t">
             <a:spAutoFit/>
           </a:bodyPr>
           <a:lstStyle/>
@@ -22666,7 +22666,7 @@
           <a:noFill/>
         </p:spPr>
         <p:txBody>
-          <a:bodyPr wrap="none" lIns="0" rIns="0" tIns="0" bIns="0" anchor="t">
+          <a:bodyPr wrap="square" lIns="0" rIns="0" tIns="0" bIns="0" anchor="t">
             <a:spAutoFit/>
           </a:bodyPr>
           <a:lstStyle/>
@@ -22705,7 +22705,7 @@
           <a:noFill/>
         </p:spPr>
         <p:txBody>
-          <a:bodyPr wrap="none" lIns="0" rIns="0" tIns="0" bIns="0" anchor="t">
+          <a:bodyPr wrap="square" lIns="0" rIns="0" tIns="0" bIns="0" anchor="t">
             <a:spAutoFit/>
           </a:bodyPr>
           <a:lstStyle/>
@@ -22722,7 +22722,7 @@
                 </a:solidFill>
                 <a:latin typeface="Outfit"/>
               </a:rPr>
-              <a:t>UNA VOLTA PADRONEGGIATA LA LETTURA BASE,</a:t>
+              <a:t>UNA VOLTA PADRONEGGIATA LA LETTURA BASE, </a:t>
             </a:r>
           </a:p>
           <a:p>
@@ -22760,7 +22760,7 @@
           <a:noFill/>
         </p:spPr>
         <p:txBody>
-          <a:bodyPr wrap="none" lIns="0" rIns="0" tIns="0" bIns="0" anchor="t">
+          <a:bodyPr wrap="square" lIns="0" rIns="0" tIns="0" bIns="0" anchor="t">
             <a:spAutoFit/>
           </a:bodyPr>
           <a:lstStyle/>
@@ -22799,7 +22799,7 @@
           <a:noFill/>
         </p:spPr>
         <p:txBody>
-          <a:bodyPr wrap="none" lIns="0" rIns="0" tIns="0" bIns="0" anchor="t">
+          <a:bodyPr wrap="square" lIns="0" rIns="0" tIns="0" bIns="0" anchor="t">
             <a:spAutoFit/>
           </a:bodyPr>
           <a:lstStyle/>
@@ -22838,7 +22838,7 @@
           <a:noFill/>
         </p:spPr>
         <p:txBody>
-          <a:bodyPr wrap="none" lIns="0" rIns="0" tIns="0" bIns="0" anchor="t">
+          <a:bodyPr wrap="square" lIns="0" rIns="0" tIns="0" bIns="0" anchor="t">
             <a:spAutoFit/>
           </a:bodyPr>
           <a:lstStyle/>
@@ -22877,7 +22877,7 @@
           <a:noFill/>
         </p:spPr>
         <p:txBody>
-          <a:bodyPr wrap="none" lIns="0" rIns="0" tIns="0" bIns="0" anchor="t">
+          <a:bodyPr wrap="square" lIns="0" rIns="0" tIns="0" bIns="0" anchor="t">
             <a:spAutoFit/>
           </a:bodyPr>
           <a:lstStyle/>

</xml_diff>

<commit_message>
deck corso: piu' aria sotto citazione e chiusa, Canva rende le righe piu' alte
Co-Authored-By: Claude Fable 5.1 <noreply@anthropic.com>

Antigravity-Session-ID: 0987b7a5-5ad3-4a1c-a0b9-eafe66b303f5
Antigravity-Session-Path: C:\Users\marco\.gemini\antigravity\brain\0987b7a5-5ad3-4a1c-a0b9-eafe66b303f5
</commit_message>
<xml_diff>
--- a/grav-site/root/kit-corso/corso-base-hd.pptx
+++ b/grav-site/root/kit-corso/corso-base-hd.pptx
@@ -4051,7 +4051,7 @@
         </p:nvSpPr>
         <p:spPr>
           <a:xfrm>
-            <a:off x="596899" y="2723548"/>
+            <a:off x="596899" y="2660048"/>
             <a:ext cx="6828490" cy="1291428"/>
           </a:xfrm>
           <a:prstGeom prst="rect">
@@ -4154,7 +4154,7 @@
         </p:nvSpPr>
         <p:spPr>
           <a:xfrm>
-            <a:off x="596899" y="4228296"/>
+            <a:off x="596899" y="4291796"/>
             <a:ext cx="6059795" cy="748008"/>
           </a:xfrm>
           <a:prstGeom prst="rect">
@@ -13018,7 +13018,7 @@
         </p:nvSpPr>
         <p:spPr>
           <a:xfrm>
-            <a:off x="965198" y="2385114"/>
+            <a:off x="965198" y="2321614"/>
             <a:ext cx="2463248" cy="260349"/>
           </a:xfrm>
           <a:prstGeom prst="rect">
@@ -13057,7 +13057,7 @@
         </p:nvSpPr>
         <p:spPr>
           <a:xfrm>
-            <a:off x="596899" y="2372414"/>
+            <a:off x="596899" y="2308914"/>
             <a:ext cx="498474" cy="228599"/>
           </a:xfrm>
           <a:prstGeom prst="rect">
@@ -13092,7 +13092,7 @@
         </p:nvSpPr>
         <p:spPr>
           <a:xfrm>
-            <a:off x="965198" y="2769883"/>
+            <a:off x="965198" y="2706383"/>
             <a:ext cx="3959959" cy="518119"/>
           </a:xfrm>
           <a:prstGeom prst="rect">
@@ -13147,7 +13147,7 @@
         </p:nvSpPr>
         <p:spPr>
           <a:xfrm>
-            <a:off x="596899" y="2757183"/>
+            <a:off x="596899" y="2693683"/>
             <a:ext cx="498474" cy="228599"/>
           </a:xfrm>
           <a:prstGeom prst="rect">
@@ -13182,7 +13182,7 @@
         </p:nvSpPr>
         <p:spPr>
           <a:xfrm>
-            <a:off x="965198" y="3412422"/>
+            <a:off x="965198" y="3348922"/>
             <a:ext cx="2587023" cy="260349"/>
           </a:xfrm>
           <a:prstGeom prst="rect">
@@ -13221,7 +13221,7 @@
         </p:nvSpPr>
         <p:spPr>
           <a:xfrm>
-            <a:off x="596899" y="3399722"/>
+            <a:off x="596899" y="3336222"/>
             <a:ext cx="498474" cy="228599"/>
           </a:xfrm>
           <a:prstGeom prst="rect">
@@ -13256,7 +13256,7 @@
         </p:nvSpPr>
         <p:spPr>
           <a:xfrm>
-            <a:off x="965198" y="3797191"/>
+            <a:off x="965198" y="3733691"/>
             <a:ext cx="4344183" cy="518119"/>
           </a:xfrm>
           <a:prstGeom prst="rect">
@@ -13311,7 +13311,7 @@
         </p:nvSpPr>
         <p:spPr>
           <a:xfrm>
-            <a:off x="596899" y="3784491"/>
+            <a:off x="596899" y="3720991"/>
             <a:ext cx="498474" cy="228599"/>
           </a:xfrm>
           <a:prstGeom prst="rect">
@@ -13346,7 +13346,7 @@
         </p:nvSpPr>
         <p:spPr>
           <a:xfrm>
-            <a:off x="596899" y="4528630"/>
+            <a:off x="596899" y="4592130"/>
             <a:ext cx="5596444" cy="748008"/>
           </a:xfrm>
           <a:prstGeom prst="rect">
@@ -13798,7 +13798,7 @@
         </p:nvSpPr>
         <p:spPr>
           <a:xfrm>
-            <a:off x="965198" y="2385114"/>
+            <a:off x="965198" y="2321614"/>
             <a:ext cx="2388586" cy="260349"/>
           </a:xfrm>
           <a:prstGeom prst="rect">
@@ -13837,7 +13837,7 @@
         </p:nvSpPr>
         <p:spPr>
           <a:xfrm>
-            <a:off x="596899" y="2372414"/>
+            <a:off x="596899" y="2308914"/>
             <a:ext cx="498474" cy="228599"/>
           </a:xfrm>
           <a:prstGeom prst="rect">
@@ -13872,7 +13872,7 @@
         </p:nvSpPr>
         <p:spPr>
           <a:xfrm>
-            <a:off x="965198" y="2769883"/>
+            <a:off x="965198" y="2706383"/>
             <a:ext cx="3885173" cy="518119"/>
           </a:xfrm>
           <a:prstGeom prst="rect">
@@ -13927,7 +13927,7 @@
         </p:nvSpPr>
         <p:spPr>
           <a:xfrm>
-            <a:off x="596899" y="2757183"/>
+            <a:off x="596899" y="2693683"/>
             <a:ext cx="498474" cy="228599"/>
           </a:xfrm>
           <a:prstGeom prst="rect">
@@ -13962,7 +13962,7 @@
         </p:nvSpPr>
         <p:spPr>
           <a:xfrm>
-            <a:off x="965198" y="3412422"/>
+            <a:off x="965198" y="3348922"/>
             <a:ext cx="2587023" cy="260349"/>
           </a:xfrm>
           <a:prstGeom prst="rect">
@@ -14001,7 +14001,7 @@
         </p:nvSpPr>
         <p:spPr>
           <a:xfrm>
-            <a:off x="596899" y="3399722"/>
+            <a:off x="596899" y="3336222"/>
             <a:ext cx="498474" cy="228599"/>
           </a:xfrm>
           <a:prstGeom prst="rect">
@@ -14036,7 +14036,7 @@
         </p:nvSpPr>
         <p:spPr>
           <a:xfrm>
-            <a:off x="965198" y="3797191"/>
+            <a:off x="965198" y="3733691"/>
             <a:ext cx="4344183" cy="518119"/>
           </a:xfrm>
           <a:prstGeom prst="rect">
@@ -14091,7 +14091,7 @@
         </p:nvSpPr>
         <p:spPr>
           <a:xfrm>
-            <a:off x="596899" y="3784491"/>
+            <a:off x="596899" y="3720991"/>
             <a:ext cx="498474" cy="228599"/>
           </a:xfrm>
           <a:prstGeom prst="rect">
@@ -14126,7 +14126,7 @@
         </p:nvSpPr>
         <p:spPr>
           <a:xfrm>
-            <a:off x="596899" y="4528630"/>
+            <a:off x="596899" y="4592130"/>
             <a:ext cx="6423803" cy="748008"/>
           </a:xfrm>
           <a:prstGeom prst="rect">
@@ -14578,7 +14578,7 @@
         </p:nvSpPr>
         <p:spPr>
           <a:xfrm>
-            <a:off x="965198" y="2385114"/>
+            <a:off x="965198" y="2321614"/>
             <a:ext cx="3734981" cy="260349"/>
           </a:xfrm>
           <a:prstGeom prst="rect">
@@ -14617,7 +14617,7 @@
         </p:nvSpPr>
         <p:spPr>
           <a:xfrm>
-            <a:off x="596899" y="2372414"/>
+            <a:off x="596899" y="2308914"/>
             <a:ext cx="498474" cy="228599"/>
           </a:xfrm>
           <a:prstGeom prst="rect">
@@ -14652,7 +14652,7 @@
         </p:nvSpPr>
         <p:spPr>
           <a:xfrm>
-            <a:off x="965198" y="2769883"/>
+            <a:off x="965198" y="2706383"/>
             <a:ext cx="4546341" cy="518119"/>
           </a:xfrm>
           <a:prstGeom prst="rect">
@@ -14725,7 +14725,7 @@
         </p:nvSpPr>
         <p:spPr>
           <a:xfrm>
-            <a:off x="596899" y="2757183"/>
+            <a:off x="596899" y="2693683"/>
             <a:ext cx="498474" cy="228599"/>
           </a:xfrm>
           <a:prstGeom prst="rect">
@@ -14760,7 +14760,7 @@
         </p:nvSpPr>
         <p:spPr>
           <a:xfrm>
-            <a:off x="965198" y="3412422"/>
+            <a:off x="965198" y="3348922"/>
             <a:ext cx="2587023" cy="260349"/>
           </a:xfrm>
           <a:prstGeom prst="rect">
@@ -14799,7 +14799,7 @@
         </p:nvSpPr>
         <p:spPr>
           <a:xfrm>
-            <a:off x="596899" y="3399722"/>
+            <a:off x="596899" y="3336222"/>
             <a:ext cx="498474" cy="228599"/>
           </a:xfrm>
           <a:prstGeom prst="rect">
@@ -14834,7 +14834,7 @@
         </p:nvSpPr>
         <p:spPr>
           <a:xfrm>
-            <a:off x="965198" y="3797191"/>
+            <a:off x="965198" y="3733691"/>
             <a:ext cx="4344183" cy="518119"/>
           </a:xfrm>
           <a:prstGeom prst="rect">
@@ -14889,7 +14889,7 @@
         </p:nvSpPr>
         <p:spPr>
           <a:xfrm>
-            <a:off x="596899" y="3784491"/>
+            <a:off x="596899" y="3720991"/>
             <a:ext cx="498474" cy="228599"/>
           </a:xfrm>
           <a:prstGeom prst="rect">
@@ -14924,7 +14924,7 @@
         </p:nvSpPr>
         <p:spPr>
           <a:xfrm>
-            <a:off x="596899" y="4528630"/>
+            <a:off x="596899" y="4592130"/>
             <a:ext cx="6574243" cy="748008"/>
           </a:xfrm>
           <a:prstGeom prst="rect">
@@ -17184,7 +17184,7 @@
         </p:nvSpPr>
         <p:spPr>
           <a:xfrm>
-            <a:off x="596899" y="1264540"/>
+            <a:off x="596899" y="1201040"/>
             <a:ext cx="2128510" cy="215899"/>
           </a:xfrm>
           <a:prstGeom prst="rect">
@@ -17223,7 +17223,7 @@
         </p:nvSpPr>
         <p:spPr>
           <a:xfrm>
-            <a:off x="596899" y="1474089"/>
+            <a:off x="596899" y="1410589"/>
             <a:ext cx="4896210" cy="749298"/>
           </a:xfrm>
           <a:prstGeom prst="rect">
@@ -17262,7 +17262,7 @@
         </p:nvSpPr>
         <p:spPr>
           <a:xfrm>
-            <a:off x="596899" y="2219518"/>
+            <a:off x="596899" y="2156018"/>
             <a:ext cx="4507397" cy="478729"/>
           </a:xfrm>
           <a:prstGeom prst="rect">
@@ -17317,7 +17317,7 @@
         </p:nvSpPr>
         <p:spPr>
           <a:xfrm>
-            <a:off x="596899" y="2916627"/>
+            <a:off x="596899" y="2853127"/>
             <a:ext cx="6590862" cy="775889"/>
           </a:xfrm>
           <a:prstGeom prst="rect">
@@ -17388,7 +17388,7 @@
         </p:nvSpPr>
         <p:spPr>
           <a:xfrm>
-            <a:off x="596899" y="3816936"/>
+            <a:off x="596899" y="3753436"/>
             <a:ext cx="6551298" cy="518119"/>
           </a:xfrm>
           <a:prstGeom prst="rect">
@@ -17443,7 +17443,7 @@
         </p:nvSpPr>
         <p:spPr>
           <a:xfrm>
-            <a:off x="596899" y="4554725"/>
+            <a:off x="596899" y="4618224"/>
             <a:ext cx="6523641" cy="891379"/>
           </a:xfrm>
           <a:prstGeom prst="rect">
@@ -19352,7 +19352,7 @@
         </p:nvSpPr>
         <p:spPr>
           <a:xfrm>
-            <a:off x="609598" y="5213436"/>
+            <a:off x="609598" y="5302336"/>
             <a:ext cx="76200" cy="76200"/>
           </a:xfrm>
           <a:prstGeom prst="ellipse">
@@ -19395,7 +19395,7 @@
         </p:nvSpPr>
         <p:spPr>
           <a:xfrm>
-            <a:off x="596899" y="1384098"/>
+            <a:off x="596899" y="1295198"/>
             <a:ext cx="2914568" cy="215899"/>
           </a:xfrm>
           <a:prstGeom prst="rect">
@@ -19434,7 +19434,7 @@
         </p:nvSpPr>
         <p:spPr>
           <a:xfrm>
-            <a:off x="596899" y="1758747"/>
+            <a:off x="596899" y="1669847"/>
             <a:ext cx="11917159" cy="2250672"/>
           </a:xfrm>
           <a:prstGeom prst="rect">
@@ -19537,7 +19537,7 @@
         </p:nvSpPr>
         <p:spPr>
           <a:xfrm>
-            <a:off x="596899" y="4226014"/>
+            <a:off x="596899" y="4314913"/>
             <a:ext cx="1120450" cy="215899"/>
           </a:xfrm>
           <a:prstGeom prst="rect">
@@ -19576,7 +19576,7 @@
         </p:nvSpPr>
         <p:spPr>
           <a:xfrm>
-            <a:off x="596899" y="4670513"/>
+            <a:off x="596899" y="4759412"/>
             <a:ext cx="7281299" cy="279399"/>
           </a:xfrm>
           <a:prstGeom prst="rect">

</xml_diff>